<commit_message>
Refresh Science teaching packs and add LAUNCH downloads
</commit_message>
<xml_diff>
--- a/Science_Teesside/Teaching_Packs/BUILD/lessons/W3B/BUILD_Science_Autumn1_W3B_Backbone_Evidence.pptx
+++ b/Science_Teesside/Teaching_Packs/BUILD/lessons/W3B/BUILD_Science_Autumn1_W3B_Backbone_Evidence.pptx
@@ -2,23 +2,23 @@
 <file path=ppt/presentation.xml><?xml version="1.0" encoding="utf-8"?>
 <p:presentation xmlns:p="http://schemas.openxmlformats.org/presentationml/2006/main">
   <p:sldMasterIdLst>
-    <p:sldMasterId xmlns:r="http://schemas.openxmlformats.org/officeDocument/2006/relationships" id="2147483648" r:id="R01bc5aa442c44329"/>
+    <p:sldMasterId xmlns:r="http://schemas.openxmlformats.org/officeDocument/2006/relationships" id="2147483648" r:id="Rec20d88f56df4085"/>
   </p:sldMasterIdLst>
   <p:notesMasterIdLst>
-    <p:notesMasterId xmlns:r="http://schemas.openxmlformats.org/officeDocument/2006/relationships" r:id="R7dbe5b7d2ae94c38"/>
+    <p:notesMasterId xmlns:r="http://schemas.openxmlformats.org/officeDocument/2006/relationships" r:id="Rc9dddd3a544e4bf2"/>
   </p:notesMasterIdLst>
   <p:sldIdLst>
-    <p:sldId xmlns:r="http://schemas.openxmlformats.org/officeDocument/2006/relationships" id="256" r:id="Ra2aa3055117a4d36"/>
-    <p:sldId xmlns:r="http://schemas.openxmlformats.org/officeDocument/2006/relationships" id="257" r:id="R5c780eb27ae14943"/>
-    <p:sldId xmlns:r="http://schemas.openxmlformats.org/officeDocument/2006/relationships" id="258" r:id="Rde738871764f42d3"/>
-    <p:sldId xmlns:r="http://schemas.openxmlformats.org/officeDocument/2006/relationships" id="259" r:id="R1bdf759efb7d4f1b"/>
-    <p:sldId xmlns:r="http://schemas.openxmlformats.org/officeDocument/2006/relationships" id="260" r:id="Rae68ee23b2e34373"/>
-    <p:sldId xmlns:r="http://schemas.openxmlformats.org/officeDocument/2006/relationships" id="261" r:id="Rb39c6ed8e41f4cc3"/>
-    <p:sldId xmlns:r="http://schemas.openxmlformats.org/officeDocument/2006/relationships" id="262" r:id="Rf5975a2c9da74c6a"/>
-    <p:sldId xmlns:r="http://schemas.openxmlformats.org/officeDocument/2006/relationships" id="263" r:id="R5547b514da6343cd"/>
-    <p:sldId xmlns:r="http://schemas.openxmlformats.org/officeDocument/2006/relationships" id="264" r:id="R5667670ecf434532"/>
-    <p:sldId xmlns:r="http://schemas.openxmlformats.org/officeDocument/2006/relationships" id="265" r:id="Rbde6248adb1d4a39"/>
-    <p:sldId xmlns:r="http://schemas.openxmlformats.org/officeDocument/2006/relationships" id="266" r:id="R6da1b4e93d004377"/>
+    <p:sldId xmlns:r="http://schemas.openxmlformats.org/officeDocument/2006/relationships" id="256" r:id="Red3c431a97564ab6"/>
+    <p:sldId xmlns:r="http://schemas.openxmlformats.org/officeDocument/2006/relationships" id="257" r:id="R67ce8d925b6c4aa8"/>
+    <p:sldId xmlns:r="http://schemas.openxmlformats.org/officeDocument/2006/relationships" id="258" r:id="R02f2e958c79f4e4b"/>
+    <p:sldId xmlns:r="http://schemas.openxmlformats.org/officeDocument/2006/relationships" id="259" r:id="R7250270e774c46a5"/>
+    <p:sldId xmlns:r="http://schemas.openxmlformats.org/officeDocument/2006/relationships" id="260" r:id="R61f606a06e1e4af3"/>
+    <p:sldId xmlns:r="http://schemas.openxmlformats.org/officeDocument/2006/relationships" id="261" r:id="R26d1d8ac35804b5a"/>
+    <p:sldId xmlns:r="http://schemas.openxmlformats.org/officeDocument/2006/relationships" id="262" r:id="Rae56129beb1044a9"/>
+    <p:sldId xmlns:r="http://schemas.openxmlformats.org/officeDocument/2006/relationships" id="263" r:id="Rdf6b12f719984fd5"/>
+    <p:sldId xmlns:r="http://schemas.openxmlformats.org/officeDocument/2006/relationships" id="264" r:id="R3da97967eec84c8a"/>
+    <p:sldId xmlns:r="http://schemas.openxmlformats.org/officeDocument/2006/relationships" id="265" r:id="Rf97498b0985b4fd2"/>
+    <p:sldId xmlns:r="http://schemas.openxmlformats.org/officeDocument/2006/relationships" id="266" r:id="R14ff385068c84a7d"/>
   </p:sldIdLst>
   <p:sldSz cx="12192000" cy="6858000"/>
   <p:notesSz cx="6858000" cy="9144000"/>
@@ -500,6 +500,15 @@
               <a:t>[/Sources]</a:t>
             </a:r>
           </a:p>
+          <a:p xmlns:a="http://schemas.openxmlformats.org/drawingml/2006/main">
+            <a:r>
+              <a:t>
+[Sources]
+https://madebymatt.uk/Lessons/Science_Teesside/Teaching_Packs/BUILD/ — original lesson text, timings and teacher notes retained.
+https://madebymatt.uk/Lessons/Science_Teesside/Build/ — existing Made by Matt scientific artwork, where shown.
+[/Sources]</a:t>
+            </a:r>
+          </a:p>
         </p:txBody>
       </p:sp>
       <p:sp>
@@ -615,6 +624,15 @@
               <a:t>[/Sources]</a:t>
             </a:r>
           </a:p>
+          <a:p xmlns:a="http://schemas.openxmlformats.org/drawingml/2006/main">
+            <a:r>
+              <a:t>
+[Sources]
+https://madebymatt.uk/Lessons/Science_Teesside/Teaching_Packs/BUILD/ — original lesson text, timings and teacher notes retained.
+https://madebymatt.uk/Lessons/Science_Teesside/Build/ — existing Made by Matt scientific artwork, where shown.
+[/Sources]</a:t>
+            </a:r>
+          </a:p>
         </p:txBody>
       </p:sp>
       <p:sp>
@@ -730,6 +748,15 @@
               <a:t>[/Sources]</a:t>
             </a:r>
           </a:p>
+          <a:p xmlns:a="http://schemas.openxmlformats.org/drawingml/2006/main">
+            <a:r>
+              <a:t>
+[Sources]
+https://madebymatt.uk/Lessons/Science_Teesside/Teaching_Packs/BUILD/ — original lesson text, timings and teacher notes retained.
+https://madebymatt.uk/Lessons/Science_Teesside/Build/ — existing Made by Matt scientific artwork, where shown.
+[/Sources]</a:t>
+            </a:r>
+          </a:p>
         </p:txBody>
       </p:sp>
       <p:sp>
@@ -845,6 +872,15 @@
               <a:t>[/Sources]</a:t>
             </a:r>
           </a:p>
+          <a:p xmlns:a="http://schemas.openxmlformats.org/drawingml/2006/main">
+            <a:r>
+              <a:t>
+[Sources]
+https://madebymatt.uk/Lessons/Science_Teesside/Teaching_Packs/BUILD/ — original lesson text, timings and teacher notes retained.
+https://madebymatt.uk/Lessons/Science_Teesside/Build/ — existing Made by Matt scientific artwork, where shown.
+[/Sources]</a:t>
+            </a:r>
+          </a:p>
         </p:txBody>
       </p:sp>
       <p:sp>
@@ -960,6 +996,15 @@
               <a:t>[/Sources]</a:t>
             </a:r>
           </a:p>
+          <a:p xmlns:a="http://schemas.openxmlformats.org/drawingml/2006/main">
+            <a:r>
+              <a:t>
+[Sources]
+https://madebymatt.uk/Lessons/Science_Teesside/Teaching_Packs/BUILD/ — original lesson text, timings and teacher notes retained.
+https://madebymatt.uk/Lessons/Science_Teesside/Build/ — existing Made by Matt scientific artwork, where shown.
+[/Sources]</a:t>
+            </a:r>
+          </a:p>
         </p:txBody>
       </p:sp>
       <p:sp>
@@ -1075,6 +1120,15 @@
               <a:t>[/Sources]</a:t>
             </a:r>
           </a:p>
+          <a:p xmlns:a="http://schemas.openxmlformats.org/drawingml/2006/main">
+            <a:r>
+              <a:t>
+[Sources]
+https://madebymatt.uk/Lessons/Science_Teesside/Teaching_Packs/BUILD/ — original lesson text, timings and teacher notes retained.
+https://madebymatt.uk/Lessons/Science_Teesside/Build/ — existing Made by Matt scientific artwork, where shown.
+[/Sources]</a:t>
+            </a:r>
+          </a:p>
         </p:txBody>
       </p:sp>
       <p:sp>
@@ -1190,6 +1244,15 @@
               <a:t>[/Sources]</a:t>
             </a:r>
           </a:p>
+          <a:p xmlns:a="http://schemas.openxmlformats.org/drawingml/2006/main">
+            <a:r>
+              <a:t>
+[Sources]
+https://madebymatt.uk/Lessons/Science_Teesside/Teaching_Packs/BUILD/ — original lesson text, timings and teacher notes retained.
+https://madebymatt.uk/Lessons/Science_Teesside/Build/ — existing Made by Matt scientific artwork, where shown.
+[/Sources]</a:t>
+            </a:r>
+          </a:p>
         </p:txBody>
       </p:sp>
       <p:sp>
@@ -1305,6 +1368,15 @@
               <a:t>[/Sources]</a:t>
             </a:r>
           </a:p>
+          <a:p xmlns:a="http://schemas.openxmlformats.org/drawingml/2006/main">
+            <a:r>
+              <a:t>
+[Sources]
+https://madebymatt.uk/Lessons/Science_Teesside/Teaching_Packs/BUILD/ — original lesson text, timings and teacher notes retained.
+https://madebymatt.uk/Lessons/Science_Teesside/Build/ — existing Made by Matt scientific artwork, where shown.
+[/Sources]</a:t>
+            </a:r>
+          </a:p>
         </p:txBody>
       </p:sp>
       <p:sp>
@@ -1420,6 +1492,15 @@
               <a:t>[/Sources]</a:t>
             </a:r>
           </a:p>
+          <a:p xmlns:a="http://schemas.openxmlformats.org/drawingml/2006/main">
+            <a:r>
+              <a:t>
+[Sources]
+https://madebymatt.uk/Lessons/Science_Teesside/Teaching_Packs/BUILD/ — original lesson text, timings and teacher notes retained.
+https://madebymatt.uk/Lessons/Science_Teesside/Build/ — existing Made by Matt scientific artwork, where shown.
+[/Sources]</a:t>
+            </a:r>
+          </a:p>
         </p:txBody>
       </p:sp>
       <p:sp>
@@ -1535,6 +1616,15 @@
               <a:t>[/Sources]</a:t>
             </a:r>
           </a:p>
+          <a:p xmlns:a="http://schemas.openxmlformats.org/drawingml/2006/main">
+            <a:r>
+              <a:t>
+[Sources]
+https://madebymatt.uk/Lessons/Science_Teesside/Teaching_Packs/BUILD/ — original lesson text, timings and teacher notes retained.
+https://madebymatt.uk/Lessons/Science_Teesside/Build/ — existing Made by Matt scientific artwork, where shown.
+[/Sources]</a:t>
+            </a:r>
+          </a:p>
         </p:txBody>
       </p:sp>
       <p:sp>
@@ -1648,6 +1738,15 @@
           <a:p xmlns:a="http://schemas.openxmlformats.org/drawingml/2006/main">
             <a:r>
               <a:t>[/Sources]</a:t>
+            </a:r>
+          </a:p>
+          <a:p xmlns:a="http://schemas.openxmlformats.org/drawingml/2006/main">
+            <a:r>
+              <a:t>
+[Sources]
+https://madebymatt.uk/Lessons/Science_Teesside/Teaching_Packs/BUILD/ — original lesson text, timings and teacher notes retained.
+https://madebymatt.uk/Lessons/Science_Teesside/Build/ — existing Made by Matt scientific artwork, where shown.
+[/Sources]</a:t>
             </a:r>
           </a:p>
         </p:txBody>
@@ -1715,7 +1814,7 @@
   </p:cSld>
   <p:clrMap bg1="lt1" tx1="dk1" bg2="lt2" tx2="dk2" accent1="accent1" accent2="accent2" accent3="accent3" accent4="accent4" accent5="accent5" accent6="accent6" hlink="hlink" folHlink="folHlink"/>
   <p:sldLayoutIdLst>
-    <p:sldLayoutId xmlns:r="http://schemas.openxmlformats.org/officeDocument/2006/relationships" id="2147483649" r:id="Rfb48842f6904407e"/>
+    <p:sldLayoutId xmlns:r="http://schemas.openxmlformats.org/officeDocument/2006/relationships" id="2147483649" r:id="R34b24aa6fbdd4b29"/>
   </p:sldLayoutIdLst>
   <p:txStyles>
     <p:titleStyle>
@@ -2248,7 +2347,7 @@
     <p:bg>
       <p:bgPr>
         <a:solidFill xmlns:a="http://schemas.openxmlformats.org/drawingml/2006/main">
-          <a:srgbClr val="F5F1E8"/>
+          <a:srgbClr val="FBF9F3"/>
         </a:solidFill>
       </p:bgPr>
     </p:bg>
@@ -2277,8 +2376,8 @@
         </p:nvSpPr>
         <p:spPr>
           <a:xfrm xmlns:a="http://schemas.openxmlformats.org/drawingml/2006/main">
-            <a:off x="609600" y="552450"/>
-            <a:ext cx="781050" cy="57150"/>
+            <a:off x="609600" y="742950"/>
+            <a:ext cx="9906000" cy="38100"/>
           </a:xfrm>
           <a:prstGeom xmlns:a="http://schemas.openxmlformats.org/drawingml/2006/main" prst="rect">
             <a:avLst/>
@@ -2308,8 +2407,8 @@
         </p:nvSpPr>
         <p:spPr>
           <a:xfrm xmlns:a="http://schemas.openxmlformats.org/drawingml/2006/main">
-            <a:off x="609600" y="762000"/>
-            <a:ext cx="9334500" cy="285750"/>
+            <a:off x="609600" y="342900"/>
+            <a:ext cx="9334500" cy="266700"/>
           </a:xfrm>
           <a:prstGeom xmlns:a="http://schemas.openxmlformats.org/drawingml/2006/main" prst="rect">
             <a:avLst/>
@@ -2321,21 +2420,30 @@
           </a:ln>
         </p:spPr>
         <p:txBody>
-          <a:bodyPr xmlns:a="http://schemas.openxmlformats.org/drawingml/2006/main" lIns="0" tIns="0" rIns="0" bIns="0" anchor="ctr"/>
+          <a:bodyPr xmlns:a="http://schemas.openxmlformats.org/drawingml/2006/main" wrap="square" lIns="0" tIns="0" rIns="0" bIns="0" anchor="ctr">
+            <a:noAutofit/>
+          </a:bodyPr>
           <a:lstStyle xmlns:a="http://schemas.openxmlformats.org/drawingml/2006/main"/>
           <a:p xmlns:a="http://schemas.openxmlformats.org/drawingml/2006/main">
             <a:pPr>
-              <a:defRPr sz="1500" b="1">
+              <a:buNone/>
+              <a:defRPr sz="1425" b="1">
                 <a:solidFill>
                   <a:srgbClr val="28685E"/>
                 </a:solidFill>
+                <a:latin typeface="Arial"/>
+                <a:ea typeface="Arial"/>
+                <a:cs typeface="Arial"/>
               </a:defRPr>
             </a:pPr>
             <a:r>
-              <a:rPr sz="1500" b="1">
+              <a:rPr sz="1425" b="1">
                 <a:solidFill>
                   <a:srgbClr val="28685E"/>
                 </a:solidFill>
+                <a:latin typeface="Arial"/>
+                <a:ea typeface="Arial"/>
+                <a:cs typeface="Arial"/>
               </a:rPr>
               <a:t>MADE BY MATT  /  BUILD SCIENCE</a:t>
             </a:r>
@@ -2344,14 +2452,14 @@
       </p:sp>
       <p:pic>
         <p:nvPicPr>
-          <p:cNvPr id="12" name=""/>
+          <p:cNvPr id="15" name=""/>
           <p:cNvPicPr>
             <a:picLocks xmlns:a="http://schemas.openxmlformats.org/drawingml/2006/main" noChangeAspect="1"/>
           </p:cNvPicPr>
           <p:nvPr/>
         </p:nvPicPr>
         <p:blipFill>
-          <a:blip xmlns:r="http://schemas.openxmlformats.org/officeDocument/2006/relationships" xmlns:a="http://schemas.openxmlformats.org/drawingml/2006/main" r:embed="Rfa47fa77662949bf"/>
+          <a:blip xmlns:r="http://schemas.openxmlformats.org/officeDocument/2006/relationships" xmlns:a="http://schemas.openxmlformats.org/drawingml/2006/main" r:embed="Re65d97769a1e4674"/>
           <a:stretch xmlns:a="http://schemas.openxmlformats.org/drawingml/2006/main"/>
         </p:blipFill>
         <p:spPr>
@@ -2380,8 +2488,8 @@
         </p:nvSpPr>
         <p:spPr>
           <a:xfrm xmlns:a="http://schemas.openxmlformats.org/drawingml/2006/main">
-            <a:off x="609600" y="1352550"/>
-            <a:ext cx="10972800" cy="952500"/>
+            <a:off x="609600" y="1047750"/>
+            <a:ext cx="10972800" cy="895350"/>
           </a:xfrm>
           <a:prstGeom xmlns:a="http://schemas.openxmlformats.org/drawingml/2006/main" prst="rect">
             <a:avLst/>
@@ -2393,21 +2501,30 @@
           </a:ln>
         </p:spPr>
         <p:txBody>
-          <a:bodyPr xmlns:a="http://schemas.openxmlformats.org/drawingml/2006/main" lIns="0" tIns="0" rIns="0" bIns="0" anchor="ctr"/>
+          <a:bodyPr xmlns:a="http://schemas.openxmlformats.org/drawingml/2006/main" wrap="square" lIns="0" tIns="0" rIns="0" bIns="0" anchor="ctr">
+            <a:noAutofit/>
+          </a:bodyPr>
           <a:lstStyle xmlns:a="http://schemas.openxmlformats.org/drawingml/2006/main"/>
           <a:p xmlns:a="http://schemas.openxmlformats.org/drawingml/2006/main">
             <a:pPr>
-              <a:defRPr sz="3750" b="1">
+              <a:buNone/>
+              <a:defRPr sz="3600" b="1">
                 <a:solidFill>
                   <a:srgbClr val="152B3A"/>
                 </a:solidFill>
+                <a:latin typeface="Arial"/>
+                <a:ea typeface="Arial"/>
+                <a:cs typeface="Arial"/>
               </a:defRPr>
             </a:pPr>
             <a:r>
-              <a:rPr sz="3750" b="1">
+              <a:rPr sz="3600" b="1">
                 <a:solidFill>
                   <a:srgbClr val="152B3A"/>
                 </a:solidFill>
+                <a:latin typeface="Arial"/>
+                <a:ea typeface="Arial"/>
+                <a:cs typeface="Arial"/>
               </a:rPr>
               <a:t>Backbone evidence lab</a:t>
             </a:r>
@@ -2474,21 +2591,30 @@
           </a:ln>
         </p:spPr>
         <p:txBody>
-          <a:bodyPr xmlns:a="http://schemas.openxmlformats.org/drawingml/2006/main" lIns="0" tIns="0" rIns="0" bIns="0" anchor="ctr"/>
+          <a:bodyPr xmlns:a="http://schemas.openxmlformats.org/drawingml/2006/main" wrap="square" lIns="0" tIns="0" rIns="0" bIns="0" anchor="ctr">
+            <a:noAutofit/>
+          </a:bodyPr>
           <a:lstStyle xmlns:a="http://schemas.openxmlformats.org/drawingml/2006/main"/>
           <a:p xmlns:a="http://schemas.openxmlformats.org/drawingml/2006/main">
             <a:pPr>
-              <a:defRPr sz="1275" b="0">
+              <a:buNone/>
+              <a:defRPr sz="1200" b="0">
                 <a:solidFill>
                   <a:srgbClr val="50616B"/>
                 </a:solidFill>
+                <a:latin typeface="Arial"/>
+                <a:ea typeface="Arial"/>
+                <a:cs typeface="Arial"/>
               </a:defRPr>
             </a:pPr>
             <a:r>
-              <a:rPr sz="1275" b="0">
+              <a:rPr sz="1200" b="0">
                 <a:solidFill>
                   <a:srgbClr val="50616B"/>
                 </a:solidFill>
+                <a:latin typeface="Arial"/>
+                <a:ea typeface="Arial"/>
+                <a:cs typeface="Arial"/>
               </a:rPr>
               <a:t>AUTUMN 1  ·  WEEK 3  ·  LESSON B</a:t>
             </a:r>
@@ -2524,14 +2650,20 @@
           </a:ln>
         </p:spPr>
         <p:txBody>
-          <a:bodyPr xmlns:a="http://schemas.openxmlformats.org/drawingml/2006/main" lIns="0" tIns="0" rIns="0" bIns="0" anchor="ctr"/>
+          <a:bodyPr xmlns:a="http://schemas.openxmlformats.org/drawingml/2006/main" wrap="square" lIns="0" tIns="0" rIns="0" bIns="0" anchor="ctr">
+            <a:noAutofit/>
+          </a:bodyPr>
           <a:lstStyle xmlns:a="http://schemas.openxmlformats.org/drawingml/2006/main"/>
           <a:p xmlns:a="http://schemas.openxmlformats.org/drawingml/2006/main">
             <a:pPr>
+              <a:buNone/>
               <a:defRPr sz="1350" b="1">
                 <a:solidFill>
                   <a:srgbClr val="28685E"/>
                 </a:solidFill>
+                <a:latin typeface="Arial"/>
+                <a:ea typeface="Arial"/>
+                <a:cs typeface="Arial"/>
               </a:defRPr>
             </a:pPr>
             <a:r>
@@ -2539,6 +2671,9 @@
                 <a:solidFill>
                   <a:srgbClr val="28685E"/>
                 </a:solidFill>
+                <a:latin typeface="Arial"/>
+                <a:ea typeface="Arial"/>
+                <a:cs typeface="Arial"/>
               </a:rPr>
               <a:t>01</a:t>
             </a:r>
@@ -2561,8 +2696,8 @@
         </p:nvSpPr>
         <p:spPr>
           <a:xfrm xmlns:a="http://schemas.openxmlformats.org/drawingml/2006/main">
-            <a:off x="609600" y="2809875"/>
-            <a:ext cx="10668000" cy="1000125"/>
+            <a:off x="609600" y="2400300"/>
+            <a:ext cx="6191250" cy="1409700"/>
           </a:xfrm>
           <a:prstGeom xmlns:a="http://schemas.openxmlformats.org/drawingml/2006/main" prst="rect">
             <a:avLst/>
@@ -2574,21 +2709,30 @@
           </a:ln>
         </p:spPr>
         <p:txBody>
-          <a:bodyPr xmlns:a="http://schemas.openxmlformats.org/drawingml/2006/main" lIns="0" tIns="0" rIns="0" bIns="0" anchor="ctr"/>
+          <a:bodyPr xmlns:a="http://schemas.openxmlformats.org/drawingml/2006/main" wrap="square" lIns="0" tIns="0" rIns="0" bIns="0" anchor="ctr">
+            <a:noAutofit/>
+          </a:bodyPr>
           <a:lstStyle xmlns:a="http://schemas.openxmlformats.org/drawingml/2006/main"/>
           <a:p xmlns:a="http://schemas.openxmlformats.org/drawingml/2006/main">
             <a:pPr>
-              <a:defRPr sz="3900" b="1">
+              <a:buNone/>
+              <a:defRPr sz="3450" b="1">
                 <a:solidFill>
                   <a:srgbClr val="28685E"/>
                 </a:solidFill>
+                <a:latin typeface="Arial"/>
+                <a:ea typeface="Arial"/>
+                <a:cs typeface="Arial"/>
               </a:defRPr>
             </a:pPr>
             <a:r>
-              <a:rPr sz="3900" b="1">
+              <a:rPr sz="3450" b="1">
                 <a:solidFill>
                   <a:srgbClr val="28685E"/>
                 </a:solidFill>
+                <a:latin typeface="Arial"/>
+                <a:ea typeface="Arial"/>
+                <a:cs typeface="Arial"/>
               </a:rPr>
               <a:t>Look inside the evidence.</a:t>
             </a:r>
@@ -2611,8 +2755,8 @@
         </p:nvSpPr>
         <p:spPr>
           <a:xfrm xmlns:a="http://schemas.openxmlformats.org/drawingml/2006/main">
-            <a:off x="609600" y="4143375"/>
-            <a:ext cx="10668000" cy="1143000"/>
+            <a:off x="609600" y="4286250"/>
+            <a:ext cx="6667500" cy="1314450"/>
           </a:xfrm>
           <a:prstGeom xmlns:a="http://schemas.openxmlformats.org/drawingml/2006/main" prst="rect">
             <a:avLst/>
@@ -2624,27 +2768,58 @@
           </a:ln>
         </p:spPr>
         <p:txBody>
-          <a:bodyPr xmlns:a="http://schemas.openxmlformats.org/drawingml/2006/main" lIns="0" tIns="0" rIns="0" bIns="0" anchor="ctr"/>
+          <a:bodyPr xmlns:a="http://schemas.openxmlformats.org/drawingml/2006/main" wrap="square" lIns="0" tIns="0" rIns="0" bIns="0" anchor="ctr">
+            <a:noAutofit/>
+          </a:bodyPr>
           <a:lstStyle xmlns:a="http://schemas.openxmlformats.org/drawingml/2006/main"/>
           <a:p xmlns:a="http://schemas.openxmlformats.org/drawingml/2006/main">
             <a:pPr>
-              <a:defRPr sz="2550" b="0">
+              <a:buNone/>
+              <a:defRPr sz="2400" b="0">
                 <a:solidFill>
                   <a:srgbClr val="152B3A"/>
                 </a:solidFill>
+                <a:latin typeface="Arial"/>
+                <a:ea typeface="Arial"/>
+                <a:cs typeface="Arial"/>
               </a:defRPr>
             </a:pPr>
             <a:r>
-              <a:rPr sz="2550" b="0">
+              <a:rPr sz="2400" b="0">
                 <a:solidFill>
                   <a:srgbClr val="152B3A"/>
                 </a:solidFill>
+                <a:latin typeface="Arial"/>
+                <a:ea typeface="Arial"/>
+                <a:cs typeface="Arial"/>
               </a:rPr>
               <a:t>I can justify a classification and improve a clue.</a:t>
             </a:r>
           </a:p>
         </p:txBody>
       </p:sp>
+      <p:pic>
+        <p:nvPicPr>
+          <p:cNvPr id="22" name=""/>
+          <p:cNvPicPr>
+            <a:picLocks xmlns:a="http://schemas.openxmlformats.org/drawingml/2006/main" noChangeAspect="1"/>
+          </p:cNvPicPr>
+          <p:nvPr/>
+        </p:nvPicPr>
+        <p:blipFill>
+          <a:blip xmlns:r="http://schemas.openxmlformats.org/officeDocument/2006/relationships" xmlns:a="http://schemas.openxmlformats.org/drawingml/2006/main" r:embed="R98744d7570614a77"/>
+          <a:stretch xmlns:a="http://schemas.openxmlformats.org/drawingml/2006/main"/>
+        </p:blipFill>
+        <p:spPr>
+          <a:xfrm xmlns:a="http://schemas.openxmlformats.org/drawingml/2006/main">
+            <a:off x="7620000" y="2369344"/>
+            <a:ext cx="3714750" cy="2786063"/>
+          </a:xfrm>
+          <a:prstGeom xmlns:a="http://schemas.openxmlformats.org/drawingml/2006/main" prst="rect">
+            <a:avLst/>
+          </a:prstGeom>
+        </p:spPr>
+      </p:pic>
     </p:spTree>
     <p:extLst>
       <p:ext uri="{BB962C8B-B14F-4D97-AF65-F5344CB8AC3E}">
@@ -2661,7 +2836,7 @@
     <p:bg>
       <p:bgPr>
         <a:solidFill xmlns:a="http://schemas.openxmlformats.org/drawingml/2006/main">
-          <a:srgbClr val="F5F1E8"/>
+          <a:srgbClr val="FBF9F3"/>
         </a:solidFill>
       </p:bgPr>
     </p:bg>
@@ -2690,8 +2865,8 @@
         </p:nvSpPr>
         <p:spPr>
           <a:xfrm xmlns:a="http://schemas.openxmlformats.org/drawingml/2006/main">
-            <a:off x="609600" y="552450"/>
-            <a:ext cx="781050" cy="57150"/>
+            <a:off x="609600" y="742950"/>
+            <a:ext cx="9906000" cy="38100"/>
           </a:xfrm>
           <a:prstGeom xmlns:a="http://schemas.openxmlformats.org/drawingml/2006/main" prst="rect">
             <a:avLst/>
@@ -2721,8 +2896,8 @@
         </p:nvSpPr>
         <p:spPr>
           <a:xfrm xmlns:a="http://schemas.openxmlformats.org/drawingml/2006/main">
-            <a:off x="609600" y="762000"/>
-            <a:ext cx="9334500" cy="285750"/>
+            <a:off x="609600" y="342900"/>
+            <a:ext cx="9334500" cy="266700"/>
           </a:xfrm>
           <a:prstGeom xmlns:a="http://schemas.openxmlformats.org/drawingml/2006/main" prst="rect">
             <a:avLst/>
@@ -2734,21 +2909,30 @@
           </a:ln>
         </p:spPr>
         <p:txBody>
-          <a:bodyPr xmlns:a="http://schemas.openxmlformats.org/drawingml/2006/main" lIns="0" tIns="0" rIns="0" bIns="0" anchor="ctr"/>
+          <a:bodyPr xmlns:a="http://schemas.openxmlformats.org/drawingml/2006/main" wrap="square" lIns="0" tIns="0" rIns="0" bIns="0" anchor="ctr">
+            <a:noAutofit/>
+          </a:bodyPr>
           <a:lstStyle xmlns:a="http://schemas.openxmlformats.org/drawingml/2006/main"/>
           <a:p xmlns:a="http://schemas.openxmlformats.org/drawingml/2006/main">
             <a:pPr>
-              <a:defRPr sz="1500" b="1">
+              <a:buNone/>
+              <a:defRPr sz="1425" b="1">
                 <a:solidFill>
                   <a:srgbClr val="28685E"/>
                 </a:solidFill>
+                <a:latin typeface="Arial"/>
+                <a:ea typeface="Arial"/>
+                <a:cs typeface="Arial"/>
               </a:defRPr>
             </a:pPr>
             <a:r>
-              <a:rPr sz="1500" b="1">
+              <a:rPr sz="1425" b="1">
                 <a:solidFill>
                   <a:srgbClr val="28685E"/>
                 </a:solidFill>
+                <a:latin typeface="Arial"/>
+                <a:ea typeface="Arial"/>
+                <a:cs typeface="Arial"/>
               </a:rPr>
               <a:t>MADE BY MATT  /  BUILD SCIENCE</a:t>
             </a:r>
@@ -2757,14 +2941,14 @@
       </p:sp>
       <p:pic>
         <p:nvPicPr>
-          <p:cNvPr id="14" name=""/>
+          <p:cNvPr id="16" name=""/>
           <p:cNvPicPr>
             <a:picLocks xmlns:a="http://schemas.openxmlformats.org/drawingml/2006/main" noChangeAspect="1"/>
           </p:cNvPicPr>
           <p:nvPr/>
         </p:nvPicPr>
         <p:blipFill>
-          <a:blip xmlns:r="http://schemas.openxmlformats.org/officeDocument/2006/relationships" xmlns:a="http://schemas.openxmlformats.org/drawingml/2006/main" r:embed="R4da5386d5ad141bf"/>
+          <a:blip xmlns:r="http://schemas.openxmlformats.org/officeDocument/2006/relationships" xmlns:a="http://schemas.openxmlformats.org/drawingml/2006/main" r:embed="Rd157d94e5cd841c6"/>
           <a:stretch xmlns:a="http://schemas.openxmlformats.org/drawingml/2006/main"/>
         </p:blipFill>
         <p:spPr>
@@ -2793,8 +2977,8 @@
         </p:nvSpPr>
         <p:spPr>
           <a:xfrm xmlns:a="http://schemas.openxmlformats.org/drawingml/2006/main">
-            <a:off x="609600" y="1352550"/>
-            <a:ext cx="10972800" cy="952500"/>
+            <a:off x="609600" y="1047750"/>
+            <a:ext cx="10972800" cy="895350"/>
           </a:xfrm>
           <a:prstGeom xmlns:a="http://schemas.openxmlformats.org/drawingml/2006/main" prst="rect">
             <a:avLst/>
@@ -2806,21 +2990,30 @@
           </a:ln>
         </p:spPr>
         <p:txBody>
-          <a:bodyPr xmlns:a="http://schemas.openxmlformats.org/drawingml/2006/main" lIns="0" tIns="0" rIns="0" bIns="0" anchor="ctr"/>
+          <a:bodyPr xmlns:a="http://schemas.openxmlformats.org/drawingml/2006/main" wrap="square" lIns="0" tIns="0" rIns="0" bIns="0" anchor="ctr">
+            <a:noAutofit/>
+          </a:bodyPr>
           <a:lstStyle xmlns:a="http://schemas.openxmlformats.org/drawingml/2006/main"/>
           <a:p xmlns:a="http://schemas.openxmlformats.org/drawingml/2006/main">
             <a:pPr>
-              <a:defRPr sz="3750" b="1">
+              <a:buNone/>
+              <a:defRPr sz="3600" b="1">
                 <a:solidFill>
                   <a:srgbClr val="152B3A"/>
                 </a:solidFill>
+                <a:latin typeface="Arial"/>
+                <a:ea typeface="Arial"/>
+                <a:cs typeface="Arial"/>
               </a:defRPr>
             </a:pPr>
             <a:r>
-              <a:rPr sz="3750" b="1">
+              <a:rPr sz="3600" b="1">
                 <a:solidFill>
                   <a:srgbClr val="152B3A"/>
                 </a:solidFill>
+                <a:latin typeface="Arial"/>
+                <a:ea typeface="Arial"/>
+                <a:cs typeface="Arial"/>
               </a:rPr>
               <a:t>Your voice can change the lesson</a:t>
             </a:r>
@@ -2887,21 +3080,30 @@
           </a:ln>
         </p:spPr>
         <p:txBody>
-          <a:bodyPr xmlns:a="http://schemas.openxmlformats.org/drawingml/2006/main" lIns="0" tIns="0" rIns="0" bIns="0" anchor="ctr"/>
+          <a:bodyPr xmlns:a="http://schemas.openxmlformats.org/drawingml/2006/main" wrap="square" lIns="0" tIns="0" rIns="0" bIns="0" anchor="ctr">
+            <a:noAutofit/>
+          </a:bodyPr>
           <a:lstStyle xmlns:a="http://schemas.openxmlformats.org/drawingml/2006/main"/>
           <a:p xmlns:a="http://schemas.openxmlformats.org/drawingml/2006/main">
             <a:pPr>
-              <a:defRPr sz="1275" b="0">
+              <a:buNone/>
+              <a:defRPr sz="1200" b="0">
                 <a:solidFill>
                   <a:srgbClr val="50616B"/>
                 </a:solidFill>
+                <a:latin typeface="Arial"/>
+                <a:ea typeface="Arial"/>
+                <a:cs typeface="Arial"/>
               </a:defRPr>
             </a:pPr>
             <a:r>
-              <a:rPr sz="1275" b="0">
+              <a:rPr sz="1200" b="0">
                 <a:solidFill>
                   <a:srgbClr val="50616B"/>
                 </a:solidFill>
+                <a:latin typeface="Arial"/>
+                <a:ea typeface="Arial"/>
+                <a:cs typeface="Arial"/>
               </a:rPr>
               <a:t>AUTUMN 1  ·  WEEK 3  ·  LESSON B</a:t>
             </a:r>
@@ -2937,14 +3139,20 @@
           </a:ln>
         </p:spPr>
         <p:txBody>
-          <a:bodyPr xmlns:a="http://schemas.openxmlformats.org/drawingml/2006/main" lIns="0" tIns="0" rIns="0" bIns="0" anchor="ctr"/>
+          <a:bodyPr xmlns:a="http://schemas.openxmlformats.org/drawingml/2006/main" wrap="square" lIns="0" tIns="0" rIns="0" bIns="0" anchor="ctr">
+            <a:noAutofit/>
+          </a:bodyPr>
           <a:lstStyle xmlns:a="http://schemas.openxmlformats.org/drawingml/2006/main"/>
           <a:p xmlns:a="http://schemas.openxmlformats.org/drawingml/2006/main">
             <a:pPr>
+              <a:buNone/>
               <a:defRPr sz="1350" b="1">
                 <a:solidFill>
                   <a:srgbClr val="28685E"/>
                 </a:solidFill>
+                <a:latin typeface="Arial"/>
+                <a:ea typeface="Arial"/>
+                <a:cs typeface="Arial"/>
               </a:defRPr>
             </a:pPr>
             <a:r>
@@ -2952,6 +3160,9 @@
                 <a:solidFill>
                   <a:srgbClr val="28685E"/>
                 </a:solidFill>
+                <a:latin typeface="Arial"/>
+                <a:ea typeface="Arial"/>
+                <a:cs typeface="Arial"/>
               </a:rPr>
               <a:t>10</a:t>
             </a:r>
@@ -2974,8 +3185,8 @@
         </p:nvSpPr>
         <p:spPr>
           <a:xfrm xmlns:a="http://schemas.openxmlformats.org/drawingml/2006/main">
-            <a:off x="609600" y="2619375"/>
-            <a:ext cx="10972800" cy="714375"/>
+            <a:off x="609600" y="2305050"/>
+            <a:ext cx="10972800" cy="704850"/>
           </a:xfrm>
           <a:prstGeom xmlns:a="http://schemas.openxmlformats.org/drawingml/2006/main" prst="rect">
             <a:avLst/>
@@ -2987,14 +3198,20 @@
           </a:ln>
         </p:spPr>
         <p:txBody>
-          <a:bodyPr xmlns:a="http://schemas.openxmlformats.org/drawingml/2006/main" lIns="0" tIns="0" rIns="0" bIns="0" anchor="ctr"/>
+          <a:bodyPr xmlns:a="http://schemas.openxmlformats.org/drawingml/2006/main" wrap="square" lIns="0" tIns="0" rIns="0" bIns="0" anchor="ctr">
+            <a:noAutofit/>
+          </a:bodyPr>
           <a:lstStyle xmlns:a="http://schemas.openxmlformats.org/drawingml/2006/main"/>
           <a:p xmlns:a="http://schemas.openxmlformats.org/drawingml/2006/main">
             <a:pPr>
+              <a:buNone/>
               <a:defRPr sz="2550" b="0">
                 <a:solidFill>
                   <a:srgbClr val="152B3A"/>
                 </a:solidFill>
+                <a:latin typeface="Arial"/>
+                <a:ea typeface="Arial"/>
+                <a:cs typeface="Arial"/>
               </a:defRPr>
             </a:pPr>
             <a:r>
@@ -3002,6 +3219,9 @@
                 <a:solidFill>
                   <a:srgbClr val="152B3A"/>
                 </a:solidFill>
+                <a:latin typeface="Arial"/>
+                <a:ea typeface="Arial"/>
+                <a:cs typeface="Arial"/>
               </a:rPr>
               <a:t>What helped you join in?</a:t>
             </a:r>
@@ -3024,8 +3244,8 @@
         </p:nvSpPr>
         <p:spPr>
           <a:xfrm xmlns:a="http://schemas.openxmlformats.org/drawingml/2006/main">
-            <a:off x="609600" y="3409950"/>
-            <a:ext cx="10972800" cy="714375"/>
+            <a:off x="609600" y="3143250"/>
+            <a:ext cx="10972800" cy="704850"/>
           </a:xfrm>
           <a:prstGeom xmlns:a="http://schemas.openxmlformats.org/drawingml/2006/main" prst="rect">
             <a:avLst/>
@@ -3037,14 +3257,20 @@
           </a:ln>
         </p:spPr>
         <p:txBody>
-          <a:bodyPr xmlns:a="http://schemas.openxmlformats.org/drawingml/2006/main" lIns="0" tIns="0" rIns="0" bIns="0" anchor="ctr"/>
+          <a:bodyPr xmlns:a="http://schemas.openxmlformats.org/drawingml/2006/main" wrap="square" lIns="0" tIns="0" rIns="0" bIns="0" anchor="ctr">
+            <a:noAutofit/>
+          </a:bodyPr>
           <a:lstStyle xmlns:a="http://schemas.openxmlformats.org/drawingml/2006/main"/>
           <a:p xmlns:a="http://schemas.openxmlformats.org/drawingml/2006/main">
             <a:pPr>
+              <a:buNone/>
               <a:defRPr sz="2550" b="0">
                 <a:solidFill>
                   <a:srgbClr val="152B3A"/>
                 </a:solidFill>
+                <a:latin typeface="Arial"/>
+                <a:ea typeface="Arial"/>
+                <a:cs typeface="Arial"/>
               </a:defRPr>
             </a:pPr>
             <a:r>
@@ -3052,6 +3278,9 @@
                 <a:solidFill>
                   <a:srgbClr val="152B3A"/>
                 </a:solidFill>
+                <a:latin typeface="Arial"/>
+                <a:ea typeface="Arial"/>
+                <a:cs typeface="Arial"/>
               </a:rPr>
               <a:t>What could make the next activity easier?</a:t>
             </a:r>
@@ -3074,8 +3303,8 @@
         </p:nvSpPr>
         <p:spPr>
           <a:xfrm xmlns:a="http://schemas.openxmlformats.org/drawingml/2006/main">
-            <a:off x="609600" y="4200525"/>
-            <a:ext cx="10972800" cy="714375"/>
+            <a:off x="609600" y="3981450"/>
+            <a:ext cx="10972800" cy="704850"/>
           </a:xfrm>
           <a:prstGeom xmlns:a="http://schemas.openxmlformats.org/drawingml/2006/main" prst="rect">
             <a:avLst/>
@@ -3087,14 +3316,20 @@
           </a:ln>
         </p:spPr>
         <p:txBody>
-          <a:bodyPr xmlns:a="http://schemas.openxmlformats.org/drawingml/2006/main" lIns="0" tIns="0" rIns="0" bIns="0" anchor="ctr"/>
+          <a:bodyPr xmlns:a="http://schemas.openxmlformats.org/drawingml/2006/main" wrap="square" lIns="0" tIns="0" rIns="0" bIns="0" anchor="ctr">
+            <a:noAutofit/>
+          </a:bodyPr>
           <a:lstStyle xmlns:a="http://schemas.openxmlformats.org/drawingml/2006/main"/>
           <a:p xmlns:a="http://schemas.openxmlformats.org/drawingml/2006/main">
             <a:pPr>
+              <a:buNone/>
               <a:defRPr sz="2550" b="0">
                 <a:solidFill>
                   <a:srgbClr val="152B3A"/>
                 </a:solidFill>
+                <a:latin typeface="Arial"/>
+                <a:ea typeface="Arial"/>
+                <a:cs typeface="Arial"/>
               </a:defRPr>
             </a:pPr>
             <a:r>
@@ -3102,6 +3337,9 @@
                 <a:solidFill>
                   <a:srgbClr val="152B3A"/>
                 </a:solidFill>
+                <a:latin typeface="Arial"/>
+                <a:ea typeface="Arial"/>
+                <a:cs typeface="Arial"/>
               </a:rPr>
               <a:t>Point, sign, speak, write or pass privately.</a:t>
             </a:r>
@@ -3124,8 +3362,8 @@
         </p:nvSpPr>
         <p:spPr>
           <a:xfrm xmlns:a="http://schemas.openxmlformats.org/drawingml/2006/main">
-            <a:off x="609600" y="4991100"/>
-            <a:ext cx="10972800" cy="714375"/>
+            <a:off x="609600" y="4819650"/>
+            <a:ext cx="10972800" cy="704850"/>
           </a:xfrm>
           <a:prstGeom xmlns:a="http://schemas.openxmlformats.org/drawingml/2006/main" prst="rect">
             <a:avLst/>
@@ -3137,21 +3375,30 @@
           </a:ln>
         </p:spPr>
         <p:txBody>
-          <a:bodyPr xmlns:a="http://schemas.openxmlformats.org/drawingml/2006/main" lIns="0" tIns="0" rIns="0" bIns="0" anchor="ctr"/>
+          <a:bodyPr xmlns:a="http://schemas.openxmlformats.org/drawingml/2006/main" wrap="square" lIns="0" tIns="0" rIns="0" bIns="0" anchor="ctr">
+            <a:noAutofit/>
+          </a:bodyPr>
           <a:lstStyle xmlns:a="http://schemas.openxmlformats.org/drawingml/2006/main"/>
           <a:p xmlns:a="http://schemas.openxmlformats.org/drawingml/2006/main">
             <a:pPr>
-              <a:defRPr sz="2550" b="0">
-                <a:solidFill>
-                  <a:srgbClr val="152B3A"/>
-                </a:solidFill>
+              <a:buNone/>
+              <a:defRPr sz="2550" b="1">
+                <a:solidFill>
+                  <a:srgbClr val="28685E"/>
+                </a:solidFill>
+                <a:latin typeface="Arial"/>
+                <a:ea typeface="Arial"/>
+                <a:cs typeface="Arial"/>
               </a:defRPr>
             </a:pPr>
             <a:r>
-              <a:rPr sz="2550" b="0">
-                <a:solidFill>
-                  <a:srgbClr val="152B3A"/>
-                </a:solidFill>
+              <a:rPr sz="2550" b="1">
+                <a:solidFill>
+                  <a:srgbClr val="28685E"/>
+                </a:solidFill>
+                <a:latin typeface="Arial"/>
+                <a:ea typeface="Arial"/>
+                <a:cs typeface="Arial"/>
               </a:rPr>
               <a:t>Adult: agree one change and explain any limit.</a:t>
             </a:r>
@@ -3174,7 +3421,7 @@
     <p:bg>
       <p:bgPr>
         <a:solidFill xmlns:a="http://schemas.openxmlformats.org/drawingml/2006/main">
-          <a:srgbClr val="F5F1E8"/>
+          <a:srgbClr val="FBF9F3"/>
         </a:solidFill>
       </p:bgPr>
     </p:bg>
@@ -3203,8 +3450,8 @@
         </p:nvSpPr>
         <p:spPr>
           <a:xfrm xmlns:a="http://schemas.openxmlformats.org/drawingml/2006/main">
-            <a:off x="609600" y="552450"/>
-            <a:ext cx="781050" cy="57150"/>
+            <a:off x="609600" y="742950"/>
+            <a:ext cx="9906000" cy="38100"/>
           </a:xfrm>
           <a:prstGeom xmlns:a="http://schemas.openxmlformats.org/drawingml/2006/main" prst="rect">
             <a:avLst/>
@@ -3234,8 +3481,8 @@
         </p:nvSpPr>
         <p:spPr>
           <a:xfrm xmlns:a="http://schemas.openxmlformats.org/drawingml/2006/main">
-            <a:off x="609600" y="762000"/>
-            <a:ext cx="9334500" cy="285750"/>
+            <a:off x="609600" y="342900"/>
+            <a:ext cx="9334500" cy="266700"/>
           </a:xfrm>
           <a:prstGeom xmlns:a="http://schemas.openxmlformats.org/drawingml/2006/main" prst="rect">
             <a:avLst/>
@@ -3247,21 +3494,30 @@
           </a:ln>
         </p:spPr>
         <p:txBody>
-          <a:bodyPr xmlns:a="http://schemas.openxmlformats.org/drawingml/2006/main" lIns="0" tIns="0" rIns="0" bIns="0" anchor="ctr"/>
+          <a:bodyPr xmlns:a="http://schemas.openxmlformats.org/drawingml/2006/main" wrap="square" lIns="0" tIns="0" rIns="0" bIns="0" anchor="ctr">
+            <a:noAutofit/>
+          </a:bodyPr>
           <a:lstStyle xmlns:a="http://schemas.openxmlformats.org/drawingml/2006/main"/>
           <a:p xmlns:a="http://schemas.openxmlformats.org/drawingml/2006/main">
             <a:pPr>
-              <a:defRPr sz="1500" b="1">
+              <a:buNone/>
+              <a:defRPr sz="1425" b="1">
                 <a:solidFill>
                   <a:srgbClr val="28685E"/>
                 </a:solidFill>
+                <a:latin typeface="Arial"/>
+                <a:ea typeface="Arial"/>
+                <a:cs typeface="Arial"/>
               </a:defRPr>
             </a:pPr>
             <a:r>
-              <a:rPr sz="1500" b="1">
+              <a:rPr sz="1425" b="1">
                 <a:solidFill>
                   <a:srgbClr val="28685E"/>
                 </a:solidFill>
+                <a:latin typeface="Arial"/>
+                <a:ea typeface="Arial"/>
+                <a:cs typeface="Arial"/>
               </a:rPr>
               <a:t>MADE BY MATT  /  BUILD SCIENCE</a:t>
             </a:r>
@@ -3270,14 +3526,14 @@
       </p:sp>
       <p:pic>
         <p:nvPicPr>
-          <p:cNvPr id="13" name=""/>
+          <p:cNvPr id="15" name=""/>
           <p:cNvPicPr>
             <a:picLocks xmlns:a="http://schemas.openxmlformats.org/drawingml/2006/main" noChangeAspect="1"/>
           </p:cNvPicPr>
           <p:nvPr/>
         </p:nvPicPr>
         <p:blipFill>
-          <a:blip xmlns:r="http://schemas.openxmlformats.org/officeDocument/2006/relationships" xmlns:a="http://schemas.openxmlformats.org/drawingml/2006/main" r:embed="Rb2fef21c90bc4ee8"/>
+          <a:blip xmlns:r="http://schemas.openxmlformats.org/officeDocument/2006/relationships" xmlns:a="http://schemas.openxmlformats.org/drawingml/2006/main" r:embed="R7238436f06e7423d"/>
           <a:stretch xmlns:a="http://schemas.openxmlformats.org/drawingml/2006/main"/>
         </p:blipFill>
         <p:spPr>
@@ -3306,8 +3562,8 @@
         </p:nvSpPr>
         <p:spPr>
           <a:xfrm xmlns:a="http://schemas.openxmlformats.org/drawingml/2006/main">
-            <a:off x="609600" y="1352550"/>
-            <a:ext cx="10972800" cy="952500"/>
+            <a:off x="609600" y="1047750"/>
+            <a:ext cx="10972800" cy="895350"/>
           </a:xfrm>
           <a:prstGeom xmlns:a="http://schemas.openxmlformats.org/drawingml/2006/main" prst="rect">
             <a:avLst/>
@@ -3319,21 +3575,30 @@
           </a:ln>
         </p:spPr>
         <p:txBody>
-          <a:bodyPr xmlns:a="http://schemas.openxmlformats.org/drawingml/2006/main" lIns="0" tIns="0" rIns="0" bIns="0" anchor="ctr"/>
+          <a:bodyPr xmlns:a="http://schemas.openxmlformats.org/drawingml/2006/main" wrap="square" lIns="0" tIns="0" rIns="0" bIns="0" anchor="ctr">
+            <a:noAutofit/>
+          </a:bodyPr>
           <a:lstStyle xmlns:a="http://schemas.openxmlformats.org/drawingml/2006/main"/>
           <a:p xmlns:a="http://schemas.openxmlformats.org/drawingml/2006/main">
             <a:pPr>
-              <a:defRPr sz="3750" b="1">
+              <a:buNone/>
+              <a:defRPr sz="3600" b="1">
                 <a:solidFill>
                   <a:srgbClr val="152B3A"/>
                 </a:solidFill>
+                <a:latin typeface="Arial"/>
+                <a:ea typeface="Arial"/>
+                <a:cs typeface="Arial"/>
               </a:defRPr>
             </a:pPr>
             <a:r>
-              <a:rPr sz="3750" b="1">
+              <a:rPr sz="3600" b="1">
                 <a:solidFill>
                   <a:srgbClr val="152B3A"/>
                 </a:solidFill>
+                <a:latin typeface="Arial"/>
+                <a:ea typeface="Arial"/>
+                <a:cs typeface="Arial"/>
               </a:rPr>
               <a:t>Show the science you can explain</a:t>
             </a:r>
@@ -3400,21 +3665,30 @@
           </a:ln>
         </p:spPr>
         <p:txBody>
-          <a:bodyPr xmlns:a="http://schemas.openxmlformats.org/drawingml/2006/main" lIns="0" tIns="0" rIns="0" bIns="0" anchor="ctr"/>
+          <a:bodyPr xmlns:a="http://schemas.openxmlformats.org/drawingml/2006/main" wrap="square" lIns="0" tIns="0" rIns="0" bIns="0" anchor="ctr">
+            <a:noAutofit/>
+          </a:bodyPr>
           <a:lstStyle xmlns:a="http://schemas.openxmlformats.org/drawingml/2006/main"/>
           <a:p xmlns:a="http://schemas.openxmlformats.org/drawingml/2006/main">
             <a:pPr>
-              <a:defRPr sz="1275" b="0">
+              <a:buNone/>
+              <a:defRPr sz="1200" b="0">
                 <a:solidFill>
                   <a:srgbClr val="50616B"/>
                 </a:solidFill>
+                <a:latin typeface="Arial"/>
+                <a:ea typeface="Arial"/>
+                <a:cs typeface="Arial"/>
               </a:defRPr>
             </a:pPr>
             <a:r>
-              <a:rPr sz="1275" b="0">
+              <a:rPr sz="1200" b="0">
                 <a:solidFill>
                   <a:srgbClr val="50616B"/>
                 </a:solidFill>
+                <a:latin typeface="Arial"/>
+                <a:ea typeface="Arial"/>
+                <a:cs typeface="Arial"/>
               </a:rPr>
               <a:t>AUTUMN 1  ·  WEEK 3  ·  LESSON B</a:t>
             </a:r>
@@ -3450,14 +3724,20 @@
           </a:ln>
         </p:spPr>
         <p:txBody>
-          <a:bodyPr xmlns:a="http://schemas.openxmlformats.org/drawingml/2006/main" lIns="0" tIns="0" rIns="0" bIns="0" anchor="ctr"/>
+          <a:bodyPr xmlns:a="http://schemas.openxmlformats.org/drawingml/2006/main" wrap="square" lIns="0" tIns="0" rIns="0" bIns="0" anchor="ctr">
+            <a:noAutofit/>
+          </a:bodyPr>
           <a:lstStyle xmlns:a="http://schemas.openxmlformats.org/drawingml/2006/main"/>
           <a:p xmlns:a="http://schemas.openxmlformats.org/drawingml/2006/main">
             <a:pPr>
+              <a:buNone/>
               <a:defRPr sz="1350" b="1">
                 <a:solidFill>
                   <a:srgbClr val="28685E"/>
                 </a:solidFill>
+                <a:latin typeface="Arial"/>
+                <a:ea typeface="Arial"/>
+                <a:cs typeface="Arial"/>
               </a:defRPr>
             </a:pPr>
             <a:r>
@@ -3465,6 +3745,9 @@
                 <a:solidFill>
                   <a:srgbClr val="28685E"/>
                 </a:solidFill>
+                <a:latin typeface="Arial"/>
+                <a:ea typeface="Arial"/>
+                <a:cs typeface="Arial"/>
               </a:rPr>
               <a:t>11</a:t>
             </a:r>
@@ -3487,8 +3770,8 @@
         </p:nvSpPr>
         <p:spPr>
           <a:xfrm xmlns:a="http://schemas.openxmlformats.org/drawingml/2006/main">
-            <a:off x="609600" y="2619375"/>
-            <a:ext cx="10972800" cy="781050"/>
+            <a:off x="609600" y="2305050"/>
+            <a:ext cx="10972800" cy="914400"/>
           </a:xfrm>
           <a:prstGeom xmlns:a="http://schemas.openxmlformats.org/drawingml/2006/main" prst="rect">
             <a:avLst/>
@@ -3500,14 +3783,20 @@
           </a:ln>
         </p:spPr>
         <p:txBody>
-          <a:bodyPr xmlns:a="http://schemas.openxmlformats.org/drawingml/2006/main" lIns="0" tIns="0" rIns="0" bIns="0" anchor="ctr"/>
+          <a:bodyPr xmlns:a="http://schemas.openxmlformats.org/drawingml/2006/main" wrap="square" lIns="0" tIns="0" rIns="0" bIns="0" anchor="ctr">
+            <a:noAutofit/>
+          </a:bodyPr>
           <a:lstStyle xmlns:a="http://schemas.openxmlformats.org/drawingml/2006/main"/>
           <a:p xmlns:a="http://schemas.openxmlformats.org/drawingml/2006/main">
             <a:pPr>
+              <a:buNone/>
               <a:defRPr sz="2550" b="0">
                 <a:solidFill>
                   <a:srgbClr val="152B3A"/>
                 </a:solidFill>
+                <a:latin typeface="Arial"/>
+                <a:ea typeface="Arial"/>
+                <a:cs typeface="Arial"/>
               </a:defRPr>
             </a:pPr>
             <a:r>
@@ -3515,6 +3804,9 @@
                 <a:solidFill>
                   <a:srgbClr val="152B3A"/>
                 </a:solidFill>
+                <a:latin typeface="Arial"/>
+                <a:ea typeface="Arial"/>
+                <a:cs typeface="Arial"/>
               </a:rPr>
               <a:t>Supported: choose an animal with a backbone.</a:t>
             </a:r>
@@ -3537,8 +3829,8 @@
         </p:nvSpPr>
         <p:spPr>
           <a:xfrm xmlns:a="http://schemas.openxmlformats.org/drawingml/2006/main">
-            <a:off x="609600" y="3476625"/>
-            <a:ext cx="10972800" cy="781050"/>
+            <a:off x="609600" y="3352800"/>
+            <a:ext cx="10972800" cy="914400"/>
           </a:xfrm>
           <a:prstGeom xmlns:a="http://schemas.openxmlformats.org/drawingml/2006/main" prst="rect">
             <a:avLst/>
@@ -3550,14 +3842,20 @@
           </a:ln>
         </p:spPr>
         <p:txBody>
-          <a:bodyPr xmlns:a="http://schemas.openxmlformats.org/drawingml/2006/main" lIns="0" tIns="0" rIns="0" bIns="0" anchor="ctr"/>
+          <a:bodyPr xmlns:a="http://schemas.openxmlformats.org/drawingml/2006/main" wrap="square" lIns="0" tIns="0" rIns="0" bIns="0" anchor="ctr">
+            <a:noAutofit/>
+          </a:bodyPr>
           <a:lstStyle xmlns:a="http://schemas.openxmlformats.org/drawingml/2006/main"/>
           <a:p xmlns:a="http://schemas.openxmlformats.org/drawingml/2006/main">
             <a:pPr>
+              <a:buNone/>
               <a:defRPr sz="2550" b="0">
                 <a:solidFill>
                   <a:srgbClr val="152B3A"/>
                 </a:solidFill>
+                <a:latin typeface="Arial"/>
+                <a:ea typeface="Arial"/>
+                <a:cs typeface="Arial"/>
               </a:defRPr>
             </a:pPr>
             <a:r>
@@ -3565,6 +3863,9 @@
                 <a:solidFill>
                   <a:srgbClr val="152B3A"/>
                 </a:solidFill>
+                <a:latin typeface="Arial"/>
+                <a:ea typeface="Arial"/>
+                <a:cs typeface="Arial"/>
               </a:rPr>
               <a:t>Standard: explain why a crab is invertebrate.</a:t>
             </a:r>
@@ -3587,8 +3888,8 @@
         </p:nvSpPr>
         <p:spPr>
           <a:xfrm xmlns:a="http://schemas.openxmlformats.org/drawingml/2006/main">
-            <a:off x="609600" y="4333875"/>
-            <a:ext cx="10972800" cy="781050"/>
+            <a:off x="609600" y="4400550"/>
+            <a:ext cx="10972800" cy="914400"/>
           </a:xfrm>
           <a:prstGeom xmlns:a="http://schemas.openxmlformats.org/drawingml/2006/main" prst="rect">
             <a:avLst/>
@@ -3600,21 +3901,30 @@
           </a:ln>
         </p:spPr>
         <p:txBody>
-          <a:bodyPr xmlns:a="http://schemas.openxmlformats.org/drawingml/2006/main" lIns="0" tIns="0" rIns="0" bIns="0" anchor="ctr"/>
+          <a:bodyPr xmlns:a="http://schemas.openxmlformats.org/drawingml/2006/main" wrap="square" lIns="0" tIns="0" rIns="0" bIns="0" anchor="ctr">
+            <a:noAutofit/>
+          </a:bodyPr>
           <a:lstStyle xmlns:a="http://schemas.openxmlformats.org/drawingml/2006/main"/>
           <a:p xmlns:a="http://schemas.openxmlformats.org/drawingml/2006/main">
             <a:pPr>
-              <a:defRPr sz="2550" b="0">
-                <a:solidFill>
-                  <a:srgbClr val="152B3A"/>
-                </a:solidFill>
+              <a:buNone/>
+              <a:defRPr sz="2550" b="1">
+                <a:solidFill>
+                  <a:srgbClr val="28685E"/>
+                </a:solidFill>
+                <a:latin typeface="Arial"/>
+                <a:ea typeface="Arial"/>
+                <a:cs typeface="Arial"/>
               </a:defRPr>
             </a:pPr>
             <a:r>
-              <a:rPr sz="2550" b="0">
-                <a:solidFill>
-                  <a:srgbClr val="152B3A"/>
-                </a:solidFill>
+              <a:rPr sz="2550" b="1">
+                <a:solidFill>
+                  <a:srgbClr val="28685E"/>
+                </a:solidFill>
+                <a:latin typeface="Arial"/>
+                <a:ea typeface="Arial"/>
+                <a:cs typeface="Arial"/>
               </a:rPr>
               <a:t>Stretch: why is body size a poor test?</a:t>
             </a:r>
@@ -3637,7 +3947,7 @@
     <p:bg>
       <p:bgPr>
         <a:solidFill xmlns:a="http://schemas.openxmlformats.org/drawingml/2006/main">
-          <a:srgbClr val="F5F1E8"/>
+          <a:srgbClr val="FBF9F3"/>
         </a:solidFill>
       </p:bgPr>
     </p:bg>
@@ -3666,8 +3976,8 @@
         </p:nvSpPr>
         <p:spPr>
           <a:xfrm xmlns:a="http://schemas.openxmlformats.org/drawingml/2006/main">
-            <a:off x="609600" y="552450"/>
-            <a:ext cx="781050" cy="57150"/>
+            <a:off x="609600" y="742950"/>
+            <a:ext cx="9906000" cy="38100"/>
           </a:xfrm>
           <a:prstGeom xmlns:a="http://schemas.openxmlformats.org/drawingml/2006/main" prst="rect">
             <a:avLst/>
@@ -3697,8 +4007,8 @@
         </p:nvSpPr>
         <p:spPr>
           <a:xfrm xmlns:a="http://schemas.openxmlformats.org/drawingml/2006/main">
-            <a:off x="609600" y="762000"/>
-            <a:ext cx="9334500" cy="285750"/>
+            <a:off x="609600" y="342900"/>
+            <a:ext cx="9334500" cy="266700"/>
           </a:xfrm>
           <a:prstGeom xmlns:a="http://schemas.openxmlformats.org/drawingml/2006/main" prst="rect">
             <a:avLst/>
@@ -3710,21 +4020,30 @@
           </a:ln>
         </p:spPr>
         <p:txBody>
-          <a:bodyPr xmlns:a="http://schemas.openxmlformats.org/drawingml/2006/main" lIns="0" tIns="0" rIns="0" bIns="0" anchor="ctr"/>
+          <a:bodyPr xmlns:a="http://schemas.openxmlformats.org/drawingml/2006/main" wrap="square" lIns="0" tIns="0" rIns="0" bIns="0" anchor="ctr">
+            <a:noAutofit/>
+          </a:bodyPr>
           <a:lstStyle xmlns:a="http://schemas.openxmlformats.org/drawingml/2006/main"/>
           <a:p xmlns:a="http://schemas.openxmlformats.org/drawingml/2006/main">
             <a:pPr>
-              <a:defRPr sz="1500" b="1">
+              <a:buNone/>
+              <a:defRPr sz="1425" b="1">
                 <a:solidFill>
                   <a:srgbClr val="28685E"/>
                 </a:solidFill>
+                <a:latin typeface="Arial"/>
+                <a:ea typeface="Arial"/>
+                <a:cs typeface="Arial"/>
               </a:defRPr>
             </a:pPr>
             <a:r>
-              <a:rPr sz="1500" b="1">
+              <a:rPr sz="1425" b="1">
                 <a:solidFill>
                   <a:srgbClr val="28685E"/>
                 </a:solidFill>
+                <a:latin typeface="Arial"/>
+                <a:ea typeface="Arial"/>
+                <a:cs typeface="Arial"/>
               </a:rPr>
               <a:t>MADE BY MATT  /  BUILD SCIENCE</a:t>
             </a:r>
@@ -3733,14 +4052,14 @@
       </p:sp>
       <p:pic>
         <p:nvPicPr>
-          <p:cNvPr id="13" name=""/>
+          <p:cNvPr id="15" name=""/>
           <p:cNvPicPr>
             <a:picLocks xmlns:a="http://schemas.openxmlformats.org/drawingml/2006/main" noChangeAspect="1"/>
           </p:cNvPicPr>
           <p:nvPr/>
         </p:nvPicPr>
         <p:blipFill>
-          <a:blip xmlns:r="http://schemas.openxmlformats.org/officeDocument/2006/relationships" xmlns:a="http://schemas.openxmlformats.org/drawingml/2006/main" r:embed="R6c8f7d7fae9b4b13"/>
+          <a:blip xmlns:r="http://schemas.openxmlformats.org/officeDocument/2006/relationships" xmlns:a="http://schemas.openxmlformats.org/drawingml/2006/main" r:embed="R8844083d9b664a31"/>
           <a:stretch xmlns:a="http://schemas.openxmlformats.org/drawingml/2006/main"/>
         </p:blipFill>
         <p:spPr>
@@ -3769,8 +4088,8 @@
         </p:nvSpPr>
         <p:spPr>
           <a:xfrm xmlns:a="http://schemas.openxmlformats.org/drawingml/2006/main">
-            <a:off x="609600" y="1352550"/>
-            <a:ext cx="10972800" cy="952500"/>
+            <a:off x="609600" y="1047750"/>
+            <a:ext cx="10972800" cy="895350"/>
           </a:xfrm>
           <a:prstGeom xmlns:a="http://schemas.openxmlformats.org/drawingml/2006/main" prst="rect">
             <a:avLst/>
@@ -3782,21 +4101,30 @@
           </a:ln>
         </p:spPr>
         <p:txBody>
-          <a:bodyPr xmlns:a="http://schemas.openxmlformats.org/drawingml/2006/main" lIns="0" tIns="0" rIns="0" bIns="0" anchor="ctr"/>
+          <a:bodyPr xmlns:a="http://schemas.openxmlformats.org/drawingml/2006/main" wrap="square" lIns="0" tIns="0" rIns="0" bIns="0" anchor="ctr">
+            <a:noAutofit/>
+          </a:bodyPr>
           <a:lstStyle xmlns:a="http://schemas.openxmlformats.org/drawingml/2006/main"/>
           <a:p xmlns:a="http://schemas.openxmlformats.org/drawingml/2006/main">
             <a:pPr>
-              <a:defRPr sz="3750" b="1">
+              <a:buNone/>
+              <a:defRPr sz="3600" b="1">
                 <a:solidFill>
                   <a:srgbClr val="152B3A"/>
                 </a:solidFill>
+                <a:latin typeface="Arial"/>
+                <a:ea typeface="Arial"/>
+                <a:cs typeface="Arial"/>
               </a:defRPr>
             </a:pPr>
             <a:r>
-              <a:rPr sz="3750" b="1">
+              <a:rPr sz="3600" b="1">
                 <a:solidFill>
                   <a:srgbClr val="152B3A"/>
                 </a:solidFill>
+                <a:latin typeface="Arial"/>
+                <a:ea typeface="Arial"/>
+                <a:cs typeface="Arial"/>
               </a:rPr>
               <a:t>Return to Monday’s rule</a:t>
             </a:r>
@@ -3863,21 +4191,30 @@
           </a:ln>
         </p:spPr>
         <p:txBody>
-          <a:bodyPr xmlns:a="http://schemas.openxmlformats.org/drawingml/2006/main" lIns="0" tIns="0" rIns="0" bIns="0" anchor="ctr"/>
+          <a:bodyPr xmlns:a="http://schemas.openxmlformats.org/drawingml/2006/main" wrap="square" lIns="0" tIns="0" rIns="0" bIns="0" anchor="ctr">
+            <a:noAutofit/>
+          </a:bodyPr>
           <a:lstStyle xmlns:a="http://schemas.openxmlformats.org/drawingml/2006/main"/>
           <a:p xmlns:a="http://schemas.openxmlformats.org/drawingml/2006/main">
             <a:pPr>
-              <a:defRPr sz="1275" b="0">
+              <a:buNone/>
+              <a:defRPr sz="1200" b="0">
                 <a:solidFill>
                   <a:srgbClr val="50616B"/>
                 </a:solidFill>
+                <a:latin typeface="Arial"/>
+                <a:ea typeface="Arial"/>
+                <a:cs typeface="Arial"/>
               </a:defRPr>
             </a:pPr>
             <a:r>
-              <a:rPr sz="1275" b="0">
+              <a:rPr sz="1200" b="0">
                 <a:solidFill>
                   <a:srgbClr val="50616B"/>
                 </a:solidFill>
+                <a:latin typeface="Arial"/>
+                <a:ea typeface="Arial"/>
+                <a:cs typeface="Arial"/>
               </a:rPr>
               <a:t>AUTUMN 1  ·  WEEK 3  ·  LESSON B</a:t>
             </a:r>
@@ -3913,14 +4250,20 @@
           </a:ln>
         </p:spPr>
         <p:txBody>
-          <a:bodyPr xmlns:a="http://schemas.openxmlformats.org/drawingml/2006/main" lIns="0" tIns="0" rIns="0" bIns="0" anchor="ctr"/>
+          <a:bodyPr xmlns:a="http://schemas.openxmlformats.org/drawingml/2006/main" wrap="square" lIns="0" tIns="0" rIns="0" bIns="0" anchor="ctr">
+            <a:noAutofit/>
+          </a:bodyPr>
           <a:lstStyle xmlns:a="http://schemas.openxmlformats.org/drawingml/2006/main"/>
           <a:p xmlns:a="http://schemas.openxmlformats.org/drawingml/2006/main">
             <a:pPr>
+              <a:buNone/>
               <a:defRPr sz="1350" b="1">
                 <a:solidFill>
                   <a:srgbClr val="28685E"/>
                 </a:solidFill>
+                <a:latin typeface="Arial"/>
+                <a:ea typeface="Arial"/>
+                <a:cs typeface="Arial"/>
               </a:defRPr>
             </a:pPr>
             <a:r>
@@ -3928,6 +4271,9 @@
                 <a:solidFill>
                   <a:srgbClr val="28685E"/>
                 </a:solidFill>
+                <a:latin typeface="Arial"/>
+                <a:ea typeface="Arial"/>
+                <a:cs typeface="Arial"/>
               </a:rPr>
               <a:t>02</a:t>
             </a:r>
@@ -3950,8 +4296,8 @@
         </p:nvSpPr>
         <p:spPr>
           <a:xfrm xmlns:a="http://schemas.openxmlformats.org/drawingml/2006/main">
-            <a:off x="609600" y="2619375"/>
-            <a:ext cx="10972800" cy="781050"/>
+            <a:off x="609600" y="2305050"/>
+            <a:ext cx="10972800" cy="914400"/>
           </a:xfrm>
           <a:prstGeom xmlns:a="http://schemas.openxmlformats.org/drawingml/2006/main" prst="rect">
             <a:avLst/>
@@ -3963,14 +4309,20 @@
           </a:ln>
         </p:spPr>
         <p:txBody>
-          <a:bodyPr xmlns:a="http://schemas.openxmlformats.org/drawingml/2006/main" lIns="0" tIns="0" rIns="0" bIns="0" anchor="ctr"/>
+          <a:bodyPr xmlns:a="http://schemas.openxmlformats.org/drawingml/2006/main" wrap="square" lIns="0" tIns="0" rIns="0" bIns="0" anchor="ctr">
+            <a:noAutofit/>
+          </a:bodyPr>
           <a:lstStyle xmlns:a="http://schemas.openxmlformats.org/drawingml/2006/main"/>
           <a:p xmlns:a="http://schemas.openxmlformats.org/drawingml/2006/main">
             <a:pPr>
+              <a:buNone/>
               <a:defRPr sz="2550" b="0">
                 <a:solidFill>
                   <a:srgbClr val="152B3A"/>
                 </a:solidFill>
+                <a:latin typeface="Arial"/>
+                <a:ea typeface="Arial"/>
+                <a:cs typeface="Arial"/>
               </a:defRPr>
             </a:pPr>
             <a:r>
@@ -3978,6 +4330,9 @@
                 <a:solidFill>
                   <a:srgbClr val="152B3A"/>
                 </a:solidFill>
+                <a:latin typeface="Arial"/>
+                <a:ea typeface="Arial"/>
+                <a:cs typeface="Arial"/>
               </a:rPr>
               <a:t>Find your saved animal sort.</a:t>
             </a:r>
@@ -4000,8 +4355,8 @@
         </p:nvSpPr>
         <p:spPr>
           <a:xfrm xmlns:a="http://schemas.openxmlformats.org/drawingml/2006/main">
-            <a:off x="609600" y="3476625"/>
-            <a:ext cx="10972800" cy="781050"/>
+            <a:off x="609600" y="3352800"/>
+            <a:ext cx="10972800" cy="914400"/>
           </a:xfrm>
           <a:prstGeom xmlns:a="http://schemas.openxmlformats.org/drawingml/2006/main" prst="rect">
             <a:avLst/>
@@ -4013,14 +4368,20 @@
           </a:ln>
         </p:spPr>
         <p:txBody>
-          <a:bodyPr xmlns:a="http://schemas.openxmlformats.org/drawingml/2006/main" lIns="0" tIns="0" rIns="0" bIns="0" anchor="ctr"/>
+          <a:bodyPr xmlns:a="http://schemas.openxmlformats.org/drawingml/2006/main" wrap="square" lIns="0" tIns="0" rIns="0" bIns="0" anchor="ctr">
+            <a:noAutofit/>
+          </a:bodyPr>
           <a:lstStyle xmlns:a="http://schemas.openxmlformats.org/drawingml/2006/main"/>
           <a:p xmlns:a="http://schemas.openxmlformats.org/drawingml/2006/main">
             <a:pPr>
+              <a:buNone/>
               <a:defRPr sz="2550" b="0">
                 <a:solidFill>
                   <a:srgbClr val="152B3A"/>
                 </a:solidFill>
+                <a:latin typeface="Arial"/>
+                <a:ea typeface="Arial"/>
+                <a:cs typeface="Arial"/>
               </a:defRPr>
             </a:pPr>
             <a:r>
@@ -4028,6 +4389,9 @@
                 <a:solidFill>
                   <a:srgbClr val="152B3A"/>
                 </a:solidFill>
+                <a:latin typeface="Arial"/>
+                <a:ea typeface="Arial"/>
+                <a:cs typeface="Arial"/>
               </a:rPr>
               <a:t>Name or point to the backbone rule.</a:t>
             </a:r>
@@ -4050,8 +4414,8 @@
         </p:nvSpPr>
         <p:spPr>
           <a:xfrm xmlns:a="http://schemas.openxmlformats.org/drawingml/2006/main">
-            <a:off x="609600" y="4333875"/>
-            <a:ext cx="10972800" cy="781050"/>
+            <a:off x="609600" y="4400550"/>
+            <a:ext cx="10972800" cy="914400"/>
           </a:xfrm>
           <a:prstGeom xmlns:a="http://schemas.openxmlformats.org/drawingml/2006/main" prst="rect">
             <a:avLst/>
@@ -4063,21 +4427,30 @@
           </a:ln>
         </p:spPr>
         <p:txBody>
-          <a:bodyPr xmlns:a="http://schemas.openxmlformats.org/drawingml/2006/main" lIns="0" tIns="0" rIns="0" bIns="0" anchor="ctr"/>
+          <a:bodyPr xmlns:a="http://schemas.openxmlformats.org/drawingml/2006/main" wrap="square" lIns="0" tIns="0" rIns="0" bIns="0" anchor="ctr">
+            <a:noAutofit/>
+          </a:bodyPr>
           <a:lstStyle xmlns:a="http://schemas.openxmlformats.org/drawingml/2006/main"/>
           <a:p xmlns:a="http://schemas.openxmlformats.org/drawingml/2006/main">
             <a:pPr>
-              <a:defRPr sz="2550" b="0">
-                <a:solidFill>
-                  <a:srgbClr val="152B3A"/>
-                </a:solidFill>
+              <a:buNone/>
+              <a:defRPr sz="2550" b="1">
+                <a:solidFill>
+                  <a:srgbClr val="28685E"/>
+                </a:solidFill>
+                <a:latin typeface="Arial"/>
+                <a:ea typeface="Arial"/>
+                <a:cs typeface="Arial"/>
               </a:defRPr>
             </a:pPr>
             <a:r>
-              <a:rPr sz="2550" b="0">
-                <a:solidFill>
-                  <a:srgbClr val="152B3A"/>
-                </a:solidFill>
+              <a:rPr sz="2550" b="1">
+                <a:solidFill>
+                  <a:srgbClr val="28685E"/>
+                </a:solidFill>
+                <a:latin typeface="Arial"/>
+                <a:ea typeface="Arial"/>
+                <a:cs typeface="Arial"/>
               </a:rPr>
               <a:t>Choose: read, point, move cards or direct.</a:t>
             </a:r>
@@ -4100,7 +4473,7 @@
     <p:bg>
       <p:bgPr>
         <a:solidFill xmlns:a="http://schemas.openxmlformats.org/drawingml/2006/main">
-          <a:srgbClr val="F5F1E8"/>
+          <a:srgbClr val="FBF9F3"/>
         </a:solidFill>
       </p:bgPr>
     </p:bg>
@@ -4129,8 +4502,8 @@
         </p:nvSpPr>
         <p:spPr>
           <a:xfrm xmlns:a="http://schemas.openxmlformats.org/drawingml/2006/main">
-            <a:off x="609600" y="552450"/>
-            <a:ext cx="781050" cy="57150"/>
+            <a:off x="609600" y="742950"/>
+            <a:ext cx="9906000" cy="38100"/>
           </a:xfrm>
           <a:prstGeom xmlns:a="http://schemas.openxmlformats.org/drawingml/2006/main" prst="rect">
             <a:avLst/>
@@ -4160,8 +4533,8 @@
         </p:nvSpPr>
         <p:spPr>
           <a:xfrm xmlns:a="http://schemas.openxmlformats.org/drawingml/2006/main">
-            <a:off x="609600" y="762000"/>
-            <a:ext cx="9334500" cy="285750"/>
+            <a:off x="609600" y="342900"/>
+            <a:ext cx="9334500" cy="266700"/>
           </a:xfrm>
           <a:prstGeom xmlns:a="http://schemas.openxmlformats.org/drawingml/2006/main" prst="rect">
             <a:avLst/>
@@ -4173,21 +4546,30 @@
           </a:ln>
         </p:spPr>
         <p:txBody>
-          <a:bodyPr xmlns:a="http://schemas.openxmlformats.org/drawingml/2006/main" lIns="0" tIns="0" rIns="0" bIns="0" anchor="ctr"/>
+          <a:bodyPr xmlns:a="http://schemas.openxmlformats.org/drawingml/2006/main" wrap="square" lIns="0" tIns="0" rIns="0" bIns="0" anchor="ctr">
+            <a:noAutofit/>
+          </a:bodyPr>
           <a:lstStyle xmlns:a="http://schemas.openxmlformats.org/drawingml/2006/main"/>
           <a:p xmlns:a="http://schemas.openxmlformats.org/drawingml/2006/main">
             <a:pPr>
-              <a:defRPr sz="1500" b="1">
+              <a:buNone/>
+              <a:defRPr sz="1425" b="1">
                 <a:solidFill>
                   <a:srgbClr val="28685E"/>
                 </a:solidFill>
+                <a:latin typeface="Arial"/>
+                <a:ea typeface="Arial"/>
+                <a:cs typeface="Arial"/>
               </a:defRPr>
             </a:pPr>
             <a:r>
-              <a:rPr sz="1500" b="1">
+              <a:rPr sz="1425" b="1">
                 <a:solidFill>
                   <a:srgbClr val="28685E"/>
                 </a:solidFill>
+                <a:latin typeface="Arial"/>
+                <a:ea typeface="Arial"/>
+                <a:cs typeface="Arial"/>
               </a:rPr>
               <a:t>MADE BY MATT  /  BUILD SCIENCE</a:t>
             </a:r>
@@ -4196,14 +4578,14 @@
       </p:sp>
       <p:pic>
         <p:nvPicPr>
-          <p:cNvPr id="14" name=""/>
+          <p:cNvPr id="19" name=""/>
           <p:cNvPicPr>
             <a:picLocks xmlns:a="http://schemas.openxmlformats.org/drawingml/2006/main" noChangeAspect="1"/>
           </p:cNvPicPr>
           <p:nvPr/>
         </p:nvPicPr>
         <p:blipFill>
-          <a:blip xmlns:r="http://schemas.openxmlformats.org/officeDocument/2006/relationships" xmlns:a="http://schemas.openxmlformats.org/drawingml/2006/main" r:embed="R5491c603e2f74a8d"/>
+          <a:blip xmlns:r="http://schemas.openxmlformats.org/officeDocument/2006/relationships" xmlns:a="http://schemas.openxmlformats.org/drawingml/2006/main" r:embed="R5d07c1f030a04b61"/>
           <a:stretch xmlns:a="http://schemas.openxmlformats.org/drawingml/2006/main"/>
         </p:blipFill>
         <p:spPr>
@@ -4232,8 +4614,8 @@
         </p:nvSpPr>
         <p:spPr>
           <a:xfrm xmlns:a="http://schemas.openxmlformats.org/drawingml/2006/main">
-            <a:off x="609600" y="1352550"/>
-            <a:ext cx="10972800" cy="952500"/>
+            <a:off x="609600" y="1047750"/>
+            <a:ext cx="10972800" cy="895350"/>
           </a:xfrm>
           <a:prstGeom xmlns:a="http://schemas.openxmlformats.org/drawingml/2006/main" prst="rect">
             <a:avLst/>
@@ -4245,21 +4627,30 @@
           </a:ln>
         </p:spPr>
         <p:txBody>
-          <a:bodyPr xmlns:a="http://schemas.openxmlformats.org/drawingml/2006/main" lIns="0" tIns="0" rIns="0" bIns="0" anchor="ctr"/>
+          <a:bodyPr xmlns:a="http://schemas.openxmlformats.org/drawingml/2006/main" wrap="square" lIns="0" tIns="0" rIns="0" bIns="0" anchor="ctr">
+            <a:noAutofit/>
+          </a:bodyPr>
           <a:lstStyle xmlns:a="http://schemas.openxmlformats.org/drawingml/2006/main"/>
           <a:p xmlns:a="http://schemas.openxmlformats.org/drawingml/2006/main">
             <a:pPr>
-              <a:defRPr sz="3750" b="1">
+              <a:buNone/>
+              <a:defRPr sz="3600" b="1">
                 <a:solidFill>
                   <a:srgbClr val="152B3A"/>
                 </a:solidFill>
+                <a:latin typeface="Arial"/>
+                <a:ea typeface="Arial"/>
+                <a:cs typeface="Arial"/>
               </a:defRPr>
             </a:pPr>
             <a:r>
-              <a:rPr sz="3750" b="1">
+              <a:rPr sz="3600" b="1">
                 <a:solidFill>
                   <a:srgbClr val="152B3A"/>
                 </a:solidFill>
+                <a:latin typeface="Arial"/>
+                <a:ea typeface="Arial"/>
+                <a:cs typeface="Arial"/>
               </a:rPr>
               <a:t>Goldfish and bat: use body clues</a:t>
             </a:r>
@@ -4326,21 +4717,30 @@
           </a:ln>
         </p:spPr>
         <p:txBody>
-          <a:bodyPr xmlns:a="http://schemas.openxmlformats.org/drawingml/2006/main" lIns="0" tIns="0" rIns="0" bIns="0" anchor="ctr"/>
+          <a:bodyPr xmlns:a="http://schemas.openxmlformats.org/drawingml/2006/main" wrap="square" lIns="0" tIns="0" rIns="0" bIns="0" anchor="ctr">
+            <a:noAutofit/>
+          </a:bodyPr>
           <a:lstStyle xmlns:a="http://schemas.openxmlformats.org/drawingml/2006/main"/>
           <a:p xmlns:a="http://schemas.openxmlformats.org/drawingml/2006/main">
             <a:pPr>
-              <a:defRPr sz="1275" b="0">
+              <a:buNone/>
+              <a:defRPr sz="1200" b="0">
                 <a:solidFill>
                   <a:srgbClr val="50616B"/>
                 </a:solidFill>
+                <a:latin typeface="Arial"/>
+                <a:ea typeface="Arial"/>
+                <a:cs typeface="Arial"/>
               </a:defRPr>
             </a:pPr>
             <a:r>
-              <a:rPr sz="1275" b="0">
+              <a:rPr sz="1200" b="0">
                 <a:solidFill>
                   <a:srgbClr val="50616B"/>
                 </a:solidFill>
+                <a:latin typeface="Arial"/>
+                <a:ea typeface="Arial"/>
+                <a:cs typeface="Arial"/>
               </a:rPr>
               <a:t>AUTUMN 1  ·  WEEK 3  ·  LESSON B</a:t>
             </a:r>
@@ -4376,14 +4776,20 @@
           </a:ln>
         </p:spPr>
         <p:txBody>
-          <a:bodyPr xmlns:a="http://schemas.openxmlformats.org/drawingml/2006/main" lIns="0" tIns="0" rIns="0" bIns="0" anchor="ctr"/>
+          <a:bodyPr xmlns:a="http://schemas.openxmlformats.org/drawingml/2006/main" wrap="square" lIns="0" tIns="0" rIns="0" bIns="0" anchor="ctr">
+            <a:noAutofit/>
+          </a:bodyPr>
           <a:lstStyle xmlns:a="http://schemas.openxmlformats.org/drawingml/2006/main"/>
           <a:p xmlns:a="http://schemas.openxmlformats.org/drawingml/2006/main">
             <a:pPr>
+              <a:buNone/>
               <a:defRPr sz="1350" b="1">
                 <a:solidFill>
                   <a:srgbClr val="28685E"/>
                 </a:solidFill>
+                <a:latin typeface="Arial"/>
+                <a:ea typeface="Arial"/>
+                <a:cs typeface="Arial"/>
               </a:defRPr>
             </a:pPr>
             <a:r>
@@ -4391,6 +4797,9 @@
                 <a:solidFill>
                   <a:srgbClr val="28685E"/>
                 </a:solidFill>
+                <a:latin typeface="Arial"/>
+                <a:ea typeface="Arial"/>
+                <a:cs typeface="Arial"/>
               </a:rPr>
               <a:t>03</a:t>
             </a:r>
@@ -4413,8 +4822,8 @@
         </p:nvSpPr>
         <p:spPr>
           <a:xfrm xmlns:a="http://schemas.openxmlformats.org/drawingml/2006/main">
-            <a:off x="609600" y="2619375"/>
-            <a:ext cx="4953000" cy="428625"/>
+            <a:off x="609600" y="2257425"/>
+            <a:ext cx="5143500" cy="533400"/>
           </a:xfrm>
           <a:prstGeom xmlns:a="http://schemas.openxmlformats.org/drawingml/2006/main" prst="rect">
             <a:avLst/>
@@ -4426,21 +4835,30 @@
           </a:ln>
         </p:spPr>
         <p:txBody>
-          <a:bodyPr xmlns:a="http://schemas.openxmlformats.org/drawingml/2006/main" lIns="0" tIns="0" rIns="0" bIns="0" anchor="ctr"/>
+          <a:bodyPr xmlns:a="http://schemas.openxmlformats.org/drawingml/2006/main" wrap="square" lIns="0" tIns="0" rIns="0" bIns="0" anchor="ctr">
+            <a:noAutofit/>
+          </a:bodyPr>
           <a:lstStyle xmlns:a="http://schemas.openxmlformats.org/drawingml/2006/main"/>
           <a:p xmlns:a="http://schemas.openxmlformats.org/drawingml/2006/main">
             <a:pPr>
-              <a:defRPr sz="2025" b="1">
+              <a:buNone/>
+              <a:defRPr sz="2100" b="1">
                 <a:solidFill>
                   <a:srgbClr val="28685E"/>
                 </a:solidFill>
+                <a:latin typeface="Arial"/>
+                <a:ea typeface="Arial"/>
+                <a:cs typeface="Arial"/>
               </a:defRPr>
             </a:pPr>
             <a:r>
-              <a:rPr sz="2025" b="1">
+              <a:rPr sz="2100" b="1">
                 <a:solidFill>
                   <a:srgbClr val="28685E"/>
                 </a:solidFill>
+                <a:latin typeface="Arial"/>
+                <a:ea typeface="Arial"/>
+                <a:cs typeface="Arial"/>
               </a:rPr>
               <a:t>GOLDFISH</a:t>
             </a:r>
@@ -4463,8 +4881,8 @@
         </p:nvSpPr>
         <p:spPr>
           <a:xfrm xmlns:a="http://schemas.openxmlformats.org/drawingml/2006/main">
-            <a:off x="6572250" y="2619375"/>
-            <a:ext cx="4953000" cy="428625"/>
+            <a:off x="6572250" y="2257425"/>
+            <a:ext cx="5010150" cy="533400"/>
           </a:xfrm>
           <a:prstGeom xmlns:a="http://schemas.openxmlformats.org/drawingml/2006/main" prst="rect">
             <a:avLst/>
@@ -4476,21 +4894,30 @@
           </a:ln>
         </p:spPr>
         <p:txBody>
-          <a:bodyPr xmlns:a="http://schemas.openxmlformats.org/drawingml/2006/main" lIns="0" tIns="0" rIns="0" bIns="0" anchor="ctr"/>
+          <a:bodyPr xmlns:a="http://schemas.openxmlformats.org/drawingml/2006/main" wrap="square" lIns="0" tIns="0" rIns="0" bIns="0" anchor="ctr">
+            <a:noAutofit/>
+          </a:bodyPr>
           <a:lstStyle xmlns:a="http://schemas.openxmlformats.org/drawingml/2006/main"/>
           <a:p xmlns:a="http://schemas.openxmlformats.org/drawingml/2006/main">
             <a:pPr>
-              <a:defRPr sz="2025" b="1">
+              <a:buNone/>
+              <a:defRPr sz="2100" b="1">
                 <a:solidFill>
                   <a:srgbClr val="A65D25"/>
                 </a:solidFill>
+                <a:latin typeface="Arial"/>
+                <a:ea typeface="Arial"/>
+                <a:cs typeface="Arial"/>
               </a:defRPr>
             </a:pPr>
             <a:r>
-              <a:rPr sz="2025" b="1">
+              <a:rPr sz="2100" b="1">
                 <a:solidFill>
                   <a:srgbClr val="A65D25"/>
                 </a:solidFill>
+                <a:latin typeface="Arial"/>
+                <a:ea typeface="Arial"/>
+                <a:cs typeface="Arial"/>
               </a:rPr>
               <a:t>BAT</a:t>
             </a:r>
@@ -4513,8 +4940,8 @@
         </p:nvSpPr>
         <p:spPr>
           <a:xfrm xmlns:a="http://schemas.openxmlformats.org/drawingml/2006/main">
-            <a:off x="609600" y="3333750"/>
-            <a:ext cx="4953000" cy="2524125"/>
+            <a:off x="609600" y="3086100"/>
+            <a:ext cx="5143500" cy="1190625"/>
           </a:xfrm>
           <a:prstGeom xmlns:a="http://schemas.openxmlformats.org/drawingml/2006/main" prst="rect">
             <a:avLst/>
@@ -4526,14 +4953,20 @@
           </a:ln>
         </p:spPr>
         <p:txBody>
-          <a:bodyPr xmlns:a="http://schemas.openxmlformats.org/drawingml/2006/main" lIns="0" tIns="0" rIns="0" bIns="0" anchor="ctr"/>
+          <a:bodyPr xmlns:a="http://schemas.openxmlformats.org/drawingml/2006/main" wrap="square" lIns="0" tIns="0" rIns="0" bIns="0" anchor="ctr">
+            <a:noAutofit/>
+          </a:bodyPr>
           <a:lstStyle xmlns:a="http://schemas.openxmlformats.org/drawingml/2006/main"/>
           <a:p xmlns:a="http://schemas.openxmlformats.org/drawingml/2006/main">
             <a:pPr>
+              <a:buNone/>
               <a:defRPr sz="2400" b="0">
                 <a:solidFill>
                   <a:srgbClr val="152B3A"/>
                 </a:solidFill>
+                <a:latin typeface="Arial"/>
+                <a:ea typeface="Arial"/>
+                <a:cs typeface="Arial"/>
               </a:defRPr>
             </a:pPr>
             <a:r>
@@ -4541,16 +4974,23 @@
                 <a:solidFill>
                   <a:srgbClr val="152B3A"/>
                 </a:solidFill>
+                <a:latin typeface="Arial"/>
+                <a:ea typeface="Arial"/>
+                <a:cs typeface="Arial"/>
               </a:rPr>
               <a:t>Bones inside its body.</a:t>
             </a:r>
           </a:p>
           <a:p xmlns:a="http://schemas.openxmlformats.org/drawingml/2006/main">
             <a:pPr>
+              <a:buNone/>
               <a:defRPr sz="2400" b="0">
                 <a:solidFill>
                   <a:srgbClr val="152B3A"/>
                 </a:solidFill>
+                <a:latin typeface="Arial"/>
+                <a:ea typeface="Arial"/>
+                <a:cs typeface="Arial"/>
               </a:defRPr>
             </a:pPr>
             <a:r>
@@ -4558,6 +4998,9 @@
                 <a:solidFill>
                   <a:srgbClr val="152B3A"/>
                 </a:solidFill>
+                <a:latin typeface="Arial"/>
+                <a:ea typeface="Arial"/>
+                <a:cs typeface="Arial"/>
               </a:rPr>
               <a:t>Those bones include a backbone.</a:t>
             </a:r>
@@ -4580,8 +5023,8 @@
         </p:nvSpPr>
         <p:spPr>
           <a:xfrm xmlns:a="http://schemas.openxmlformats.org/drawingml/2006/main">
-            <a:off x="6572250" y="3333750"/>
-            <a:ext cx="4857750" cy="2524125"/>
+            <a:off x="6572250" y="3086100"/>
+            <a:ext cx="5010150" cy="1714500"/>
           </a:xfrm>
           <a:prstGeom xmlns:a="http://schemas.openxmlformats.org/drawingml/2006/main" prst="rect">
             <a:avLst/>
@@ -4593,14 +5036,20 @@
           </a:ln>
         </p:spPr>
         <p:txBody>
-          <a:bodyPr xmlns:a="http://schemas.openxmlformats.org/drawingml/2006/main" lIns="0" tIns="0" rIns="0" bIns="0" anchor="ctr"/>
+          <a:bodyPr xmlns:a="http://schemas.openxmlformats.org/drawingml/2006/main" wrap="square" lIns="0" tIns="0" rIns="0" bIns="0" anchor="ctr">
+            <a:noAutofit/>
+          </a:bodyPr>
           <a:lstStyle xmlns:a="http://schemas.openxmlformats.org/drawingml/2006/main"/>
           <a:p xmlns:a="http://schemas.openxmlformats.org/drawingml/2006/main">
             <a:pPr>
+              <a:buNone/>
               <a:defRPr sz="2400" b="0">
                 <a:solidFill>
                   <a:srgbClr val="152B3A"/>
                 </a:solidFill>
+                <a:latin typeface="Arial"/>
+                <a:ea typeface="Arial"/>
+                <a:cs typeface="Arial"/>
               </a:defRPr>
             </a:pPr>
             <a:r>
@@ -4608,16 +5057,23 @@
                 <a:solidFill>
                   <a:srgbClr val="152B3A"/>
                 </a:solidFill>
+                <a:latin typeface="Arial"/>
+                <a:ea typeface="Arial"/>
+                <a:cs typeface="Arial"/>
               </a:rPr>
               <a:t>Wings on the outside.</a:t>
             </a:r>
           </a:p>
           <a:p xmlns:a="http://schemas.openxmlformats.org/drawingml/2006/main">
             <a:pPr>
+              <a:buNone/>
               <a:defRPr sz="2400" b="0">
                 <a:solidFill>
                   <a:srgbClr val="152B3A"/>
                 </a:solidFill>
+                <a:latin typeface="Arial"/>
+                <a:ea typeface="Arial"/>
+                <a:cs typeface="Arial"/>
               </a:defRPr>
             </a:pPr>
             <a:r>
@@ -4625,12 +5081,99 @@
                 <a:solidFill>
                   <a:srgbClr val="152B3A"/>
                 </a:solidFill>
+                <a:latin typeface="Arial"/>
+                <a:ea typeface="Arial"/>
+                <a:cs typeface="Arial"/>
               </a:rPr>
               <a:t>An internal backbone.</a:t>
             </a:r>
           </a:p>
         </p:txBody>
       </p:sp>
+      <p:sp>
+        <p:nvSpPr>
+          <p:cNvPr id="14" name="">
+            <a:extLst xmlns:a="http://schemas.openxmlformats.org/drawingml/2006/main">
+              <a:ext uri="{FF2B5EF4-FFF2-40B4-BE49-F238E27FC236}">
+                <a16:creationId xmlns:a16="http://schemas.microsoft.com/office/drawing/2014/main" id="{5D816F3A-BC46-494D-8495-9D0D4CF4CD12}"/>
+              </a:ext>
+            </a:extLst>
+          </p:cNvPr>
+          <p:cNvSpPr>
+            <a:spLocks xmlns:a="http://schemas.openxmlformats.org/drawingml/2006/main" noGrp="1"/>
+          </p:cNvSpPr>
+          <p:nvPr/>
+        </p:nvSpPr>
+        <p:spPr>
+          <a:xfrm xmlns:a="http://schemas.openxmlformats.org/drawingml/2006/main">
+            <a:off x="609600" y="2886075"/>
+            <a:ext cx="5048250" cy="0"/>
+          </a:xfrm>
+          <a:prstGeom xmlns:a="http://schemas.openxmlformats.org/drawingml/2006/main" prst="line">
+            <a:avLst/>
+          </a:prstGeom>
+          <a:noFill xmlns:a="http://schemas.openxmlformats.org/drawingml/2006/main"/>
+          <a:ln xmlns:a="http://schemas.openxmlformats.org/drawingml/2006/main" w="28575">
+            <a:solidFill>
+              <a:srgbClr val="DCE7DD"/>
+            </a:solidFill>
+            <a:prstDash val="solid"/>
+          </a:ln>
+        </p:spPr>
+      </p:sp>
+      <p:sp>
+        <p:nvSpPr>
+          <p:cNvPr id="15" name="">
+            <a:extLst xmlns:a="http://schemas.openxmlformats.org/drawingml/2006/main">
+              <a:ext uri="{FF2B5EF4-FFF2-40B4-BE49-F238E27FC236}">
+                <a16:creationId xmlns:a16="http://schemas.microsoft.com/office/drawing/2014/main" id="{6D160E14-555F-41F4-82EB-BCF5C95CD554}"/>
+              </a:ext>
+            </a:extLst>
+          </p:cNvPr>
+          <p:cNvSpPr>
+            <a:spLocks xmlns:a="http://schemas.openxmlformats.org/drawingml/2006/main" noGrp="1"/>
+          </p:cNvSpPr>
+          <p:nvPr/>
+        </p:nvSpPr>
+        <p:spPr>
+          <a:xfrm xmlns:a="http://schemas.openxmlformats.org/drawingml/2006/main">
+            <a:off x="6572250" y="2886075"/>
+            <a:ext cx="5010150" cy="0"/>
+          </a:xfrm>
+          <a:prstGeom xmlns:a="http://schemas.openxmlformats.org/drawingml/2006/main" prst="line">
+            <a:avLst/>
+          </a:prstGeom>
+          <a:noFill xmlns:a="http://schemas.openxmlformats.org/drawingml/2006/main"/>
+          <a:ln xmlns:a="http://schemas.openxmlformats.org/drawingml/2006/main" w="28575">
+            <a:solidFill>
+              <a:srgbClr val="DCE7DD"/>
+            </a:solidFill>
+            <a:prstDash val="solid"/>
+          </a:ln>
+        </p:spPr>
+      </p:sp>
+      <p:pic>
+        <p:nvPicPr>
+          <p:cNvPr id="30" name=""/>
+          <p:cNvPicPr>
+            <a:picLocks xmlns:a="http://schemas.openxmlformats.org/drawingml/2006/main" noChangeAspect="1"/>
+          </p:cNvPicPr>
+          <p:nvPr/>
+        </p:nvPicPr>
+        <p:blipFill>
+          <a:blip xmlns:r="http://schemas.openxmlformats.org/officeDocument/2006/relationships" xmlns:a="http://schemas.openxmlformats.org/drawingml/2006/main" r:embed="Rede0e157f0e442a7"/>
+          <a:stretch xmlns:a="http://schemas.openxmlformats.org/drawingml/2006/main"/>
+        </p:blipFill>
+        <p:spPr>
+          <a:xfrm xmlns:a="http://schemas.openxmlformats.org/drawingml/2006/main">
+            <a:off x="1841500" y="4381500"/>
+            <a:ext cx="2032000" cy="1524000"/>
+          </a:xfrm>
+          <a:prstGeom xmlns:a="http://schemas.openxmlformats.org/drawingml/2006/main" prst="rect">
+            <a:avLst/>
+          </a:prstGeom>
+        </p:spPr>
+      </p:pic>
     </p:spTree>
     <p:extLst>
       <p:ext uri="{BB962C8B-B14F-4D97-AF65-F5344CB8AC3E}">
@@ -4647,7 +5190,7 @@
     <p:bg>
       <p:bgPr>
         <a:solidFill xmlns:a="http://schemas.openxmlformats.org/drawingml/2006/main">
-          <a:srgbClr val="F5F1E8"/>
+          <a:srgbClr val="FBF9F3"/>
         </a:solidFill>
       </p:bgPr>
     </p:bg>
@@ -4676,8 +5219,8 @@
         </p:nvSpPr>
         <p:spPr>
           <a:xfrm xmlns:a="http://schemas.openxmlformats.org/drawingml/2006/main">
-            <a:off x="609600" y="552450"/>
-            <a:ext cx="781050" cy="57150"/>
+            <a:off x="609600" y="742950"/>
+            <a:ext cx="9906000" cy="38100"/>
           </a:xfrm>
           <a:prstGeom xmlns:a="http://schemas.openxmlformats.org/drawingml/2006/main" prst="rect">
             <a:avLst/>
@@ -4707,8 +5250,8 @@
         </p:nvSpPr>
         <p:spPr>
           <a:xfrm xmlns:a="http://schemas.openxmlformats.org/drawingml/2006/main">
-            <a:off x="609600" y="762000"/>
-            <a:ext cx="9334500" cy="285750"/>
+            <a:off x="609600" y="342900"/>
+            <a:ext cx="9334500" cy="266700"/>
           </a:xfrm>
           <a:prstGeom xmlns:a="http://schemas.openxmlformats.org/drawingml/2006/main" prst="rect">
             <a:avLst/>
@@ -4720,21 +5263,30 @@
           </a:ln>
         </p:spPr>
         <p:txBody>
-          <a:bodyPr xmlns:a="http://schemas.openxmlformats.org/drawingml/2006/main" lIns="0" tIns="0" rIns="0" bIns="0" anchor="ctr"/>
+          <a:bodyPr xmlns:a="http://schemas.openxmlformats.org/drawingml/2006/main" wrap="square" lIns="0" tIns="0" rIns="0" bIns="0" anchor="ctr">
+            <a:noAutofit/>
+          </a:bodyPr>
           <a:lstStyle xmlns:a="http://schemas.openxmlformats.org/drawingml/2006/main"/>
           <a:p xmlns:a="http://schemas.openxmlformats.org/drawingml/2006/main">
             <a:pPr>
-              <a:defRPr sz="1500" b="1">
+              <a:buNone/>
+              <a:defRPr sz="1425" b="1">
                 <a:solidFill>
                   <a:srgbClr val="28685E"/>
                 </a:solidFill>
+                <a:latin typeface="Arial"/>
+                <a:ea typeface="Arial"/>
+                <a:cs typeface="Arial"/>
               </a:defRPr>
             </a:pPr>
             <a:r>
-              <a:rPr sz="1500" b="1">
+              <a:rPr sz="1425" b="1">
                 <a:solidFill>
                   <a:srgbClr val="28685E"/>
                 </a:solidFill>
+                <a:latin typeface="Arial"/>
+                <a:ea typeface="Arial"/>
+                <a:cs typeface="Arial"/>
               </a:rPr>
               <a:t>MADE BY MATT  /  BUILD SCIENCE</a:t>
             </a:r>
@@ -4743,14 +5295,14 @@
       </p:sp>
       <p:pic>
         <p:nvPicPr>
-          <p:cNvPr id="14" name=""/>
+          <p:cNvPr id="20" name=""/>
           <p:cNvPicPr>
             <a:picLocks xmlns:a="http://schemas.openxmlformats.org/drawingml/2006/main" noChangeAspect="1"/>
           </p:cNvPicPr>
           <p:nvPr/>
         </p:nvPicPr>
         <p:blipFill>
-          <a:blip xmlns:r="http://schemas.openxmlformats.org/officeDocument/2006/relationships" xmlns:a="http://schemas.openxmlformats.org/drawingml/2006/main" r:embed="Re7aa2abf92504ae9"/>
+          <a:blip xmlns:r="http://schemas.openxmlformats.org/officeDocument/2006/relationships" xmlns:a="http://schemas.openxmlformats.org/drawingml/2006/main" r:embed="R046b213dfa284096"/>
           <a:stretch xmlns:a="http://schemas.openxmlformats.org/drawingml/2006/main"/>
         </p:blipFill>
         <p:spPr>
@@ -4779,8 +5331,8 @@
         </p:nvSpPr>
         <p:spPr>
           <a:xfrm xmlns:a="http://schemas.openxmlformats.org/drawingml/2006/main">
-            <a:off x="609600" y="1352550"/>
-            <a:ext cx="10972800" cy="952500"/>
+            <a:off x="609600" y="1047750"/>
+            <a:ext cx="10972800" cy="895350"/>
           </a:xfrm>
           <a:prstGeom xmlns:a="http://schemas.openxmlformats.org/drawingml/2006/main" prst="rect">
             <a:avLst/>
@@ -4792,21 +5344,30 @@
           </a:ln>
         </p:spPr>
         <p:txBody>
-          <a:bodyPr xmlns:a="http://schemas.openxmlformats.org/drawingml/2006/main" lIns="0" tIns="0" rIns="0" bIns="0" anchor="ctr"/>
+          <a:bodyPr xmlns:a="http://schemas.openxmlformats.org/drawingml/2006/main" wrap="square" lIns="0" tIns="0" rIns="0" bIns="0" anchor="ctr">
+            <a:noAutofit/>
+          </a:bodyPr>
           <a:lstStyle xmlns:a="http://schemas.openxmlformats.org/drawingml/2006/main"/>
           <a:p xmlns:a="http://schemas.openxmlformats.org/drawingml/2006/main">
             <a:pPr>
-              <a:defRPr sz="3750" b="1">
+              <a:buNone/>
+              <a:defRPr sz="3600" b="1">
                 <a:solidFill>
                   <a:srgbClr val="152B3A"/>
                 </a:solidFill>
+                <a:latin typeface="Arial"/>
+                <a:ea typeface="Arial"/>
+                <a:cs typeface="Arial"/>
               </a:defRPr>
             </a:pPr>
             <a:r>
-              <a:rPr sz="3750" b="1">
+              <a:rPr sz="3600" b="1">
                 <a:solidFill>
                   <a:srgbClr val="152B3A"/>
                 </a:solidFill>
+                <a:latin typeface="Arial"/>
+                <a:ea typeface="Arial"/>
+                <a:cs typeface="Arial"/>
               </a:rPr>
               <a:t>Beetle and earthworm: compare</a:t>
             </a:r>
@@ -4873,21 +5434,30 @@
           </a:ln>
         </p:spPr>
         <p:txBody>
-          <a:bodyPr xmlns:a="http://schemas.openxmlformats.org/drawingml/2006/main" lIns="0" tIns="0" rIns="0" bIns="0" anchor="ctr"/>
+          <a:bodyPr xmlns:a="http://schemas.openxmlformats.org/drawingml/2006/main" wrap="square" lIns="0" tIns="0" rIns="0" bIns="0" anchor="ctr">
+            <a:noAutofit/>
+          </a:bodyPr>
           <a:lstStyle xmlns:a="http://schemas.openxmlformats.org/drawingml/2006/main"/>
           <a:p xmlns:a="http://schemas.openxmlformats.org/drawingml/2006/main">
             <a:pPr>
-              <a:defRPr sz="1275" b="0">
+              <a:buNone/>
+              <a:defRPr sz="1200" b="0">
                 <a:solidFill>
                   <a:srgbClr val="50616B"/>
                 </a:solidFill>
+                <a:latin typeface="Arial"/>
+                <a:ea typeface="Arial"/>
+                <a:cs typeface="Arial"/>
               </a:defRPr>
             </a:pPr>
             <a:r>
-              <a:rPr sz="1275" b="0">
+              <a:rPr sz="1200" b="0">
                 <a:solidFill>
                   <a:srgbClr val="50616B"/>
                 </a:solidFill>
+                <a:latin typeface="Arial"/>
+                <a:ea typeface="Arial"/>
+                <a:cs typeface="Arial"/>
               </a:rPr>
               <a:t>AUTUMN 1  ·  WEEK 3  ·  LESSON B</a:t>
             </a:r>
@@ -4923,14 +5493,20 @@
           </a:ln>
         </p:spPr>
         <p:txBody>
-          <a:bodyPr xmlns:a="http://schemas.openxmlformats.org/drawingml/2006/main" lIns="0" tIns="0" rIns="0" bIns="0" anchor="ctr"/>
+          <a:bodyPr xmlns:a="http://schemas.openxmlformats.org/drawingml/2006/main" wrap="square" lIns="0" tIns="0" rIns="0" bIns="0" anchor="ctr">
+            <a:noAutofit/>
+          </a:bodyPr>
           <a:lstStyle xmlns:a="http://schemas.openxmlformats.org/drawingml/2006/main"/>
           <a:p xmlns:a="http://schemas.openxmlformats.org/drawingml/2006/main">
             <a:pPr>
+              <a:buNone/>
               <a:defRPr sz="1350" b="1">
                 <a:solidFill>
                   <a:srgbClr val="28685E"/>
                 </a:solidFill>
+                <a:latin typeface="Arial"/>
+                <a:ea typeface="Arial"/>
+                <a:cs typeface="Arial"/>
               </a:defRPr>
             </a:pPr>
             <a:r>
@@ -4938,6 +5514,9 @@
                 <a:solidFill>
                   <a:srgbClr val="28685E"/>
                 </a:solidFill>
+                <a:latin typeface="Arial"/>
+                <a:ea typeface="Arial"/>
+                <a:cs typeface="Arial"/>
               </a:rPr>
               <a:t>04</a:t>
             </a:r>
@@ -4960,8 +5539,8 @@
         </p:nvSpPr>
         <p:spPr>
           <a:xfrm xmlns:a="http://schemas.openxmlformats.org/drawingml/2006/main">
-            <a:off x="609600" y="2619375"/>
-            <a:ext cx="4953000" cy="428625"/>
+            <a:off x="609600" y="2257425"/>
+            <a:ext cx="5143500" cy="533400"/>
           </a:xfrm>
           <a:prstGeom xmlns:a="http://schemas.openxmlformats.org/drawingml/2006/main" prst="rect">
             <a:avLst/>
@@ -4973,21 +5552,30 @@
           </a:ln>
         </p:spPr>
         <p:txBody>
-          <a:bodyPr xmlns:a="http://schemas.openxmlformats.org/drawingml/2006/main" lIns="0" tIns="0" rIns="0" bIns="0" anchor="ctr"/>
+          <a:bodyPr xmlns:a="http://schemas.openxmlformats.org/drawingml/2006/main" wrap="square" lIns="0" tIns="0" rIns="0" bIns="0" anchor="ctr">
+            <a:noAutofit/>
+          </a:bodyPr>
           <a:lstStyle xmlns:a="http://schemas.openxmlformats.org/drawingml/2006/main"/>
           <a:p xmlns:a="http://schemas.openxmlformats.org/drawingml/2006/main">
             <a:pPr>
-              <a:defRPr sz="2025" b="1">
+              <a:buNone/>
+              <a:defRPr sz="2100" b="1">
                 <a:solidFill>
                   <a:srgbClr val="28685E"/>
                 </a:solidFill>
+                <a:latin typeface="Arial"/>
+                <a:ea typeface="Arial"/>
+                <a:cs typeface="Arial"/>
               </a:defRPr>
             </a:pPr>
             <a:r>
-              <a:rPr sz="2025" b="1">
+              <a:rPr sz="2100" b="1">
                 <a:solidFill>
                   <a:srgbClr val="28685E"/>
                 </a:solidFill>
+                <a:latin typeface="Arial"/>
+                <a:ea typeface="Arial"/>
+                <a:cs typeface="Arial"/>
               </a:rPr>
               <a:t>BEETLE</a:t>
             </a:r>
@@ -5010,8 +5598,8 @@
         </p:nvSpPr>
         <p:spPr>
           <a:xfrm xmlns:a="http://schemas.openxmlformats.org/drawingml/2006/main">
-            <a:off x="6572250" y="2619375"/>
-            <a:ext cx="4953000" cy="428625"/>
+            <a:off x="6572250" y="2257425"/>
+            <a:ext cx="5010150" cy="533400"/>
           </a:xfrm>
           <a:prstGeom xmlns:a="http://schemas.openxmlformats.org/drawingml/2006/main" prst="rect">
             <a:avLst/>
@@ -5023,21 +5611,30 @@
           </a:ln>
         </p:spPr>
         <p:txBody>
-          <a:bodyPr xmlns:a="http://schemas.openxmlformats.org/drawingml/2006/main" lIns="0" tIns="0" rIns="0" bIns="0" anchor="ctr"/>
+          <a:bodyPr xmlns:a="http://schemas.openxmlformats.org/drawingml/2006/main" wrap="square" lIns="0" tIns="0" rIns="0" bIns="0" anchor="ctr">
+            <a:noAutofit/>
+          </a:bodyPr>
           <a:lstStyle xmlns:a="http://schemas.openxmlformats.org/drawingml/2006/main"/>
           <a:p xmlns:a="http://schemas.openxmlformats.org/drawingml/2006/main">
             <a:pPr>
-              <a:defRPr sz="2025" b="1">
+              <a:buNone/>
+              <a:defRPr sz="2100" b="1">
                 <a:solidFill>
                   <a:srgbClr val="A65D25"/>
                 </a:solidFill>
+                <a:latin typeface="Arial"/>
+                <a:ea typeface="Arial"/>
+                <a:cs typeface="Arial"/>
               </a:defRPr>
             </a:pPr>
             <a:r>
-              <a:rPr sz="2025" b="1">
+              <a:rPr sz="2100" b="1">
                 <a:solidFill>
                   <a:srgbClr val="A65D25"/>
                 </a:solidFill>
+                <a:latin typeface="Arial"/>
+                <a:ea typeface="Arial"/>
+                <a:cs typeface="Arial"/>
               </a:rPr>
               <a:t>EARTHWORM</a:t>
             </a:r>
@@ -5060,8 +5657,8 @@
         </p:nvSpPr>
         <p:spPr>
           <a:xfrm xmlns:a="http://schemas.openxmlformats.org/drawingml/2006/main">
-            <a:off x="609600" y="3333750"/>
-            <a:ext cx="4953000" cy="2524125"/>
+            <a:off x="609600" y="4381500"/>
+            <a:ext cx="5143500" cy="1571625"/>
           </a:xfrm>
           <a:prstGeom xmlns:a="http://schemas.openxmlformats.org/drawingml/2006/main" prst="rect">
             <a:avLst/>
@@ -5073,14 +5670,20 @@
           </a:ln>
         </p:spPr>
         <p:txBody>
-          <a:bodyPr xmlns:a="http://schemas.openxmlformats.org/drawingml/2006/main" lIns="0" tIns="0" rIns="0" bIns="0" anchor="ctr"/>
+          <a:bodyPr xmlns:a="http://schemas.openxmlformats.org/drawingml/2006/main" wrap="square" lIns="0" tIns="0" rIns="0" bIns="0" anchor="ctr">
+            <a:noAutofit/>
+          </a:bodyPr>
           <a:lstStyle xmlns:a="http://schemas.openxmlformats.org/drawingml/2006/main"/>
           <a:p xmlns:a="http://schemas.openxmlformats.org/drawingml/2006/main">
             <a:pPr>
+              <a:buNone/>
               <a:defRPr sz="2400" b="0">
                 <a:solidFill>
                   <a:srgbClr val="152B3A"/>
                 </a:solidFill>
+                <a:latin typeface="Arial"/>
+                <a:ea typeface="Arial"/>
+                <a:cs typeface="Arial"/>
               </a:defRPr>
             </a:pPr>
             <a:r>
@@ -5088,16 +5691,23 @@
                 <a:solidFill>
                   <a:srgbClr val="152B3A"/>
                 </a:solidFill>
+                <a:latin typeface="Arial"/>
+                <a:ea typeface="Arial"/>
+                <a:cs typeface="Arial"/>
               </a:rPr>
               <a:t>Hard outer case.</a:t>
             </a:r>
           </a:p>
           <a:p xmlns:a="http://schemas.openxmlformats.org/drawingml/2006/main">
             <a:pPr>
+              <a:buNone/>
               <a:defRPr sz="2400" b="0">
                 <a:solidFill>
                   <a:srgbClr val="152B3A"/>
                 </a:solidFill>
+                <a:latin typeface="Arial"/>
+                <a:ea typeface="Arial"/>
+                <a:cs typeface="Arial"/>
               </a:defRPr>
             </a:pPr>
             <a:r>
@@ -5105,6 +5715,9 @@
                 <a:solidFill>
                   <a:srgbClr val="152B3A"/>
                 </a:solidFill>
+                <a:latin typeface="Arial"/>
+                <a:ea typeface="Arial"/>
+                <a:cs typeface="Arial"/>
               </a:rPr>
               <a:t>No internal backbone.</a:t>
             </a:r>
@@ -5127,8 +5740,8 @@
         </p:nvSpPr>
         <p:spPr>
           <a:xfrm xmlns:a="http://schemas.openxmlformats.org/drawingml/2006/main">
-            <a:off x="6572250" y="3333750"/>
-            <a:ext cx="4857750" cy="2524125"/>
+            <a:off x="6572250" y="4381500"/>
+            <a:ext cx="5010150" cy="1571625"/>
           </a:xfrm>
           <a:prstGeom xmlns:a="http://schemas.openxmlformats.org/drawingml/2006/main" prst="rect">
             <a:avLst/>
@@ -5140,14 +5753,20 @@
           </a:ln>
         </p:spPr>
         <p:txBody>
-          <a:bodyPr xmlns:a="http://schemas.openxmlformats.org/drawingml/2006/main" lIns="0" tIns="0" rIns="0" bIns="0" anchor="ctr"/>
+          <a:bodyPr xmlns:a="http://schemas.openxmlformats.org/drawingml/2006/main" wrap="square" lIns="0" tIns="0" rIns="0" bIns="0" anchor="ctr">
+            <a:noAutofit/>
+          </a:bodyPr>
           <a:lstStyle xmlns:a="http://schemas.openxmlformats.org/drawingml/2006/main"/>
           <a:p xmlns:a="http://schemas.openxmlformats.org/drawingml/2006/main">
             <a:pPr>
+              <a:buNone/>
               <a:defRPr sz="2400" b="0">
                 <a:solidFill>
                   <a:srgbClr val="152B3A"/>
                 </a:solidFill>
+                <a:latin typeface="Arial"/>
+                <a:ea typeface="Arial"/>
+                <a:cs typeface="Arial"/>
               </a:defRPr>
             </a:pPr>
             <a:r>
@@ -5155,16 +5774,23 @@
                 <a:solidFill>
                   <a:srgbClr val="152B3A"/>
                 </a:solidFill>
+                <a:latin typeface="Arial"/>
+                <a:ea typeface="Arial"/>
+                <a:cs typeface="Arial"/>
               </a:rPr>
               <a:t>Muscles act against fluid inside.</a:t>
             </a:r>
           </a:p>
           <a:p xmlns:a="http://schemas.openxmlformats.org/drawingml/2006/main">
             <a:pPr>
+              <a:buNone/>
               <a:defRPr sz="2400" b="0">
                 <a:solidFill>
                   <a:srgbClr val="152B3A"/>
                 </a:solidFill>
+                <a:latin typeface="Arial"/>
+                <a:ea typeface="Arial"/>
+                <a:cs typeface="Arial"/>
               </a:defRPr>
             </a:pPr>
             <a:r>
@@ -5172,12 +5798,121 @@
                 <a:solidFill>
                   <a:srgbClr val="152B3A"/>
                 </a:solidFill>
+                <a:latin typeface="Arial"/>
+                <a:ea typeface="Arial"/>
+                <a:cs typeface="Arial"/>
               </a:rPr>
               <a:t>Skin rings are not bones.</a:t>
             </a:r>
           </a:p>
         </p:txBody>
       </p:sp>
+      <p:sp>
+        <p:nvSpPr>
+          <p:cNvPr id="14" name="">
+            <a:extLst xmlns:a="http://schemas.openxmlformats.org/drawingml/2006/main">
+              <a:ext uri="{FF2B5EF4-FFF2-40B4-BE49-F238E27FC236}">
+                <a16:creationId xmlns:a16="http://schemas.microsoft.com/office/drawing/2014/main" id="{A8EEAC50-1A20-406F-939E-677896B9CC98}"/>
+              </a:ext>
+            </a:extLst>
+          </p:cNvPr>
+          <p:cNvSpPr>
+            <a:spLocks xmlns:a="http://schemas.openxmlformats.org/drawingml/2006/main" noGrp="1"/>
+          </p:cNvSpPr>
+          <p:nvPr/>
+        </p:nvSpPr>
+        <p:spPr>
+          <a:xfrm xmlns:a="http://schemas.openxmlformats.org/drawingml/2006/main">
+            <a:off x="609600" y="2886075"/>
+            <a:ext cx="5048250" cy="0"/>
+          </a:xfrm>
+          <a:prstGeom xmlns:a="http://schemas.openxmlformats.org/drawingml/2006/main" prst="line">
+            <a:avLst/>
+          </a:prstGeom>
+          <a:noFill xmlns:a="http://schemas.openxmlformats.org/drawingml/2006/main"/>
+          <a:ln xmlns:a="http://schemas.openxmlformats.org/drawingml/2006/main" w="28575">
+            <a:solidFill>
+              <a:srgbClr val="DCE7DD"/>
+            </a:solidFill>
+            <a:prstDash val="solid"/>
+          </a:ln>
+        </p:spPr>
+      </p:sp>
+      <p:sp>
+        <p:nvSpPr>
+          <p:cNvPr id="15" name="">
+            <a:extLst xmlns:a="http://schemas.openxmlformats.org/drawingml/2006/main">
+              <a:ext uri="{FF2B5EF4-FFF2-40B4-BE49-F238E27FC236}">
+                <a16:creationId xmlns:a16="http://schemas.microsoft.com/office/drawing/2014/main" id="{501D3090-6D72-4EEA-8AA7-7AF624EDF1D2}"/>
+              </a:ext>
+            </a:extLst>
+          </p:cNvPr>
+          <p:cNvSpPr>
+            <a:spLocks xmlns:a="http://schemas.openxmlformats.org/drawingml/2006/main" noGrp="1"/>
+          </p:cNvSpPr>
+          <p:nvPr/>
+        </p:nvSpPr>
+        <p:spPr>
+          <a:xfrm xmlns:a="http://schemas.openxmlformats.org/drawingml/2006/main">
+            <a:off x="6572250" y="2886075"/>
+            <a:ext cx="5010150" cy="0"/>
+          </a:xfrm>
+          <a:prstGeom xmlns:a="http://schemas.openxmlformats.org/drawingml/2006/main" prst="line">
+            <a:avLst/>
+          </a:prstGeom>
+          <a:noFill xmlns:a="http://schemas.openxmlformats.org/drawingml/2006/main"/>
+          <a:ln xmlns:a="http://schemas.openxmlformats.org/drawingml/2006/main" w="28575">
+            <a:solidFill>
+              <a:srgbClr val="DCE7DD"/>
+            </a:solidFill>
+            <a:prstDash val="solid"/>
+          </a:ln>
+        </p:spPr>
+      </p:sp>
+      <p:pic>
+        <p:nvPicPr>
+          <p:cNvPr id="31" name=""/>
+          <p:cNvPicPr>
+            <a:picLocks xmlns:a="http://schemas.openxmlformats.org/drawingml/2006/main" noChangeAspect="1"/>
+          </p:cNvPicPr>
+          <p:nvPr/>
+        </p:nvPicPr>
+        <p:blipFill>
+          <a:blip xmlns:r="http://schemas.openxmlformats.org/officeDocument/2006/relationships" xmlns:a="http://schemas.openxmlformats.org/drawingml/2006/main" r:embed="R1dc3a8f3b4fa4dcc"/>
+          <a:stretch xmlns:a="http://schemas.openxmlformats.org/drawingml/2006/main"/>
+        </p:blipFill>
+        <p:spPr>
+          <a:xfrm xmlns:a="http://schemas.openxmlformats.org/drawingml/2006/main">
+            <a:off x="2109788" y="2952750"/>
+            <a:ext cx="1905000" cy="1428750"/>
+          </a:xfrm>
+          <a:prstGeom xmlns:a="http://schemas.openxmlformats.org/drawingml/2006/main" prst="rect">
+            <a:avLst/>
+          </a:prstGeom>
+        </p:spPr>
+      </p:pic>
+      <p:pic>
+        <p:nvPicPr>
+          <p:cNvPr id="32" name=""/>
+          <p:cNvPicPr>
+            <a:picLocks xmlns:a="http://schemas.openxmlformats.org/drawingml/2006/main" noChangeAspect="1"/>
+          </p:cNvPicPr>
+          <p:nvPr/>
+        </p:nvPicPr>
+        <p:blipFill>
+          <a:blip xmlns:r="http://schemas.openxmlformats.org/officeDocument/2006/relationships" xmlns:a="http://schemas.openxmlformats.org/drawingml/2006/main" r:embed="R9c9694967bfc4a32"/>
+          <a:stretch xmlns:a="http://schemas.openxmlformats.org/drawingml/2006/main"/>
+        </p:blipFill>
+        <p:spPr>
+          <a:xfrm xmlns:a="http://schemas.openxmlformats.org/drawingml/2006/main">
+            <a:off x="8072438" y="2952750"/>
+            <a:ext cx="1905000" cy="1428750"/>
+          </a:xfrm>
+          <a:prstGeom xmlns:a="http://schemas.openxmlformats.org/drawingml/2006/main" prst="rect">
+            <a:avLst/>
+          </a:prstGeom>
+        </p:spPr>
+      </p:pic>
     </p:spTree>
     <p:extLst>
       <p:ext uri="{BB962C8B-B14F-4D97-AF65-F5344CB8AC3E}">
@@ -5194,7 +5929,7 @@
     <p:bg>
       <p:bgPr>
         <a:solidFill xmlns:a="http://schemas.openxmlformats.org/drawingml/2006/main">
-          <a:srgbClr val="F5F1E8"/>
+          <a:srgbClr val="FBF9F3"/>
         </a:solidFill>
       </p:bgPr>
     </p:bg>
@@ -5223,8 +5958,8 @@
         </p:nvSpPr>
         <p:spPr>
           <a:xfrm xmlns:a="http://schemas.openxmlformats.org/drawingml/2006/main">
-            <a:off x="609600" y="552450"/>
-            <a:ext cx="781050" cy="57150"/>
+            <a:off x="609600" y="742950"/>
+            <a:ext cx="9906000" cy="38100"/>
           </a:xfrm>
           <a:prstGeom xmlns:a="http://schemas.openxmlformats.org/drawingml/2006/main" prst="rect">
             <a:avLst/>
@@ -5254,8 +5989,8 @@
         </p:nvSpPr>
         <p:spPr>
           <a:xfrm xmlns:a="http://schemas.openxmlformats.org/drawingml/2006/main">
-            <a:off x="609600" y="762000"/>
-            <a:ext cx="9334500" cy="285750"/>
+            <a:off x="609600" y="342900"/>
+            <a:ext cx="9334500" cy="266700"/>
           </a:xfrm>
           <a:prstGeom xmlns:a="http://schemas.openxmlformats.org/drawingml/2006/main" prst="rect">
             <a:avLst/>
@@ -5267,21 +6002,30 @@
           </a:ln>
         </p:spPr>
         <p:txBody>
-          <a:bodyPr xmlns:a="http://schemas.openxmlformats.org/drawingml/2006/main" lIns="0" tIns="0" rIns="0" bIns="0" anchor="ctr"/>
+          <a:bodyPr xmlns:a="http://schemas.openxmlformats.org/drawingml/2006/main" wrap="square" lIns="0" tIns="0" rIns="0" bIns="0" anchor="ctr">
+            <a:noAutofit/>
+          </a:bodyPr>
           <a:lstStyle xmlns:a="http://schemas.openxmlformats.org/drawingml/2006/main"/>
           <a:p xmlns:a="http://schemas.openxmlformats.org/drawingml/2006/main">
             <a:pPr>
-              <a:defRPr sz="1500" b="1">
+              <a:buNone/>
+              <a:defRPr sz="1425" b="1">
                 <a:solidFill>
                   <a:srgbClr val="28685E"/>
                 </a:solidFill>
+                <a:latin typeface="Arial"/>
+                <a:ea typeface="Arial"/>
+                <a:cs typeface="Arial"/>
               </a:defRPr>
             </a:pPr>
             <a:r>
-              <a:rPr sz="1500" b="1">
+              <a:rPr sz="1425" b="1">
                 <a:solidFill>
                   <a:srgbClr val="28685E"/>
                 </a:solidFill>
+                <a:latin typeface="Arial"/>
+                <a:ea typeface="Arial"/>
+                <a:cs typeface="Arial"/>
               </a:rPr>
               <a:t>MADE BY MATT  /  BUILD SCIENCE</a:t>
             </a:r>
@@ -5290,14 +6034,14 @@
       </p:sp>
       <p:pic>
         <p:nvPicPr>
-          <p:cNvPr id="14" name=""/>
+          <p:cNvPr id="16" name=""/>
           <p:cNvPicPr>
             <a:picLocks xmlns:a="http://schemas.openxmlformats.org/drawingml/2006/main" noChangeAspect="1"/>
           </p:cNvPicPr>
           <p:nvPr/>
         </p:nvPicPr>
         <p:blipFill>
-          <a:blip xmlns:r="http://schemas.openxmlformats.org/officeDocument/2006/relationships" xmlns:a="http://schemas.openxmlformats.org/drawingml/2006/main" r:embed="R8f8f6051bbea4b36"/>
+          <a:blip xmlns:r="http://schemas.openxmlformats.org/officeDocument/2006/relationships" xmlns:a="http://schemas.openxmlformats.org/drawingml/2006/main" r:embed="R2c4f2f6a2e504c78"/>
           <a:stretch xmlns:a="http://schemas.openxmlformats.org/drawingml/2006/main"/>
         </p:blipFill>
         <p:spPr>
@@ -5326,8 +6070,8 @@
         </p:nvSpPr>
         <p:spPr>
           <a:xfrm xmlns:a="http://schemas.openxmlformats.org/drawingml/2006/main">
-            <a:off x="609600" y="1352550"/>
-            <a:ext cx="10972800" cy="952500"/>
+            <a:off x="609600" y="1047750"/>
+            <a:ext cx="10972800" cy="895350"/>
           </a:xfrm>
           <a:prstGeom xmlns:a="http://schemas.openxmlformats.org/drawingml/2006/main" prst="rect">
             <a:avLst/>
@@ -5339,21 +6083,30 @@
           </a:ln>
         </p:spPr>
         <p:txBody>
-          <a:bodyPr xmlns:a="http://schemas.openxmlformats.org/drawingml/2006/main" lIns="0" tIns="0" rIns="0" bIns="0" anchor="ctr"/>
+          <a:bodyPr xmlns:a="http://schemas.openxmlformats.org/drawingml/2006/main" wrap="square" lIns="0" tIns="0" rIns="0" bIns="0" anchor="ctr">
+            <a:noAutofit/>
+          </a:bodyPr>
           <a:lstStyle xmlns:a="http://schemas.openxmlformats.org/drawingml/2006/main"/>
           <a:p xmlns:a="http://schemas.openxmlformats.org/drawingml/2006/main">
             <a:pPr>
-              <a:defRPr sz="3750" b="1">
+              <a:buNone/>
+              <a:defRPr sz="3600" b="1">
                 <a:solidFill>
                   <a:srgbClr val="152B3A"/>
                 </a:solidFill>
+                <a:latin typeface="Arial"/>
+                <a:ea typeface="Arial"/>
+                <a:cs typeface="Arial"/>
               </a:defRPr>
             </a:pPr>
             <a:r>
-              <a:rPr sz="3750" b="1">
+              <a:rPr sz="3600" b="1">
                 <a:solidFill>
                   <a:srgbClr val="152B3A"/>
                 </a:solidFill>
+                <a:latin typeface="Arial"/>
+                <a:ea typeface="Arial"/>
+                <a:cs typeface="Arial"/>
               </a:rPr>
               <a:t>Make a two-clue mystery card</a:t>
             </a:r>
@@ -5420,21 +6173,30 @@
           </a:ln>
         </p:spPr>
         <p:txBody>
-          <a:bodyPr xmlns:a="http://schemas.openxmlformats.org/drawingml/2006/main" lIns="0" tIns="0" rIns="0" bIns="0" anchor="ctr"/>
+          <a:bodyPr xmlns:a="http://schemas.openxmlformats.org/drawingml/2006/main" wrap="square" lIns="0" tIns="0" rIns="0" bIns="0" anchor="ctr">
+            <a:noAutofit/>
+          </a:bodyPr>
           <a:lstStyle xmlns:a="http://schemas.openxmlformats.org/drawingml/2006/main"/>
           <a:p xmlns:a="http://schemas.openxmlformats.org/drawingml/2006/main">
             <a:pPr>
-              <a:defRPr sz="1275" b="0">
+              <a:buNone/>
+              <a:defRPr sz="1200" b="0">
                 <a:solidFill>
                   <a:srgbClr val="50616B"/>
                 </a:solidFill>
+                <a:latin typeface="Arial"/>
+                <a:ea typeface="Arial"/>
+                <a:cs typeface="Arial"/>
               </a:defRPr>
             </a:pPr>
             <a:r>
-              <a:rPr sz="1275" b="0">
+              <a:rPr sz="1200" b="0">
                 <a:solidFill>
                   <a:srgbClr val="50616B"/>
                 </a:solidFill>
+                <a:latin typeface="Arial"/>
+                <a:ea typeface="Arial"/>
+                <a:cs typeface="Arial"/>
               </a:rPr>
               <a:t>AUTUMN 1  ·  WEEK 3  ·  LESSON B</a:t>
             </a:r>
@@ -5470,14 +6232,20 @@
           </a:ln>
         </p:spPr>
         <p:txBody>
-          <a:bodyPr xmlns:a="http://schemas.openxmlformats.org/drawingml/2006/main" lIns="0" tIns="0" rIns="0" bIns="0" anchor="ctr"/>
+          <a:bodyPr xmlns:a="http://schemas.openxmlformats.org/drawingml/2006/main" wrap="square" lIns="0" tIns="0" rIns="0" bIns="0" anchor="ctr">
+            <a:noAutofit/>
+          </a:bodyPr>
           <a:lstStyle xmlns:a="http://schemas.openxmlformats.org/drawingml/2006/main"/>
           <a:p xmlns:a="http://schemas.openxmlformats.org/drawingml/2006/main">
             <a:pPr>
+              <a:buNone/>
               <a:defRPr sz="1350" b="1">
                 <a:solidFill>
                   <a:srgbClr val="28685E"/>
                 </a:solidFill>
+                <a:latin typeface="Arial"/>
+                <a:ea typeface="Arial"/>
+                <a:cs typeface="Arial"/>
               </a:defRPr>
             </a:pPr>
             <a:r>
@@ -5485,6 +6253,9 @@
                 <a:solidFill>
                   <a:srgbClr val="28685E"/>
                 </a:solidFill>
+                <a:latin typeface="Arial"/>
+                <a:ea typeface="Arial"/>
+                <a:cs typeface="Arial"/>
               </a:rPr>
               <a:t>05</a:t>
             </a:r>
@@ -5507,8 +6278,8 @@
         </p:nvSpPr>
         <p:spPr>
           <a:xfrm xmlns:a="http://schemas.openxmlformats.org/drawingml/2006/main">
-            <a:off x="609600" y="2619375"/>
-            <a:ext cx="10972800" cy="714375"/>
+            <a:off x="609600" y="2305050"/>
+            <a:ext cx="10972800" cy="704850"/>
           </a:xfrm>
           <a:prstGeom xmlns:a="http://schemas.openxmlformats.org/drawingml/2006/main" prst="rect">
             <a:avLst/>
@@ -5520,14 +6291,20 @@
           </a:ln>
         </p:spPr>
         <p:txBody>
-          <a:bodyPr xmlns:a="http://schemas.openxmlformats.org/drawingml/2006/main" lIns="0" tIns="0" rIns="0" bIns="0" anchor="ctr"/>
+          <a:bodyPr xmlns:a="http://schemas.openxmlformats.org/drawingml/2006/main" wrap="square" lIns="0" tIns="0" rIns="0" bIns="0" anchor="ctr">
+            <a:noAutofit/>
+          </a:bodyPr>
           <a:lstStyle xmlns:a="http://schemas.openxmlformats.org/drawingml/2006/main"/>
           <a:p xmlns:a="http://schemas.openxmlformats.org/drawingml/2006/main">
             <a:pPr>
+              <a:buNone/>
               <a:defRPr sz="2550" b="0">
                 <a:solidFill>
                   <a:srgbClr val="152B3A"/>
                 </a:solidFill>
+                <a:latin typeface="Arial"/>
+                <a:ea typeface="Arial"/>
+                <a:cs typeface="Arial"/>
               </a:defRPr>
             </a:pPr>
             <a:r>
@@ -5535,6 +6312,9 @@
                 <a:solidFill>
                   <a:srgbClr val="152B3A"/>
                 </a:solidFill>
+                <a:latin typeface="Arial"/>
+                <a:ea typeface="Arial"/>
+                <a:cs typeface="Arial"/>
               </a:rPr>
               <a:t>Choose one animal from Monday.</a:t>
             </a:r>
@@ -5557,8 +6337,8 @@
         </p:nvSpPr>
         <p:spPr>
           <a:xfrm xmlns:a="http://schemas.openxmlformats.org/drawingml/2006/main">
-            <a:off x="609600" y="3409950"/>
-            <a:ext cx="10972800" cy="714375"/>
+            <a:off x="609600" y="3143250"/>
+            <a:ext cx="10972800" cy="704850"/>
           </a:xfrm>
           <a:prstGeom xmlns:a="http://schemas.openxmlformats.org/drawingml/2006/main" prst="rect">
             <a:avLst/>
@@ -5570,14 +6350,20 @@
           </a:ln>
         </p:spPr>
         <p:txBody>
-          <a:bodyPr xmlns:a="http://schemas.openxmlformats.org/drawingml/2006/main" lIns="0" tIns="0" rIns="0" bIns="0" anchor="ctr"/>
+          <a:bodyPr xmlns:a="http://schemas.openxmlformats.org/drawingml/2006/main" wrap="square" lIns="0" tIns="0" rIns="0" bIns="0" anchor="ctr">
+            <a:noAutofit/>
+          </a:bodyPr>
           <a:lstStyle xmlns:a="http://schemas.openxmlformats.org/drawingml/2006/main"/>
           <a:p xmlns:a="http://schemas.openxmlformats.org/drawingml/2006/main">
             <a:pPr>
+              <a:buNone/>
               <a:defRPr sz="2550" b="0">
                 <a:solidFill>
                   <a:srgbClr val="152B3A"/>
                 </a:solidFill>
+                <a:latin typeface="Arial"/>
+                <a:ea typeface="Arial"/>
+                <a:cs typeface="Arial"/>
               </a:defRPr>
             </a:pPr>
             <a:r>
@@ -5585,6 +6371,9 @@
                 <a:solidFill>
                   <a:srgbClr val="152B3A"/>
                 </a:solidFill>
+                <a:latin typeface="Arial"/>
+                <a:ea typeface="Arial"/>
+                <a:cs typeface="Arial"/>
               </a:rPr>
               <a:t>Hide its name.</a:t>
             </a:r>
@@ -5607,8 +6396,8 @@
         </p:nvSpPr>
         <p:spPr>
           <a:xfrm xmlns:a="http://schemas.openxmlformats.org/drawingml/2006/main">
-            <a:off x="609600" y="4200525"/>
-            <a:ext cx="10972800" cy="714375"/>
+            <a:off x="609600" y="3981450"/>
+            <a:ext cx="10972800" cy="704850"/>
           </a:xfrm>
           <a:prstGeom xmlns:a="http://schemas.openxmlformats.org/drawingml/2006/main" prst="rect">
             <a:avLst/>
@@ -5620,14 +6409,20 @@
           </a:ln>
         </p:spPr>
         <p:txBody>
-          <a:bodyPr xmlns:a="http://schemas.openxmlformats.org/drawingml/2006/main" lIns="0" tIns="0" rIns="0" bIns="0" anchor="ctr"/>
+          <a:bodyPr xmlns:a="http://schemas.openxmlformats.org/drawingml/2006/main" wrap="square" lIns="0" tIns="0" rIns="0" bIns="0" anchor="ctr">
+            <a:noAutofit/>
+          </a:bodyPr>
           <a:lstStyle xmlns:a="http://schemas.openxmlformats.org/drawingml/2006/main"/>
           <a:p xmlns:a="http://schemas.openxmlformats.org/drawingml/2006/main">
             <a:pPr>
+              <a:buNone/>
               <a:defRPr sz="2550" b="0">
                 <a:solidFill>
                   <a:srgbClr val="152B3A"/>
                 </a:solidFill>
+                <a:latin typeface="Arial"/>
+                <a:ea typeface="Arial"/>
+                <a:cs typeface="Arial"/>
               </a:defRPr>
             </a:pPr>
             <a:r>
@@ -5635,6 +6430,9 @@
                 <a:solidFill>
                   <a:srgbClr val="152B3A"/>
                 </a:solidFill>
+                <a:latin typeface="Arial"/>
+                <a:ea typeface="Arial"/>
+                <a:cs typeface="Arial"/>
               </a:rPr>
               <a:t>Write or dictate two true body clues.</a:t>
             </a:r>
@@ -5657,8 +6455,8 @@
         </p:nvSpPr>
         <p:spPr>
           <a:xfrm xmlns:a="http://schemas.openxmlformats.org/drawingml/2006/main">
-            <a:off x="609600" y="4991100"/>
-            <a:ext cx="10972800" cy="714375"/>
+            <a:off x="609600" y="4819650"/>
+            <a:ext cx="10972800" cy="704850"/>
           </a:xfrm>
           <a:prstGeom xmlns:a="http://schemas.openxmlformats.org/drawingml/2006/main" prst="rect">
             <a:avLst/>
@@ -5670,21 +6468,30 @@
           </a:ln>
         </p:spPr>
         <p:txBody>
-          <a:bodyPr xmlns:a="http://schemas.openxmlformats.org/drawingml/2006/main" lIns="0" tIns="0" rIns="0" bIns="0" anchor="ctr"/>
+          <a:bodyPr xmlns:a="http://schemas.openxmlformats.org/drawingml/2006/main" wrap="square" lIns="0" tIns="0" rIns="0" bIns="0" anchor="ctr">
+            <a:noAutofit/>
+          </a:bodyPr>
           <a:lstStyle xmlns:a="http://schemas.openxmlformats.org/drawingml/2006/main"/>
           <a:p xmlns:a="http://schemas.openxmlformats.org/drawingml/2006/main">
             <a:pPr>
-              <a:defRPr sz="2550" b="0">
-                <a:solidFill>
-                  <a:srgbClr val="152B3A"/>
-                </a:solidFill>
+              <a:buNone/>
+              <a:defRPr sz="2550" b="1">
+                <a:solidFill>
+                  <a:srgbClr val="28685E"/>
+                </a:solidFill>
+                <a:latin typeface="Arial"/>
+                <a:ea typeface="Arial"/>
+                <a:cs typeface="Arial"/>
               </a:defRPr>
             </a:pPr>
             <a:r>
-              <a:rPr sz="2550" b="0">
-                <a:solidFill>
-                  <a:srgbClr val="152B3A"/>
-                </a:solidFill>
+              <a:rPr sz="2550" b="1">
+                <a:solidFill>
+                  <a:srgbClr val="28685E"/>
+                </a:solidFill>
+                <a:latin typeface="Arial"/>
+                <a:ea typeface="Arial"/>
+                <a:cs typeface="Arial"/>
               </a:rPr>
               <a:t>Make at least one clue about its support.</a:t>
             </a:r>
@@ -5707,7 +6514,7 @@
     <p:bg>
       <p:bgPr>
         <a:solidFill xmlns:a="http://schemas.openxmlformats.org/drawingml/2006/main">
-          <a:srgbClr val="F5F1E8"/>
+          <a:srgbClr val="FBF9F3"/>
         </a:solidFill>
       </p:bgPr>
     </p:bg>
@@ -5736,8 +6543,8 @@
         </p:nvSpPr>
         <p:spPr>
           <a:xfrm xmlns:a="http://schemas.openxmlformats.org/drawingml/2006/main">
-            <a:off x="609600" y="552450"/>
-            <a:ext cx="781050" cy="57150"/>
+            <a:off x="609600" y="742950"/>
+            <a:ext cx="9906000" cy="38100"/>
           </a:xfrm>
           <a:prstGeom xmlns:a="http://schemas.openxmlformats.org/drawingml/2006/main" prst="rect">
             <a:avLst/>
@@ -5767,8 +6574,8 @@
         </p:nvSpPr>
         <p:spPr>
           <a:xfrm xmlns:a="http://schemas.openxmlformats.org/drawingml/2006/main">
-            <a:off x="609600" y="762000"/>
-            <a:ext cx="9334500" cy="285750"/>
+            <a:off x="609600" y="342900"/>
+            <a:ext cx="9334500" cy="266700"/>
           </a:xfrm>
           <a:prstGeom xmlns:a="http://schemas.openxmlformats.org/drawingml/2006/main" prst="rect">
             <a:avLst/>
@@ -5780,21 +6587,30 @@
           </a:ln>
         </p:spPr>
         <p:txBody>
-          <a:bodyPr xmlns:a="http://schemas.openxmlformats.org/drawingml/2006/main" lIns="0" tIns="0" rIns="0" bIns="0" anchor="ctr"/>
+          <a:bodyPr xmlns:a="http://schemas.openxmlformats.org/drawingml/2006/main" wrap="square" lIns="0" tIns="0" rIns="0" bIns="0" anchor="ctr">
+            <a:noAutofit/>
+          </a:bodyPr>
           <a:lstStyle xmlns:a="http://schemas.openxmlformats.org/drawingml/2006/main"/>
           <a:p xmlns:a="http://schemas.openxmlformats.org/drawingml/2006/main">
             <a:pPr>
-              <a:defRPr sz="1500" b="1">
+              <a:buNone/>
+              <a:defRPr sz="1425" b="1">
                 <a:solidFill>
                   <a:srgbClr val="28685E"/>
                 </a:solidFill>
+                <a:latin typeface="Arial"/>
+                <a:ea typeface="Arial"/>
+                <a:cs typeface="Arial"/>
               </a:defRPr>
             </a:pPr>
             <a:r>
-              <a:rPr sz="1500" b="1">
+              <a:rPr sz="1425" b="1">
                 <a:solidFill>
                   <a:srgbClr val="28685E"/>
                 </a:solidFill>
+                <a:latin typeface="Arial"/>
+                <a:ea typeface="Arial"/>
+                <a:cs typeface="Arial"/>
               </a:rPr>
               <a:t>MADE BY MATT  /  BUILD SCIENCE</a:t>
             </a:r>
@@ -5803,14 +6619,14 @@
       </p:sp>
       <p:pic>
         <p:nvPicPr>
-          <p:cNvPr id="14" name=""/>
+          <p:cNvPr id="16" name=""/>
           <p:cNvPicPr>
             <a:picLocks xmlns:a="http://schemas.openxmlformats.org/drawingml/2006/main" noChangeAspect="1"/>
           </p:cNvPicPr>
           <p:nvPr/>
         </p:nvPicPr>
         <p:blipFill>
-          <a:blip xmlns:r="http://schemas.openxmlformats.org/officeDocument/2006/relationships" xmlns:a="http://schemas.openxmlformats.org/drawingml/2006/main" r:embed="R9448203999fa4916"/>
+          <a:blip xmlns:r="http://schemas.openxmlformats.org/officeDocument/2006/relationships" xmlns:a="http://schemas.openxmlformats.org/drawingml/2006/main" r:embed="R3d5b8be1ea9a4144"/>
           <a:stretch xmlns:a="http://schemas.openxmlformats.org/drawingml/2006/main"/>
         </p:blipFill>
         <p:spPr>
@@ -5839,8 +6655,8 @@
         </p:nvSpPr>
         <p:spPr>
           <a:xfrm xmlns:a="http://schemas.openxmlformats.org/drawingml/2006/main">
-            <a:off x="609600" y="1352550"/>
-            <a:ext cx="10972800" cy="952500"/>
+            <a:off x="609600" y="1047750"/>
+            <a:ext cx="10972800" cy="895350"/>
           </a:xfrm>
           <a:prstGeom xmlns:a="http://schemas.openxmlformats.org/drawingml/2006/main" prst="rect">
             <a:avLst/>
@@ -5852,21 +6668,30 @@
           </a:ln>
         </p:spPr>
         <p:txBody>
-          <a:bodyPr xmlns:a="http://schemas.openxmlformats.org/drawingml/2006/main" lIns="0" tIns="0" rIns="0" bIns="0" anchor="ctr"/>
+          <a:bodyPr xmlns:a="http://schemas.openxmlformats.org/drawingml/2006/main" wrap="square" lIns="0" tIns="0" rIns="0" bIns="0" anchor="ctr">
+            <a:noAutofit/>
+          </a:bodyPr>
           <a:lstStyle xmlns:a="http://schemas.openxmlformats.org/drawingml/2006/main"/>
           <a:p xmlns:a="http://schemas.openxmlformats.org/drawingml/2006/main">
             <a:pPr>
-              <a:defRPr sz="3750" b="1">
+              <a:buNone/>
+              <a:defRPr sz="3600" b="1">
                 <a:solidFill>
                   <a:srgbClr val="152B3A"/>
                 </a:solidFill>
+                <a:latin typeface="Arial"/>
+                <a:ea typeface="Arial"/>
+                <a:cs typeface="Arial"/>
               </a:defRPr>
             </a:pPr>
             <a:r>
-              <a:rPr sz="3750" b="1">
+              <a:rPr sz="3600" b="1">
                 <a:solidFill>
                   <a:srgbClr val="152B3A"/>
                 </a:solidFill>
+                <a:latin typeface="Arial"/>
+                <a:ea typeface="Arial"/>
+                <a:cs typeface="Arial"/>
               </a:rPr>
               <a:t>Test the clue, then explain</a:t>
             </a:r>
@@ -5933,21 +6758,30 @@
           </a:ln>
         </p:spPr>
         <p:txBody>
-          <a:bodyPr xmlns:a="http://schemas.openxmlformats.org/drawingml/2006/main" lIns="0" tIns="0" rIns="0" bIns="0" anchor="ctr"/>
+          <a:bodyPr xmlns:a="http://schemas.openxmlformats.org/drawingml/2006/main" wrap="square" lIns="0" tIns="0" rIns="0" bIns="0" anchor="ctr">
+            <a:noAutofit/>
+          </a:bodyPr>
           <a:lstStyle xmlns:a="http://schemas.openxmlformats.org/drawingml/2006/main"/>
           <a:p xmlns:a="http://schemas.openxmlformats.org/drawingml/2006/main">
             <a:pPr>
-              <a:defRPr sz="1275" b="0">
+              <a:buNone/>
+              <a:defRPr sz="1200" b="0">
                 <a:solidFill>
                   <a:srgbClr val="50616B"/>
                 </a:solidFill>
+                <a:latin typeface="Arial"/>
+                <a:ea typeface="Arial"/>
+                <a:cs typeface="Arial"/>
               </a:defRPr>
             </a:pPr>
             <a:r>
-              <a:rPr sz="1275" b="0">
+              <a:rPr sz="1200" b="0">
                 <a:solidFill>
                   <a:srgbClr val="50616B"/>
                 </a:solidFill>
+                <a:latin typeface="Arial"/>
+                <a:ea typeface="Arial"/>
+                <a:cs typeface="Arial"/>
               </a:rPr>
               <a:t>AUTUMN 1  ·  WEEK 3  ·  LESSON B</a:t>
             </a:r>
@@ -5983,14 +6817,20 @@
           </a:ln>
         </p:spPr>
         <p:txBody>
-          <a:bodyPr xmlns:a="http://schemas.openxmlformats.org/drawingml/2006/main" lIns="0" tIns="0" rIns="0" bIns="0" anchor="ctr"/>
+          <a:bodyPr xmlns:a="http://schemas.openxmlformats.org/drawingml/2006/main" wrap="square" lIns="0" tIns="0" rIns="0" bIns="0" anchor="ctr">
+            <a:noAutofit/>
+          </a:bodyPr>
           <a:lstStyle xmlns:a="http://schemas.openxmlformats.org/drawingml/2006/main"/>
           <a:p xmlns:a="http://schemas.openxmlformats.org/drawingml/2006/main">
             <a:pPr>
+              <a:buNone/>
               <a:defRPr sz="1350" b="1">
                 <a:solidFill>
                   <a:srgbClr val="28685E"/>
                 </a:solidFill>
+                <a:latin typeface="Arial"/>
+                <a:ea typeface="Arial"/>
+                <a:cs typeface="Arial"/>
               </a:defRPr>
             </a:pPr>
             <a:r>
@@ -5998,6 +6838,9 @@
                 <a:solidFill>
                   <a:srgbClr val="28685E"/>
                 </a:solidFill>
+                <a:latin typeface="Arial"/>
+                <a:ea typeface="Arial"/>
+                <a:cs typeface="Arial"/>
               </a:rPr>
               <a:t>06</a:t>
             </a:r>
@@ -6020,8 +6863,8 @@
         </p:nvSpPr>
         <p:spPr>
           <a:xfrm xmlns:a="http://schemas.openxmlformats.org/drawingml/2006/main">
-            <a:off x="609600" y="2619375"/>
-            <a:ext cx="10972800" cy="714375"/>
+            <a:off x="609600" y="2305050"/>
+            <a:ext cx="10972800" cy="704850"/>
           </a:xfrm>
           <a:prstGeom xmlns:a="http://schemas.openxmlformats.org/drawingml/2006/main" prst="rect">
             <a:avLst/>
@@ -6033,14 +6876,20 @@
           </a:ln>
         </p:spPr>
         <p:txBody>
-          <a:bodyPr xmlns:a="http://schemas.openxmlformats.org/drawingml/2006/main" lIns="0" tIns="0" rIns="0" bIns="0" anchor="ctr"/>
+          <a:bodyPr xmlns:a="http://schemas.openxmlformats.org/drawingml/2006/main" wrap="square" lIns="0" tIns="0" rIns="0" bIns="0" anchor="ctr">
+            <a:noAutofit/>
+          </a:bodyPr>
           <a:lstStyle xmlns:a="http://schemas.openxmlformats.org/drawingml/2006/main"/>
           <a:p xmlns:a="http://schemas.openxmlformats.org/drawingml/2006/main">
             <a:pPr>
+              <a:buNone/>
               <a:defRPr sz="2550" b="0">
                 <a:solidFill>
                   <a:srgbClr val="152B3A"/>
                 </a:solidFill>
+                <a:latin typeface="Arial"/>
+                <a:ea typeface="Arial"/>
+                <a:cs typeface="Arial"/>
               </a:defRPr>
             </a:pPr>
             <a:r>
@@ -6048,6 +6897,9 @@
                 <a:solidFill>
                   <a:srgbClr val="152B3A"/>
                 </a:solidFill>
+                <a:latin typeface="Arial"/>
+                <a:ea typeface="Arial"/>
+                <a:cs typeface="Arial"/>
               </a:rPr>
               <a:t>Read the clues to an adult or partner.</a:t>
             </a:r>
@@ -6070,8 +6922,8 @@
         </p:nvSpPr>
         <p:spPr>
           <a:xfrm xmlns:a="http://schemas.openxmlformats.org/drawingml/2006/main">
-            <a:off x="609600" y="3409950"/>
-            <a:ext cx="10972800" cy="714375"/>
+            <a:off x="609600" y="3143250"/>
+            <a:ext cx="10972800" cy="704850"/>
           </a:xfrm>
           <a:prstGeom xmlns:a="http://schemas.openxmlformats.org/drawingml/2006/main" prst="rect">
             <a:avLst/>
@@ -6083,14 +6935,20 @@
           </a:ln>
         </p:spPr>
         <p:txBody>
-          <a:bodyPr xmlns:a="http://schemas.openxmlformats.org/drawingml/2006/main" lIns="0" tIns="0" rIns="0" bIns="0" anchor="ctr"/>
+          <a:bodyPr xmlns:a="http://schemas.openxmlformats.org/drawingml/2006/main" wrap="square" lIns="0" tIns="0" rIns="0" bIns="0" anchor="ctr">
+            <a:noAutofit/>
+          </a:bodyPr>
           <a:lstStyle xmlns:a="http://schemas.openxmlformats.org/drawingml/2006/main"/>
           <a:p xmlns:a="http://schemas.openxmlformats.org/drawingml/2006/main">
             <a:pPr>
+              <a:buNone/>
               <a:defRPr sz="2550" b="0">
                 <a:solidFill>
                   <a:srgbClr val="152B3A"/>
                 </a:solidFill>
+                <a:latin typeface="Arial"/>
+                <a:ea typeface="Arial"/>
+                <a:cs typeface="Arial"/>
               </a:defRPr>
             </a:pPr>
             <a:r>
@@ -6098,6 +6956,9 @@
                 <a:solidFill>
                   <a:srgbClr val="152B3A"/>
                 </a:solidFill>
+                <a:latin typeface="Arial"/>
+                <a:ea typeface="Arial"/>
+                <a:cs typeface="Arial"/>
               </a:rPr>
               <a:t>Ask: which group, and why?</a:t>
             </a:r>
@@ -6120,8 +6981,8 @@
         </p:nvSpPr>
         <p:spPr>
           <a:xfrm xmlns:a="http://schemas.openxmlformats.org/drawingml/2006/main">
-            <a:off x="609600" y="4200525"/>
-            <a:ext cx="10972800" cy="714375"/>
+            <a:off x="609600" y="3981450"/>
+            <a:ext cx="10972800" cy="704850"/>
           </a:xfrm>
           <a:prstGeom xmlns:a="http://schemas.openxmlformats.org/drawingml/2006/main" prst="rect">
             <a:avLst/>
@@ -6133,14 +6994,20 @@
           </a:ln>
         </p:spPr>
         <p:txBody>
-          <a:bodyPr xmlns:a="http://schemas.openxmlformats.org/drawingml/2006/main" lIns="0" tIns="0" rIns="0" bIns="0" anchor="ctr"/>
+          <a:bodyPr xmlns:a="http://schemas.openxmlformats.org/drawingml/2006/main" wrap="square" lIns="0" tIns="0" rIns="0" bIns="0" anchor="ctr">
+            <a:noAutofit/>
+          </a:bodyPr>
           <a:lstStyle xmlns:a="http://schemas.openxmlformats.org/drawingml/2006/main"/>
           <a:p xmlns:a="http://schemas.openxmlformats.org/drawingml/2006/main">
             <a:pPr>
+              <a:buNone/>
               <a:defRPr sz="2550" b="0">
                 <a:solidFill>
                   <a:srgbClr val="152B3A"/>
                 </a:solidFill>
+                <a:latin typeface="Arial"/>
+                <a:ea typeface="Arial"/>
+                <a:cs typeface="Arial"/>
               </a:defRPr>
             </a:pPr>
             <a:r>
@@ -6148,6 +7015,9 @@
                 <a:solidFill>
                   <a:srgbClr val="152B3A"/>
                 </a:solidFill>
+                <a:latin typeface="Arial"/>
+                <a:ea typeface="Arial"/>
+                <a:cs typeface="Arial"/>
               </a:rPr>
               <a:t>You can check the card on your own.</a:t>
             </a:r>
@@ -6170,8 +7040,8 @@
         </p:nvSpPr>
         <p:spPr>
           <a:xfrm xmlns:a="http://schemas.openxmlformats.org/drawingml/2006/main">
-            <a:off x="609600" y="4991100"/>
-            <a:ext cx="10972800" cy="714375"/>
+            <a:off x="609600" y="4819650"/>
+            <a:ext cx="10972800" cy="704850"/>
           </a:xfrm>
           <a:prstGeom xmlns:a="http://schemas.openxmlformats.org/drawingml/2006/main" prst="rect">
             <a:avLst/>
@@ -6183,21 +7053,30 @@
           </a:ln>
         </p:spPr>
         <p:txBody>
-          <a:bodyPr xmlns:a="http://schemas.openxmlformats.org/drawingml/2006/main" lIns="0" tIns="0" rIns="0" bIns="0" anchor="ctr"/>
+          <a:bodyPr xmlns:a="http://schemas.openxmlformats.org/drawingml/2006/main" wrap="square" lIns="0" tIns="0" rIns="0" bIns="0" anchor="ctr">
+            <a:noAutofit/>
+          </a:bodyPr>
           <a:lstStyle xmlns:a="http://schemas.openxmlformats.org/drawingml/2006/main"/>
           <a:p xmlns:a="http://schemas.openxmlformats.org/drawingml/2006/main">
             <a:pPr>
-              <a:defRPr sz="2550" b="0">
-                <a:solidFill>
-                  <a:srgbClr val="152B3A"/>
-                </a:solidFill>
+              <a:buNone/>
+              <a:defRPr sz="2550" b="1">
+                <a:solidFill>
+                  <a:srgbClr val="28685E"/>
+                </a:solidFill>
+                <a:latin typeface="Arial"/>
+                <a:ea typeface="Arial"/>
+                <a:cs typeface="Arial"/>
               </a:defRPr>
             </a:pPr>
             <a:r>
-              <a:rPr sz="2550" b="0">
-                <a:solidFill>
-                  <a:srgbClr val="152B3A"/>
-                </a:solidFill>
+              <a:rPr sz="2550" b="1">
+                <a:solidFill>
+                  <a:srgbClr val="28685E"/>
+                </a:solidFill>
+                <a:latin typeface="Arial"/>
+                <a:ea typeface="Arial"/>
+                <a:cs typeface="Arial"/>
               </a:rPr>
               <a:t>Does a clue prove the group?</a:t>
             </a:r>
@@ -6220,7 +7099,7 @@
     <p:bg>
       <p:bgPr>
         <a:solidFill xmlns:a="http://schemas.openxmlformats.org/drawingml/2006/main">
-          <a:srgbClr val="F5F1E8"/>
+          <a:srgbClr val="FBF9F3"/>
         </a:solidFill>
       </p:bgPr>
     </p:bg>
@@ -6249,8 +7128,8 @@
         </p:nvSpPr>
         <p:spPr>
           <a:xfrm xmlns:a="http://schemas.openxmlformats.org/drawingml/2006/main">
-            <a:off x="609600" y="552450"/>
-            <a:ext cx="781050" cy="57150"/>
+            <a:off x="609600" y="742950"/>
+            <a:ext cx="9906000" cy="38100"/>
           </a:xfrm>
           <a:prstGeom xmlns:a="http://schemas.openxmlformats.org/drawingml/2006/main" prst="rect">
             <a:avLst/>
@@ -6280,8 +7159,8 @@
         </p:nvSpPr>
         <p:spPr>
           <a:xfrm xmlns:a="http://schemas.openxmlformats.org/drawingml/2006/main">
-            <a:off x="609600" y="762000"/>
-            <a:ext cx="9334500" cy="285750"/>
+            <a:off x="609600" y="342900"/>
+            <a:ext cx="9334500" cy="266700"/>
           </a:xfrm>
           <a:prstGeom xmlns:a="http://schemas.openxmlformats.org/drawingml/2006/main" prst="rect">
             <a:avLst/>
@@ -6293,21 +7172,30 @@
           </a:ln>
         </p:spPr>
         <p:txBody>
-          <a:bodyPr xmlns:a="http://schemas.openxmlformats.org/drawingml/2006/main" lIns="0" tIns="0" rIns="0" bIns="0" anchor="ctr"/>
+          <a:bodyPr xmlns:a="http://schemas.openxmlformats.org/drawingml/2006/main" wrap="square" lIns="0" tIns="0" rIns="0" bIns="0" anchor="ctr">
+            <a:noAutofit/>
+          </a:bodyPr>
           <a:lstStyle xmlns:a="http://schemas.openxmlformats.org/drawingml/2006/main"/>
           <a:p xmlns:a="http://schemas.openxmlformats.org/drawingml/2006/main">
             <a:pPr>
-              <a:defRPr sz="1500" b="1">
+              <a:buNone/>
+              <a:defRPr sz="1425" b="1">
                 <a:solidFill>
                   <a:srgbClr val="28685E"/>
                 </a:solidFill>
+                <a:latin typeface="Arial"/>
+                <a:ea typeface="Arial"/>
+                <a:cs typeface="Arial"/>
               </a:defRPr>
             </a:pPr>
             <a:r>
-              <a:rPr sz="1500" b="1">
+              <a:rPr sz="1425" b="1">
                 <a:solidFill>
                   <a:srgbClr val="28685E"/>
                 </a:solidFill>
+                <a:latin typeface="Arial"/>
+                <a:ea typeface="Arial"/>
+                <a:cs typeface="Arial"/>
               </a:rPr>
               <a:t>MADE BY MATT  /  BUILD SCIENCE</a:t>
             </a:r>
@@ -6316,14 +7204,14 @@
       </p:sp>
       <p:pic>
         <p:nvPicPr>
-          <p:cNvPr id="13" name=""/>
+          <p:cNvPr id="16" name=""/>
           <p:cNvPicPr>
             <a:picLocks xmlns:a="http://schemas.openxmlformats.org/drawingml/2006/main" noChangeAspect="1"/>
           </p:cNvPicPr>
           <p:nvPr/>
         </p:nvPicPr>
         <p:blipFill>
-          <a:blip xmlns:r="http://schemas.openxmlformats.org/officeDocument/2006/relationships" xmlns:a="http://schemas.openxmlformats.org/drawingml/2006/main" r:embed="R2073a739e0c4441c"/>
+          <a:blip xmlns:r="http://schemas.openxmlformats.org/officeDocument/2006/relationships" xmlns:a="http://schemas.openxmlformats.org/drawingml/2006/main" r:embed="Rdb6dd9d613d9461e"/>
           <a:stretch xmlns:a="http://schemas.openxmlformats.org/drawingml/2006/main"/>
         </p:blipFill>
         <p:spPr>
@@ -6352,8 +7240,8 @@
         </p:nvSpPr>
         <p:spPr>
           <a:xfrm xmlns:a="http://schemas.openxmlformats.org/drawingml/2006/main">
-            <a:off x="609600" y="1352550"/>
-            <a:ext cx="10972800" cy="952500"/>
+            <a:off x="609600" y="1047750"/>
+            <a:ext cx="10972800" cy="895350"/>
           </a:xfrm>
           <a:prstGeom xmlns:a="http://schemas.openxmlformats.org/drawingml/2006/main" prst="rect">
             <a:avLst/>
@@ -6365,21 +7253,30 @@
           </a:ln>
         </p:spPr>
         <p:txBody>
-          <a:bodyPr xmlns:a="http://schemas.openxmlformats.org/drawingml/2006/main" lIns="0" tIns="0" rIns="0" bIns="0" anchor="ctr"/>
+          <a:bodyPr xmlns:a="http://schemas.openxmlformats.org/drawingml/2006/main" wrap="square" lIns="0" tIns="0" rIns="0" bIns="0" anchor="ctr">
+            <a:noAutofit/>
+          </a:bodyPr>
           <a:lstStyle xmlns:a="http://schemas.openxmlformats.org/drawingml/2006/main"/>
           <a:p xmlns:a="http://schemas.openxmlformats.org/drawingml/2006/main">
             <a:pPr>
-              <a:defRPr sz="3750" b="1">
+              <a:buNone/>
+              <a:defRPr sz="3600" b="1">
                 <a:solidFill>
                   <a:srgbClr val="152B3A"/>
                 </a:solidFill>
+                <a:latin typeface="Arial"/>
+                <a:ea typeface="Arial"/>
+                <a:cs typeface="Arial"/>
               </a:defRPr>
             </a:pPr>
             <a:r>
-              <a:rPr sz="3750" b="1">
+              <a:rPr sz="3600" b="1">
                 <a:solidFill>
                   <a:srgbClr val="152B3A"/>
                 </a:solidFill>
+                <a:latin typeface="Arial"/>
+                <a:ea typeface="Arial"/>
+                <a:cs typeface="Arial"/>
               </a:rPr>
               <a:t>Pause and check the rule</a:t>
             </a:r>
@@ -6446,21 +7343,30 @@
           </a:ln>
         </p:spPr>
         <p:txBody>
-          <a:bodyPr xmlns:a="http://schemas.openxmlformats.org/drawingml/2006/main" lIns="0" tIns="0" rIns="0" bIns="0" anchor="ctr"/>
+          <a:bodyPr xmlns:a="http://schemas.openxmlformats.org/drawingml/2006/main" wrap="square" lIns="0" tIns="0" rIns="0" bIns="0" anchor="ctr">
+            <a:noAutofit/>
+          </a:bodyPr>
           <a:lstStyle xmlns:a="http://schemas.openxmlformats.org/drawingml/2006/main"/>
           <a:p xmlns:a="http://schemas.openxmlformats.org/drawingml/2006/main">
             <a:pPr>
-              <a:defRPr sz="1275" b="0">
+              <a:buNone/>
+              <a:defRPr sz="1200" b="0">
                 <a:solidFill>
                   <a:srgbClr val="50616B"/>
                 </a:solidFill>
+                <a:latin typeface="Arial"/>
+                <a:ea typeface="Arial"/>
+                <a:cs typeface="Arial"/>
               </a:defRPr>
             </a:pPr>
             <a:r>
-              <a:rPr sz="1275" b="0">
+              <a:rPr sz="1200" b="0">
                 <a:solidFill>
                   <a:srgbClr val="50616B"/>
                 </a:solidFill>
+                <a:latin typeface="Arial"/>
+                <a:ea typeface="Arial"/>
+                <a:cs typeface="Arial"/>
               </a:rPr>
               <a:t>AUTUMN 1  ·  WEEK 3  ·  LESSON B</a:t>
             </a:r>
@@ -6496,14 +7402,20 @@
           </a:ln>
         </p:spPr>
         <p:txBody>
-          <a:bodyPr xmlns:a="http://schemas.openxmlformats.org/drawingml/2006/main" lIns="0" tIns="0" rIns="0" bIns="0" anchor="ctr"/>
+          <a:bodyPr xmlns:a="http://schemas.openxmlformats.org/drawingml/2006/main" wrap="square" lIns="0" tIns="0" rIns="0" bIns="0" anchor="ctr">
+            <a:noAutofit/>
+          </a:bodyPr>
           <a:lstStyle xmlns:a="http://schemas.openxmlformats.org/drawingml/2006/main"/>
           <a:p xmlns:a="http://schemas.openxmlformats.org/drawingml/2006/main">
             <a:pPr>
+              <a:buNone/>
               <a:defRPr sz="1350" b="1">
                 <a:solidFill>
                   <a:srgbClr val="28685E"/>
                 </a:solidFill>
+                <a:latin typeface="Arial"/>
+                <a:ea typeface="Arial"/>
+                <a:cs typeface="Arial"/>
               </a:defRPr>
             </a:pPr>
             <a:r>
@@ -6511,6 +7423,9 @@
                 <a:solidFill>
                   <a:srgbClr val="28685E"/>
                 </a:solidFill>
+                <a:latin typeface="Arial"/>
+                <a:ea typeface="Arial"/>
+                <a:cs typeface="Arial"/>
               </a:rPr>
               <a:t>07</a:t>
             </a:r>
@@ -6533,8 +7448,8 @@
         </p:nvSpPr>
         <p:spPr>
           <a:xfrm xmlns:a="http://schemas.openxmlformats.org/drawingml/2006/main">
-            <a:off x="609600" y="2619375"/>
-            <a:ext cx="10972800" cy="781050"/>
+            <a:off x="609600" y="2305050"/>
+            <a:ext cx="7096125" cy="914400"/>
           </a:xfrm>
           <a:prstGeom xmlns:a="http://schemas.openxmlformats.org/drawingml/2006/main" prst="rect">
             <a:avLst/>
@@ -6546,14 +7461,20 @@
           </a:ln>
         </p:spPr>
         <p:txBody>
-          <a:bodyPr xmlns:a="http://schemas.openxmlformats.org/drawingml/2006/main" lIns="0" tIns="0" rIns="0" bIns="0" anchor="ctr"/>
+          <a:bodyPr xmlns:a="http://schemas.openxmlformats.org/drawingml/2006/main" wrap="square" lIns="0" tIns="0" rIns="0" bIns="0" anchor="ctr">
+            <a:noAutofit/>
+          </a:bodyPr>
           <a:lstStyle xmlns:a="http://schemas.openxmlformats.org/drawingml/2006/main"/>
           <a:p xmlns:a="http://schemas.openxmlformats.org/drawingml/2006/main">
             <a:pPr>
+              <a:buNone/>
               <a:defRPr sz="2550" b="0">
                 <a:solidFill>
                   <a:srgbClr val="152B3A"/>
                 </a:solidFill>
+                <a:latin typeface="Arial"/>
+                <a:ea typeface="Arial"/>
+                <a:cs typeface="Arial"/>
               </a:defRPr>
             </a:pPr>
             <a:r>
@@ -6561,6 +7482,9 @@
                 <a:solidFill>
                   <a:srgbClr val="152B3A"/>
                 </a:solidFill>
+                <a:latin typeface="Arial"/>
+                <a:ea typeface="Arial"/>
+                <a:cs typeface="Arial"/>
               </a:rPr>
               <a:t>Look at one first idea and final choice.</a:t>
             </a:r>
@@ -6583,8 +7507,8 @@
         </p:nvSpPr>
         <p:spPr>
           <a:xfrm xmlns:a="http://schemas.openxmlformats.org/drawingml/2006/main">
-            <a:off x="609600" y="3476625"/>
-            <a:ext cx="10972800" cy="781050"/>
+            <a:off x="609600" y="3352800"/>
+            <a:ext cx="7096125" cy="914400"/>
           </a:xfrm>
           <a:prstGeom xmlns:a="http://schemas.openxmlformats.org/drawingml/2006/main" prst="rect">
             <a:avLst/>
@@ -6596,14 +7520,20 @@
           </a:ln>
         </p:spPr>
         <p:txBody>
-          <a:bodyPr xmlns:a="http://schemas.openxmlformats.org/drawingml/2006/main" lIns="0" tIns="0" rIns="0" bIns="0" anchor="ctr"/>
+          <a:bodyPr xmlns:a="http://schemas.openxmlformats.org/drawingml/2006/main" wrap="square" lIns="0" tIns="0" rIns="0" bIns="0" anchor="ctr">
+            <a:noAutofit/>
+          </a:bodyPr>
           <a:lstStyle xmlns:a="http://schemas.openxmlformats.org/drawingml/2006/main"/>
           <a:p xmlns:a="http://schemas.openxmlformats.org/drawingml/2006/main">
             <a:pPr>
+              <a:buNone/>
               <a:defRPr sz="2550" b="0">
                 <a:solidFill>
                   <a:srgbClr val="152B3A"/>
                 </a:solidFill>
+                <a:latin typeface="Arial"/>
+                <a:ea typeface="Arial"/>
+                <a:cs typeface="Arial"/>
               </a:defRPr>
             </a:pPr>
             <a:r>
@@ -6611,6 +7541,9 @@
                 <a:solidFill>
                   <a:srgbClr val="152B3A"/>
                 </a:solidFill>
+                <a:latin typeface="Arial"/>
+                <a:ea typeface="Arial"/>
+                <a:cs typeface="Arial"/>
               </a:rPr>
               <a:t>Point to the clue that decided it.</a:t>
             </a:r>
@@ -6633,8 +7566,8 @@
         </p:nvSpPr>
         <p:spPr>
           <a:xfrm xmlns:a="http://schemas.openxmlformats.org/drawingml/2006/main">
-            <a:off x="609600" y="4333875"/>
-            <a:ext cx="10972800" cy="781050"/>
+            <a:off x="609600" y="4400550"/>
+            <a:ext cx="7096125" cy="914400"/>
           </a:xfrm>
           <a:prstGeom xmlns:a="http://schemas.openxmlformats.org/drawingml/2006/main" prst="rect">
             <a:avLst/>
@@ -6646,27 +7579,58 @@
           </a:ln>
         </p:spPr>
         <p:txBody>
-          <a:bodyPr xmlns:a="http://schemas.openxmlformats.org/drawingml/2006/main" lIns="0" tIns="0" rIns="0" bIns="0" anchor="ctr"/>
+          <a:bodyPr xmlns:a="http://schemas.openxmlformats.org/drawingml/2006/main" wrap="square" lIns="0" tIns="0" rIns="0" bIns="0" anchor="ctr">
+            <a:noAutofit/>
+          </a:bodyPr>
           <a:lstStyle xmlns:a="http://schemas.openxmlformats.org/drawingml/2006/main"/>
           <a:p xmlns:a="http://schemas.openxmlformats.org/drawingml/2006/main">
             <a:pPr>
-              <a:defRPr sz="2550" b="0">
-                <a:solidFill>
-                  <a:srgbClr val="152B3A"/>
-                </a:solidFill>
+              <a:buNone/>
+              <a:defRPr sz="2550" b="1">
+                <a:solidFill>
+                  <a:srgbClr val="28685E"/>
+                </a:solidFill>
+                <a:latin typeface="Arial"/>
+                <a:ea typeface="Arial"/>
+                <a:cs typeface="Arial"/>
               </a:defRPr>
             </a:pPr>
             <a:r>
-              <a:rPr sz="2550" b="0">
-                <a:solidFill>
-                  <a:srgbClr val="152B3A"/>
-                </a:solidFill>
+              <a:rPr sz="2550" b="1">
+                <a:solidFill>
+                  <a:srgbClr val="28685E"/>
+                </a:solidFill>
+                <a:latin typeface="Arial"/>
+                <a:ea typeface="Arial"/>
+                <a:cs typeface="Arial"/>
               </a:rPr>
               <a:t>Check: a skin ring is not a backbone.</a:t>
             </a:r>
           </a:p>
         </p:txBody>
       </p:sp>
+      <p:pic>
+        <p:nvPicPr>
+          <p:cNvPr id="24" name=""/>
+          <p:cNvPicPr>
+            <a:picLocks xmlns:a="http://schemas.openxmlformats.org/drawingml/2006/main" noChangeAspect="1"/>
+          </p:cNvPicPr>
+          <p:nvPr/>
+        </p:nvPicPr>
+        <p:blipFill>
+          <a:blip xmlns:r="http://schemas.openxmlformats.org/officeDocument/2006/relationships" xmlns:a="http://schemas.openxmlformats.org/drawingml/2006/main" r:embed="R4b0fac55cadf4fe9"/>
+          <a:stretch xmlns:a="http://schemas.openxmlformats.org/drawingml/2006/main"/>
+        </p:blipFill>
+        <p:spPr>
+          <a:xfrm xmlns:a="http://schemas.openxmlformats.org/drawingml/2006/main">
+            <a:off x="8429625" y="2971800"/>
+            <a:ext cx="2857500" cy="2143125"/>
+          </a:xfrm>
+          <a:prstGeom xmlns:a="http://schemas.openxmlformats.org/drawingml/2006/main" prst="rect">
+            <a:avLst/>
+          </a:prstGeom>
+        </p:spPr>
+      </p:pic>
     </p:spTree>
     <p:extLst>
       <p:ext uri="{BB962C8B-B14F-4D97-AF65-F5344CB8AC3E}">
@@ -6683,7 +7647,7 @@
     <p:bg>
       <p:bgPr>
         <a:solidFill xmlns:a="http://schemas.openxmlformats.org/drawingml/2006/main">
-          <a:srgbClr val="F5F1E8"/>
+          <a:srgbClr val="FBF9F3"/>
         </a:solidFill>
       </p:bgPr>
     </p:bg>
@@ -6712,8 +7676,8 @@
         </p:nvSpPr>
         <p:spPr>
           <a:xfrm xmlns:a="http://schemas.openxmlformats.org/drawingml/2006/main">
-            <a:off x="609600" y="552450"/>
-            <a:ext cx="781050" cy="57150"/>
+            <a:off x="609600" y="742950"/>
+            <a:ext cx="9906000" cy="38100"/>
           </a:xfrm>
           <a:prstGeom xmlns:a="http://schemas.openxmlformats.org/drawingml/2006/main" prst="rect">
             <a:avLst/>
@@ -6743,8 +7707,8 @@
         </p:nvSpPr>
         <p:spPr>
           <a:xfrm xmlns:a="http://schemas.openxmlformats.org/drawingml/2006/main">
-            <a:off x="609600" y="762000"/>
-            <a:ext cx="9334500" cy="285750"/>
+            <a:off x="609600" y="342900"/>
+            <a:ext cx="9334500" cy="266700"/>
           </a:xfrm>
           <a:prstGeom xmlns:a="http://schemas.openxmlformats.org/drawingml/2006/main" prst="rect">
             <a:avLst/>
@@ -6756,21 +7720,30 @@
           </a:ln>
         </p:spPr>
         <p:txBody>
-          <a:bodyPr xmlns:a="http://schemas.openxmlformats.org/drawingml/2006/main" lIns="0" tIns="0" rIns="0" bIns="0" anchor="ctr"/>
+          <a:bodyPr xmlns:a="http://schemas.openxmlformats.org/drawingml/2006/main" wrap="square" lIns="0" tIns="0" rIns="0" bIns="0" anchor="ctr">
+            <a:noAutofit/>
+          </a:bodyPr>
           <a:lstStyle xmlns:a="http://schemas.openxmlformats.org/drawingml/2006/main"/>
           <a:p xmlns:a="http://schemas.openxmlformats.org/drawingml/2006/main">
             <a:pPr>
-              <a:defRPr sz="1500" b="1">
+              <a:buNone/>
+              <a:defRPr sz="1425" b="1">
                 <a:solidFill>
                   <a:srgbClr val="28685E"/>
                 </a:solidFill>
+                <a:latin typeface="Arial"/>
+                <a:ea typeface="Arial"/>
+                <a:cs typeface="Arial"/>
               </a:defRPr>
             </a:pPr>
             <a:r>
-              <a:rPr sz="1500" b="1">
+              <a:rPr sz="1425" b="1">
                 <a:solidFill>
                   <a:srgbClr val="28685E"/>
                 </a:solidFill>
+                <a:latin typeface="Arial"/>
+                <a:ea typeface="Arial"/>
+                <a:cs typeface="Arial"/>
               </a:rPr>
               <a:t>MADE BY MATT  /  BUILD SCIENCE</a:t>
             </a:r>
@@ -6779,14 +7752,14 @@
       </p:sp>
       <p:pic>
         <p:nvPicPr>
-          <p:cNvPr id="13" name=""/>
+          <p:cNvPr id="15" name=""/>
           <p:cNvPicPr>
             <a:picLocks xmlns:a="http://schemas.openxmlformats.org/drawingml/2006/main" noChangeAspect="1"/>
           </p:cNvPicPr>
           <p:nvPr/>
         </p:nvPicPr>
         <p:blipFill>
-          <a:blip xmlns:r="http://schemas.openxmlformats.org/officeDocument/2006/relationships" xmlns:a="http://schemas.openxmlformats.org/drawingml/2006/main" r:embed="R75058843ff5b4c98"/>
+          <a:blip xmlns:r="http://schemas.openxmlformats.org/officeDocument/2006/relationships" xmlns:a="http://schemas.openxmlformats.org/drawingml/2006/main" r:embed="R39d89e861fbe4ac4"/>
           <a:stretch xmlns:a="http://schemas.openxmlformats.org/drawingml/2006/main"/>
         </p:blipFill>
         <p:spPr>
@@ -6815,8 +7788,8 @@
         </p:nvSpPr>
         <p:spPr>
           <a:xfrm xmlns:a="http://schemas.openxmlformats.org/drawingml/2006/main">
-            <a:off x="609600" y="1352550"/>
-            <a:ext cx="10972800" cy="952500"/>
+            <a:off x="609600" y="1047750"/>
+            <a:ext cx="10972800" cy="895350"/>
           </a:xfrm>
           <a:prstGeom xmlns:a="http://schemas.openxmlformats.org/drawingml/2006/main" prst="rect">
             <a:avLst/>
@@ -6828,21 +7801,30 @@
           </a:ln>
         </p:spPr>
         <p:txBody>
-          <a:bodyPr xmlns:a="http://schemas.openxmlformats.org/drawingml/2006/main" lIns="0" tIns="0" rIns="0" bIns="0" anchor="ctr"/>
+          <a:bodyPr xmlns:a="http://schemas.openxmlformats.org/drawingml/2006/main" wrap="square" lIns="0" tIns="0" rIns="0" bIns="0" anchor="ctr">
+            <a:noAutofit/>
+          </a:bodyPr>
           <a:lstStyle xmlns:a="http://schemas.openxmlformats.org/drawingml/2006/main"/>
           <a:p xmlns:a="http://schemas.openxmlformats.org/drawingml/2006/main">
             <a:pPr>
-              <a:defRPr sz="3750" b="1">
+              <a:buNone/>
+              <a:defRPr sz="3600" b="1">
                 <a:solidFill>
                   <a:srgbClr val="152B3A"/>
                 </a:solidFill>
+                <a:latin typeface="Arial"/>
+                <a:ea typeface="Arial"/>
+                <a:cs typeface="Arial"/>
               </a:defRPr>
             </a:pPr>
             <a:r>
-              <a:rPr sz="3750" b="1">
+              <a:rPr sz="3600" b="1">
                 <a:solidFill>
                   <a:srgbClr val="152B3A"/>
                 </a:solidFill>
+                <a:latin typeface="Arial"/>
+                <a:ea typeface="Arial"/>
+                <a:cs typeface="Arial"/>
               </a:rPr>
               <a:t>Improve one clue and save it</a:t>
             </a:r>
@@ -6909,21 +7891,30 @@
           </a:ln>
         </p:spPr>
         <p:txBody>
-          <a:bodyPr xmlns:a="http://schemas.openxmlformats.org/drawingml/2006/main" lIns="0" tIns="0" rIns="0" bIns="0" anchor="ctr"/>
+          <a:bodyPr xmlns:a="http://schemas.openxmlformats.org/drawingml/2006/main" wrap="square" lIns="0" tIns="0" rIns="0" bIns="0" anchor="ctr">
+            <a:noAutofit/>
+          </a:bodyPr>
           <a:lstStyle xmlns:a="http://schemas.openxmlformats.org/drawingml/2006/main"/>
           <a:p xmlns:a="http://schemas.openxmlformats.org/drawingml/2006/main">
             <a:pPr>
-              <a:defRPr sz="1275" b="0">
+              <a:buNone/>
+              <a:defRPr sz="1200" b="0">
                 <a:solidFill>
                   <a:srgbClr val="50616B"/>
                 </a:solidFill>
+                <a:latin typeface="Arial"/>
+                <a:ea typeface="Arial"/>
+                <a:cs typeface="Arial"/>
               </a:defRPr>
             </a:pPr>
             <a:r>
-              <a:rPr sz="1275" b="0">
+              <a:rPr sz="1200" b="0">
                 <a:solidFill>
                   <a:srgbClr val="50616B"/>
                 </a:solidFill>
+                <a:latin typeface="Arial"/>
+                <a:ea typeface="Arial"/>
+                <a:cs typeface="Arial"/>
               </a:rPr>
               <a:t>AUTUMN 1  ·  WEEK 3  ·  LESSON B</a:t>
             </a:r>
@@ -6959,14 +7950,20 @@
           </a:ln>
         </p:spPr>
         <p:txBody>
-          <a:bodyPr xmlns:a="http://schemas.openxmlformats.org/drawingml/2006/main" lIns="0" tIns="0" rIns="0" bIns="0" anchor="ctr"/>
+          <a:bodyPr xmlns:a="http://schemas.openxmlformats.org/drawingml/2006/main" wrap="square" lIns="0" tIns="0" rIns="0" bIns="0" anchor="ctr">
+            <a:noAutofit/>
+          </a:bodyPr>
           <a:lstStyle xmlns:a="http://schemas.openxmlformats.org/drawingml/2006/main"/>
           <a:p xmlns:a="http://schemas.openxmlformats.org/drawingml/2006/main">
             <a:pPr>
+              <a:buNone/>
               <a:defRPr sz="1350" b="1">
                 <a:solidFill>
                   <a:srgbClr val="28685E"/>
                 </a:solidFill>
+                <a:latin typeface="Arial"/>
+                <a:ea typeface="Arial"/>
+                <a:cs typeface="Arial"/>
               </a:defRPr>
             </a:pPr>
             <a:r>
@@ -6974,6 +7971,9 @@
                 <a:solidFill>
                   <a:srgbClr val="28685E"/>
                 </a:solidFill>
+                <a:latin typeface="Arial"/>
+                <a:ea typeface="Arial"/>
+                <a:cs typeface="Arial"/>
               </a:rPr>
               <a:t>08</a:t>
             </a:r>
@@ -6996,8 +7996,8 @@
         </p:nvSpPr>
         <p:spPr>
           <a:xfrm xmlns:a="http://schemas.openxmlformats.org/drawingml/2006/main">
-            <a:off x="609600" y="2619375"/>
-            <a:ext cx="10972800" cy="781050"/>
+            <a:off x="609600" y="2305050"/>
+            <a:ext cx="10972800" cy="914400"/>
           </a:xfrm>
           <a:prstGeom xmlns:a="http://schemas.openxmlformats.org/drawingml/2006/main" prst="rect">
             <a:avLst/>
@@ -7009,14 +8009,20 @@
           </a:ln>
         </p:spPr>
         <p:txBody>
-          <a:bodyPr xmlns:a="http://schemas.openxmlformats.org/drawingml/2006/main" lIns="0" tIns="0" rIns="0" bIns="0" anchor="ctr"/>
+          <a:bodyPr xmlns:a="http://schemas.openxmlformats.org/drawingml/2006/main" wrap="square" lIns="0" tIns="0" rIns="0" bIns="0" anchor="ctr">
+            <a:noAutofit/>
+          </a:bodyPr>
           <a:lstStyle xmlns:a="http://schemas.openxmlformats.org/drawingml/2006/main"/>
           <a:p xmlns:a="http://schemas.openxmlformats.org/drawingml/2006/main">
             <a:pPr>
+              <a:buNone/>
               <a:defRPr sz="2550" b="0">
                 <a:solidFill>
                   <a:srgbClr val="152B3A"/>
                 </a:solidFill>
+                <a:latin typeface="Arial"/>
+                <a:ea typeface="Arial"/>
+                <a:cs typeface="Arial"/>
               </a:defRPr>
             </a:pPr>
             <a:r>
@@ -7024,6 +8030,9 @@
                 <a:solidFill>
                   <a:srgbClr val="152B3A"/>
                 </a:solidFill>
+                <a:latin typeface="Arial"/>
+                <a:ea typeface="Arial"/>
+                <a:cs typeface="Arial"/>
               </a:rPr>
               <a:t>Make one clue more precise.</a:t>
             </a:r>
@@ -7046,8 +8055,8 @@
         </p:nvSpPr>
         <p:spPr>
           <a:xfrm xmlns:a="http://schemas.openxmlformats.org/drawingml/2006/main">
-            <a:off x="609600" y="3476625"/>
-            <a:ext cx="10972800" cy="781050"/>
+            <a:off x="609600" y="3352800"/>
+            <a:ext cx="10972800" cy="914400"/>
           </a:xfrm>
           <a:prstGeom xmlns:a="http://schemas.openxmlformats.org/drawingml/2006/main" prst="rect">
             <a:avLst/>
@@ -7059,14 +8068,20 @@
           </a:ln>
         </p:spPr>
         <p:txBody>
-          <a:bodyPr xmlns:a="http://schemas.openxmlformats.org/drawingml/2006/main" lIns="0" tIns="0" rIns="0" bIns="0" anchor="ctr"/>
+          <a:bodyPr xmlns:a="http://schemas.openxmlformats.org/drawingml/2006/main" wrap="square" lIns="0" tIns="0" rIns="0" bIns="0" anchor="ctr">
+            <a:noAutofit/>
+          </a:bodyPr>
           <a:lstStyle xmlns:a="http://schemas.openxmlformats.org/drawingml/2006/main"/>
           <a:p xmlns:a="http://schemas.openxmlformats.org/drawingml/2006/main">
             <a:pPr>
+              <a:buNone/>
               <a:defRPr sz="2550" b="0">
                 <a:solidFill>
                   <a:srgbClr val="152B3A"/>
                 </a:solidFill>
+                <a:latin typeface="Arial"/>
+                <a:ea typeface="Arial"/>
+                <a:cs typeface="Arial"/>
               </a:defRPr>
             </a:pPr>
             <a:r>
@@ -7074,6 +8089,9 @@
                 <a:solidFill>
                   <a:srgbClr val="152B3A"/>
                 </a:solidFill>
+                <a:latin typeface="Arial"/>
+                <a:ea typeface="Arial"/>
+                <a:cs typeface="Arial"/>
               </a:rPr>
               <a:t>Keep your first and improved version.</a:t>
             </a:r>
@@ -7096,8 +8114,8 @@
         </p:nvSpPr>
         <p:spPr>
           <a:xfrm xmlns:a="http://schemas.openxmlformats.org/drawingml/2006/main">
-            <a:off x="609600" y="4333875"/>
-            <a:ext cx="10972800" cy="781050"/>
+            <a:off x="609600" y="4400550"/>
+            <a:ext cx="10972800" cy="914400"/>
           </a:xfrm>
           <a:prstGeom xmlns:a="http://schemas.openxmlformats.org/drawingml/2006/main" prst="rect">
             <a:avLst/>
@@ -7109,21 +8127,30 @@
           </a:ln>
         </p:spPr>
         <p:txBody>
-          <a:bodyPr xmlns:a="http://schemas.openxmlformats.org/drawingml/2006/main" lIns="0" tIns="0" rIns="0" bIns="0" anchor="ctr"/>
+          <a:bodyPr xmlns:a="http://schemas.openxmlformats.org/drawingml/2006/main" wrap="square" lIns="0" tIns="0" rIns="0" bIns="0" anchor="ctr">
+            <a:noAutofit/>
+          </a:bodyPr>
           <a:lstStyle xmlns:a="http://schemas.openxmlformats.org/drawingml/2006/main"/>
           <a:p xmlns:a="http://schemas.openxmlformats.org/drawingml/2006/main">
             <a:pPr>
-              <a:defRPr sz="2550" b="0">
-                <a:solidFill>
-                  <a:srgbClr val="152B3A"/>
-                </a:solidFill>
+              <a:buNone/>
+              <a:defRPr sz="2550" b="1">
+                <a:solidFill>
+                  <a:srgbClr val="28685E"/>
+                </a:solidFill>
+                <a:latin typeface="Arial"/>
+                <a:ea typeface="Arial"/>
+                <a:cs typeface="Arial"/>
               </a:defRPr>
             </a:pPr>
             <a:r>
-              <a:rPr sz="2550" b="0">
-                <a:solidFill>
-                  <a:srgbClr val="152B3A"/>
-                </a:solidFill>
+              <a:rPr sz="2550" b="1">
+                <a:solidFill>
+                  <a:srgbClr val="28685E"/>
+                </a:solidFill>
+                <a:latin typeface="Arial"/>
+                <a:ea typeface="Arial"/>
+                <a:cs typeface="Arial"/>
               </a:rPr>
               <a:t>Explain which animal group it supports.</a:t>
             </a:r>
@@ -7146,7 +8173,7 @@
     <p:bg>
       <p:bgPr>
         <a:solidFill xmlns:a="http://schemas.openxmlformats.org/drawingml/2006/main">
-          <a:srgbClr val="F5F1E8"/>
+          <a:srgbClr val="FBF9F3"/>
         </a:solidFill>
       </p:bgPr>
     </p:bg>
@@ -7175,8 +8202,8 @@
         </p:nvSpPr>
         <p:spPr>
           <a:xfrm xmlns:a="http://schemas.openxmlformats.org/drawingml/2006/main">
-            <a:off x="609600" y="552450"/>
-            <a:ext cx="781050" cy="57150"/>
+            <a:off x="609600" y="742950"/>
+            <a:ext cx="9906000" cy="38100"/>
           </a:xfrm>
           <a:prstGeom xmlns:a="http://schemas.openxmlformats.org/drawingml/2006/main" prst="rect">
             <a:avLst/>
@@ -7206,8 +8233,8 @@
         </p:nvSpPr>
         <p:spPr>
           <a:xfrm xmlns:a="http://schemas.openxmlformats.org/drawingml/2006/main">
-            <a:off x="609600" y="762000"/>
-            <a:ext cx="9334500" cy="285750"/>
+            <a:off x="609600" y="342900"/>
+            <a:ext cx="9334500" cy="266700"/>
           </a:xfrm>
           <a:prstGeom xmlns:a="http://schemas.openxmlformats.org/drawingml/2006/main" prst="rect">
             <a:avLst/>
@@ -7219,21 +8246,30 @@
           </a:ln>
         </p:spPr>
         <p:txBody>
-          <a:bodyPr xmlns:a="http://schemas.openxmlformats.org/drawingml/2006/main" lIns="0" tIns="0" rIns="0" bIns="0" anchor="ctr"/>
+          <a:bodyPr xmlns:a="http://schemas.openxmlformats.org/drawingml/2006/main" wrap="square" lIns="0" tIns="0" rIns="0" bIns="0" anchor="ctr">
+            <a:noAutofit/>
+          </a:bodyPr>
           <a:lstStyle xmlns:a="http://schemas.openxmlformats.org/drawingml/2006/main"/>
           <a:p xmlns:a="http://schemas.openxmlformats.org/drawingml/2006/main">
             <a:pPr>
-              <a:defRPr sz="1500" b="1">
+              <a:buNone/>
+              <a:defRPr sz="1425" b="1">
                 <a:solidFill>
                   <a:srgbClr val="28685E"/>
                 </a:solidFill>
+                <a:latin typeface="Arial"/>
+                <a:ea typeface="Arial"/>
+                <a:cs typeface="Arial"/>
               </a:defRPr>
             </a:pPr>
             <a:r>
-              <a:rPr sz="1500" b="1">
+              <a:rPr sz="1425" b="1">
                 <a:solidFill>
                   <a:srgbClr val="28685E"/>
                 </a:solidFill>
+                <a:latin typeface="Arial"/>
+                <a:ea typeface="Arial"/>
+                <a:cs typeface="Arial"/>
               </a:rPr>
               <a:t>MADE BY MATT  /  BUILD SCIENCE</a:t>
             </a:r>
@@ -7242,14 +8278,14 @@
       </p:sp>
       <p:pic>
         <p:nvPicPr>
-          <p:cNvPr id="13" name=""/>
+          <p:cNvPr id="15" name=""/>
           <p:cNvPicPr>
             <a:picLocks xmlns:a="http://schemas.openxmlformats.org/drawingml/2006/main" noChangeAspect="1"/>
           </p:cNvPicPr>
           <p:nvPr/>
         </p:nvPicPr>
         <p:blipFill>
-          <a:blip xmlns:r="http://schemas.openxmlformats.org/officeDocument/2006/relationships" xmlns:a="http://schemas.openxmlformats.org/drawingml/2006/main" r:embed="Rc4520aee67dc4f46"/>
+          <a:blip xmlns:r="http://schemas.openxmlformats.org/officeDocument/2006/relationships" xmlns:a="http://schemas.openxmlformats.org/drawingml/2006/main" r:embed="R327889860e904771"/>
           <a:stretch xmlns:a="http://schemas.openxmlformats.org/drawingml/2006/main"/>
         </p:blipFill>
         <p:spPr>
@@ -7278,8 +8314,8 @@
         </p:nvSpPr>
         <p:spPr>
           <a:xfrm xmlns:a="http://schemas.openxmlformats.org/drawingml/2006/main">
-            <a:off x="609600" y="1352550"/>
-            <a:ext cx="10972800" cy="952500"/>
+            <a:off x="609600" y="1047750"/>
+            <a:ext cx="10972800" cy="895350"/>
           </a:xfrm>
           <a:prstGeom xmlns:a="http://schemas.openxmlformats.org/drawingml/2006/main" prst="rect">
             <a:avLst/>
@@ -7291,21 +8327,30 @@
           </a:ln>
         </p:spPr>
         <p:txBody>
-          <a:bodyPr xmlns:a="http://schemas.openxmlformats.org/drawingml/2006/main" lIns="0" tIns="0" rIns="0" bIns="0" anchor="ctr"/>
+          <a:bodyPr xmlns:a="http://schemas.openxmlformats.org/drawingml/2006/main" wrap="square" lIns="0" tIns="0" rIns="0" bIns="0" anchor="ctr">
+            <a:noAutofit/>
+          </a:bodyPr>
           <a:lstStyle xmlns:a="http://schemas.openxmlformats.org/drawingml/2006/main"/>
           <a:p xmlns:a="http://schemas.openxmlformats.org/drawingml/2006/main">
             <a:pPr>
-              <a:defRPr sz="3750" b="1">
+              <a:buNone/>
+              <a:defRPr sz="3600" b="1">
                 <a:solidFill>
                   <a:srgbClr val="152B3A"/>
                 </a:solidFill>
+                <a:latin typeface="Arial"/>
+                <a:ea typeface="Arial"/>
+                <a:cs typeface="Arial"/>
               </a:defRPr>
             </a:pPr>
             <a:r>
-              <a:rPr sz="3750" b="1">
+              <a:rPr sz="3600" b="1">
                 <a:solidFill>
                   <a:srgbClr val="152B3A"/>
                 </a:solidFill>
+                <a:latin typeface="Arial"/>
+                <a:ea typeface="Arial"/>
+                <a:cs typeface="Arial"/>
               </a:rPr>
               <a:t>Leave the evidence ready</a:t>
             </a:r>
@@ -7372,21 +8417,30 @@
           </a:ln>
         </p:spPr>
         <p:txBody>
-          <a:bodyPr xmlns:a="http://schemas.openxmlformats.org/drawingml/2006/main" lIns="0" tIns="0" rIns="0" bIns="0" anchor="ctr"/>
+          <a:bodyPr xmlns:a="http://schemas.openxmlformats.org/drawingml/2006/main" wrap="square" lIns="0" tIns="0" rIns="0" bIns="0" anchor="ctr">
+            <a:noAutofit/>
+          </a:bodyPr>
           <a:lstStyle xmlns:a="http://schemas.openxmlformats.org/drawingml/2006/main"/>
           <a:p xmlns:a="http://schemas.openxmlformats.org/drawingml/2006/main">
             <a:pPr>
-              <a:defRPr sz="1275" b="0">
+              <a:buNone/>
+              <a:defRPr sz="1200" b="0">
                 <a:solidFill>
                   <a:srgbClr val="50616B"/>
                 </a:solidFill>
+                <a:latin typeface="Arial"/>
+                <a:ea typeface="Arial"/>
+                <a:cs typeface="Arial"/>
               </a:defRPr>
             </a:pPr>
             <a:r>
-              <a:rPr sz="1275" b="0">
+              <a:rPr sz="1200" b="0">
                 <a:solidFill>
                   <a:srgbClr val="50616B"/>
                 </a:solidFill>
+                <a:latin typeface="Arial"/>
+                <a:ea typeface="Arial"/>
+                <a:cs typeface="Arial"/>
               </a:rPr>
               <a:t>AUTUMN 1  ·  WEEK 3  ·  LESSON B</a:t>
             </a:r>
@@ -7422,14 +8476,20 @@
           </a:ln>
         </p:spPr>
         <p:txBody>
-          <a:bodyPr xmlns:a="http://schemas.openxmlformats.org/drawingml/2006/main" lIns="0" tIns="0" rIns="0" bIns="0" anchor="ctr"/>
+          <a:bodyPr xmlns:a="http://schemas.openxmlformats.org/drawingml/2006/main" wrap="square" lIns="0" tIns="0" rIns="0" bIns="0" anchor="ctr">
+            <a:noAutofit/>
+          </a:bodyPr>
           <a:lstStyle xmlns:a="http://schemas.openxmlformats.org/drawingml/2006/main"/>
           <a:p xmlns:a="http://schemas.openxmlformats.org/drawingml/2006/main">
             <a:pPr>
+              <a:buNone/>
               <a:defRPr sz="1350" b="1">
                 <a:solidFill>
                   <a:srgbClr val="28685E"/>
                 </a:solidFill>
+                <a:latin typeface="Arial"/>
+                <a:ea typeface="Arial"/>
+                <a:cs typeface="Arial"/>
               </a:defRPr>
             </a:pPr>
             <a:r>
@@ -7437,6 +8497,9 @@
                 <a:solidFill>
                   <a:srgbClr val="28685E"/>
                 </a:solidFill>
+                <a:latin typeface="Arial"/>
+                <a:ea typeface="Arial"/>
+                <a:cs typeface="Arial"/>
               </a:rPr>
               <a:t>09</a:t>
             </a:r>
@@ -7459,8 +8522,8 @@
         </p:nvSpPr>
         <p:spPr>
           <a:xfrm xmlns:a="http://schemas.openxmlformats.org/drawingml/2006/main">
-            <a:off x="609600" y="2619375"/>
-            <a:ext cx="10972800" cy="781050"/>
+            <a:off x="609600" y="2305050"/>
+            <a:ext cx="10972800" cy="914400"/>
           </a:xfrm>
           <a:prstGeom xmlns:a="http://schemas.openxmlformats.org/drawingml/2006/main" prst="rect">
             <a:avLst/>
@@ -7472,14 +8535,20 @@
           </a:ln>
         </p:spPr>
         <p:txBody>
-          <a:bodyPr xmlns:a="http://schemas.openxmlformats.org/drawingml/2006/main" lIns="0" tIns="0" rIns="0" bIns="0" anchor="ctr"/>
+          <a:bodyPr xmlns:a="http://schemas.openxmlformats.org/drawingml/2006/main" wrap="square" lIns="0" tIns="0" rIns="0" bIns="0" anchor="ctr">
+            <a:noAutofit/>
+          </a:bodyPr>
           <a:lstStyle xmlns:a="http://schemas.openxmlformats.org/drawingml/2006/main"/>
           <a:p xmlns:a="http://schemas.openxmlformats.org/drawingml/2006/main">
             <a:pPr>
+              <a:buNone/>
               <a:defRPr sz="2550" b="0">
                 <a:solidFill>
                   <a:srgbClr val="152B3A"/>
                 </a:solidFill>
+                <a:latin typeface="Arial"/>
+                <a:ea typeface="Arial"/>
+                <a:cs typeface="Arial"/>
               </a:defRPr>
             </a:pPr>
             <a:r>
@@ -7487,6 +8556,9 @@
                 <a:solidFill>
                   <a:srgbClr val="152B3A"/>
                 </a:solidFill>
+                <a:latin typeface="Arial"/>
+                <a:ea typeface="Arial"/>
+                <a:cs typeface="Arial"/>
               </a:rPr>
               <a:t>Keep the sort, clue and explanation together.</a:t>
             </a:r>
@@ -7509,8 +8581,8 @@
         </p:nvSpPr>
         <p:spPr>
           <a:xfrm xmlns:a="http://schemas.openxmlformats.org/drawingml/2006/main">
-            <a:off x="609600" y="3476625"/>
-            <a:ext cx="10972800" cy="781050"/>
+            <a:off x="609600" y="3352800"/>
+            <a:ext cx="10972800" cy="914400"/>
           </a:xfrm>
           <a:prstGeom xmlns:a="http://schemas.openxmlformats.org/drawingml/2006/main" prst="rect">
             <a:avLst/>
@@ -7522,14 +8594,20 @@
           </a:ln>
         </p:spPr>
         <p:txBody>
-          <a:bodyPr xmlns:a="http://schemas.openxmlformats.org/drawingml/2006/main" lIns="0" tIns="0" rIns="0" bIns="0" anchor="ctr"/>
+          <a:bodyPr xmlns:a="http://schemas.openxmlformats.org/drawingml/2006/main" wrap="square" lIns="0" tIns="0" rIns="0" bIns="0" anchor="ctr">
+            <a:noAutofit/>
+          </a:bodyPr>
           <a:lstStyle xmlns:a="http://schemas.openxmlformats.org/drawingml/2006/main"/>
           <a:p xmlns:a="http://schemas.openxmlformats.org/drawingml/2006/main">
             <a:pPr>
+              <a:buNone/>
               <a:defRPr sz="2550" b="0">
                 <a:solidFill>
                   <a:srgbClr val="152B3A"/>
                 </a:solidFill>
+                <a:latin typeface="Arial"/>
+                <a:ea typeface="Arial"/>
+                <a:cs typeface="Arial"/>
               </a:defRPr>
             </a:pPr>
             <a:r>
@@ -7537,6 +8615,9 @@
                 <a:solidFill>
                   <a:srgbClr val="152B3A"/>
                 </a:solidFill>
+                <a:latin typeface="Arial"/>
+                <a:ea typeface="Arial"/>
+                <a:cs typeface="Arial"/>
               </a:rPr>
               <a:t>Label your work.</a:t>
             </a:r>
@@ -7559,8 +8640,8 @@
         </p:nvSpPr>
         <p:spPr>
           <a:xfrm xmlns:a="http://schemas.openxmlformats.org/drawingml/2006/main">
-            <a:off x="609600" y="4333875"/>
-            <a:ext cx="10972800" cy="781050"/>
+            <a:off x="609600" y="4400550"/>
+            <a:ext cx="10972800" cy="914400"/>
           </a:xfrm>
           <a:prstGeom xmlns:a="http://schemas.openxmlformats.org/drawingml/2006/main" prst="rect">
             <a:avLst/>
@@ -7572,21 +8653,30 @@
           </a:ln>
         </p:spPr>
         <p:txBody>
-          <a:bodyPr xmlns:a="http://schemas.openxmlformats.org/drawingml/2006/main" lIns="0" tIns="0" rIns="0" bIns="0" anchor="ctr"/>
+          <a:bodyPr xmlns:a="http://schemas.openxmlformats.org/drawingml/2006/main" wrap="square" lIns="0" tIns="0" rIns="0" bIns="0" anchor="ctr">
+            <a:noAutofit/>
+          </a:bodyPr>
           <a:lstStyle xmlns:a="http://schemas.openxmlformats.org/drawingml/2006/main"/>
           <a:p xmlns:a="http://schemas.openxmlformats.org/drawingml/2006/main">
             <a:pPr>
-              <a:defRPr sz="2550" b="0">
-                <a:solidFill>
-                  <a:srgbClr val="152B3A"/>
-                </a:solidFill>
+              <a:buNone/>
+              <a:defRPr sz="2550" b="1">
+                <a:solidFill>
+                  <a:srgbClr val="28685E"/>
+                </a:solidFill>
+                <a:latin typeface="Arial"/>
+                <a:ea typeface="Arial"/>
+                <a:cs typeface="Arial"/>
               </a:defRPr>
             </a:pPr>
             <a:r>
-              <a:rPr sz="2550" b="0">
-                <a:solidFill>
-                  <a:srgbClr val="152B3A"/>
-                </a:solidFill>
+              <a:rPr sz="2550" b="1">
+                <a:solidFill>
+                  <a:srgbClr val="28685E"/>
+                </a:solidFill>
+                <a:latin typeface="Arial"/>
+                <a:ea typeface="Arial"/>
+                <a:cs typeface="Arial"/>
               </a:rPr>
               <a:t>Return labels and clear the table.</a:t>
             </a:r>

</xml_diff>